<commit_message>
docs(slides): tighten prompt deck layout
</commit_message>
<xml_diff>
--- a/docs/source/TP Prompt Ingénierie.pptx
+++ b/docs/source/TP Prompt Ingénierie.pptx
@@ -3170,7 +3170,7 @@
                 </a:solidFill>
                 <a:latin typeface="Aptos"/>
               </a:rPr>
-              <a:t>Il cadre un coding harness : modèle, agent loop et runtime supports.</a:t>
+              <a:t>Le prompt ne cadre pas seulement le modèle. Il cadre le système d'exécution : modèle, boucle agentique et runtime.</a:t>
             </a:r>
           </a:p>
         </p:txBody>
@@ -3226,8 +3226,8 @@
         </p:nvSpPr>
         <p:spPr>
           <a:xfrm>
-            <a:off x="4279392" y="1847088"/>
-            <a:ext cx="3657600" cy="402336"/>
+            <a:off x="3822191" y="1828800"/>
+            <a:ext cx="4617720" cy="475488"/>
           </a:xfrm>
           <a:prstGeom prst="rect">
             <a:avLst/>
@@ -3242,13 +3242,13 @@
           <a:p>
             <a:pPr algn="ctr"/>
             <a:r>
-              <a:rPr sz="2300" b="1">
+              <a:rPr sz="2000" b="1">
                 <a:solidFill>
                   <a:srgbClr val="17222D"/>
                 </a:solidFill>
                 <a:latin typeface="Aptos"/>
               </a:rPr>
-              <a:t>Coding harness</a:t>
+              <a:t>Système cadré par le prompt</a:t>
             </a:r>
           </a:p>
         </p:txBody>
@@ -3418,7 +3418,7 @@
                 </a:solidFill>
                 <a:latin typeface="Aptos"/>
               </a:rPr>
-              <a:t>Model family</a:t>
+              <a:t>Couche modèle</a:t>
             </a:r>
           </a:p>
         </p:txBody>
@@ -3476,8 +3476,8 @@
         </p:nvSpPr>
         <p:spPr>
           <a:xfrm>
-            <a:off x="1170432" y="3456432"/>
-            <a:ext cx="1517904" cy="219456"/>
+            <a:off x="1115568" y="3456432"/>
+            <a:ext cx="1627632" cy="219456"/>
           </a:xfrm>
           <a:prstGeom prst="rect">
             <a:avLst/>
@@ -3492,13 +3492,13 @@
           <a:p>
             <a:pPr algn="ctr"/>
             <a:r>
-              <a:rPr sz="2100" b="0">
+              <a:rPr sz="2000" b="0">
                 <a:solidFill>
                   <a:srgbClr val="17222D"/>
                 </a:solidFill>
                 <a:latin typeface="Aptos"/>
               </a:rPr>
-              <a:t>Base LLM</a:t>
+              <a:t>LLM de base</a:t>
             </a:r>
           </a:p>
         </p:txBody>
@@ -3599,8 +3599,8 @@
         </p:nvSpPr>
         <p:spPr>
           <a:xfrm>
-            <a:off x="1170432" y="4681728"/>
-            <a:ext cx="1517904" cy="384048"/>
+            <a:off x="1115568" y="4681728"/>
+            <a:ext cx="1627632" cy="384048"/>
           </a:xfrm>
           <a:prstGeom prst="rect">
             <a:avLst/>
@@ -3621,8 +3621,8 @@
                 </a:solidFill>
                 <a:latin typeface="Aptos"/>
               </a:rPr>
-              <a:t>Reasoning
-model</a:t>
+              <a:t>LLM
+reasoning</a:t>
             </a:r>
           </a:p>
         </p:txBody>
@@ -3657,7 +3657,7 @@
                 </a:solidFill>
                 <a:latin typeface="Aptos"/>
               </a:rPr>
-              <a:t>Agent loop</a:t>
+              <a:t>Boucle agentique</a:t>
             </a:r>
           </a:p>
         </p:txBody>
@@ -3737,7 +3737,7 @@
                 </a:solidFill>
                 <a:latin typeface="Aptos"/>
               </a:rPr>
-              <a:t>Inspect</a:t>
+              <a:t>Inspecte</a:t>
             </a:r>
           </a:p>
         </p:txBody>
@@ -3817,7 +3817,7 @@
                 </a:solidFill>
                 <a:latin typeface="Aptos"/>
               </a:rPr>
-              <a:t>Choose</a:t>
+              <a:t>Choisit</a:t>
             </a:r>
           </a:p>
         </p:txBody>
@@ -3977,7 +3977,7 @@
                 </a:solidFill>
                 <a:latin typeface="Aptos"/>
               </a:rPr>
-              <a:t>Act</a:t>
+              <a:t>Agit</a:t>
             </a:r>
           </a:p>
         </p:txBody>
@@ -4162,8 +4162,8 @@
         </p:nvSpPr>
         <p:spPr>
           <a:xfrm>
-            <a:off x="8961120" y="2542032"/>
-            <a:ext cx="2176272" cy="292608"/>
+            <a:off x="8686800" y="2542032"/>
+            <a:ext cx="2724912" cy="292608"/>
           </a:xfrm>
           <a:prstGeom prst="rect">
             <a:avLst/>
@@ -4178,13 +4178,13 @@
           <a:p>
             <a:pPr algn="ctr"/>
             <a:r>
-              <a:rPr sz="2100" b="0">
+              <a:rPr sz="2000" b="0">
                 <a:solidFill>
                   <a:srgbClr val="17222D"/>
                 </a:solidFill>
                 <a:latin typeface="Aptos"/>
               </a:rPr>
-              <a:t>Runtime supports</a:t>
+              <a:t>Cadre d'exécution</a:t>
             </a:r>
           </a:p>
         </p:txBody>
@@ -4197,8 +4197,8 @@
         </p:nvSpPr>
         <p:spPr>
           <a:xfrm>
-            <a:off x="8851392" y="3474720"/>
-            <a:ext cx="1133856" cy="493776"/>
+            <a:off x="8778240" y="3456432"/>
+            <a:ext cx="1261872" cy="530352"/>
           </a:xfrm>
           <a:prstGeom prst="roundRect">
             <a:avLst/>
@@ -4242,8 +4242,8 @@
         </p:nvSpPr>
         <p:spPr>
           <a:xfrm>
-            <a:off x="8851392" y="3602736"/>
-            <a:ext cx="1133856" cy="182880"/>
+            <a:off x="8778240" y="3538728"/>
+            <a:ext cx="1261872" cy="310896"/>
           </a:xfrm>
           <a:prstGeom prst="rect">
             <a:avLst/>
@@ -4258,13 +4258,14 @@
           <a:p>
             <a:pPr algn="ctr"/>
             <a:r>
-              <a:rPr sz="1500" b="0">
+              <a:rPr sz="1400" b="0">
                 <a:solidFill>
                   <a:srgbClr val="17222D"/>
                 </a:solidFill>
                 <a:latin typeface="Aptos"/>
               </a:rPr>
-              <a:t>Repo context</a:t>
+              <a:t>Contexte
+repo</a:t>
             </a:r>
           </a:p>
         </p:txBody>
@@ -4277,8 +4278,8 @@
         </p:nvSpPr>
         <p:spPr>
           <a:xfrm>
-            <a:off x="10213848" y="3474720"/>
-            <a:ext cx="1133856" cy="493776"/>
+            <a:off x="10113264" y="3456432"/>
+            <a:ext cx="1261872" cy="530352"/>
           </a:xfrm>
           <a:prstGeom prst="roundRect">
             <a:avLst/>
@@ -4322,8 +4323,8 @@
         </p:nvSpPr>
         <p:spPr>
           <a:xfrm>
-            <a:off x="10213848" y="3602736"/>
-            <a:ext cx="1133856" cy="182880"/>
+            <a:off x="10113264" y="3538728"/>
+            <a:ext cx="1261872" cy="310896"/>
           </a:xfrm>
           <a:prstGeom prst="rect">
             <a:avLst/>
@@ -4338,13 +4339,13 @@
           <a:p>
             <a:pPr algn="ctr"/>
             <a:r>
-              <a:rPr sz="1500" b="0">
+              <a:rPr sz="1400" b="0">
                 <a:solidFill>
                   <a:srgbClr val="17222D"/>
                 </a:solidFill>
                 <a:latin typeface="Aptos"/>
               </a:rPr>
-              <a:t>Tools</a:t>
+              <a:t>Outils</a:t>
             </a:r>
           </a:p>
         </p:txBody>
@@ -4357,8 +4358,8 @@
         </p:nvSpPr>
         <p:spPr>
           <a:xfrm>
-            <a:off x="8851392" y="4261104"/>
-            <a:ext cx="1133856" cy="493776"/>
+            <a:off x="8778240" y="4224528"/>
+            <a:ext cx="1261872" cy="530352"/>
           </a:xfrm>
           <a:prstGeom prst="roundRect">
             <a:avLst/>
@@ -4402,8 +4403,8 @@
         </p:nvSpPr>
         <p:spPr>
           <a:xfrm>
-            <a:off x="8851392" y="4389120"/>
-            <a:ext cx="1133856" cy="182880"/>
+            <a:off x="8778240" y="4306824"/>
+            <a:ext cx="1261872" cy="310896"/>
           </a:xfrm>
           <a:prstGeom prst="rect">
             <a:avLst/>
@@ -4418,7 +4419,7 @@
           <a:p>
             <a:pPr algn="ctr"/>
             <a:r>
-              <a:rPr sz="1500" b="0">
+              <a:rPr sz="1400" b="0">
                 <a:solidFill>
                   <a:srgbClr val="17222D"/>
                 </a:solidFill>
@@ -4437,8 +4438,8 @@
         </p:nvSpPr>
         <p:spPr>
           <a:xfrm>
-            <a:off x="10213848" y="4261104"/>
-            <a:ext cx="1133856" cy="493776"/>
+            <a:off x="10113264" y="4224528"/>
+            <a:ext cx="1261872" cy="530352"/>
           </a:xfrm>
           <a:prstGeom prst="roundRect">
             <a:avLst/>
@@ -4482,8 +4483,8 @@
         </p:nvSpPr>
         <p:spPr>
           <a:xfrm>
-            <a:off x="10213848" y="4389120"/>
-            <a:ext cx="1133856" cy="182880"/>
+            <a:off x="10113264" y="4306824"/>
+            <a:ext cx="1261872" cy="310896"/>
           </a:xfrm>
           <a:prstGeom prst="rect">
             <a:avLst/>
@@ -4498,13 +4499,13 @@
           <a:p>
             <a:pPr algn="ctr"/>
             <a:r>
-              <a:rPr sz="1500" b="0">
+              <a:rPr sz="1400" b="0">
                 <a:solidFill>
                   <a:srgbClr val="17222D"/>
                 </a:solidFill>
                 <a:latin typeface="Aptos"/>
               </a:rPr>
-              <a:t>Memory</a:t>
+              <a:t>Mémoire</a:t>
             </a:r>
           </a:p>
         </p:txBody>
@@ -4517,8 +4518,8 @@
         </p:nvSpPr>
         <p:spPr>
           <a:xfrm>
-            <a:off x="8851392" y="5047488"/>
-            <a:ext cx="1133856" cy="493776"/>
+            <a:off x="8778240" y="4992624"/>
+            <a:ext cx="1261872" cy="530352"/>
           </a:xfrm>
           <a:prstGeom prst="roundRect">
             <a:avLst/>
@@ -4562,8 +4563,8 @@
         </p:nvSpPr>
         <p:spPr>
           <a:xfrm>
-            <a:off x="8851392" y="5175504"/>
-            <a:ext cx="1133856" cy="182880"/>
+            <a:off x="8778240" y="5074920"/>
+            <a:ext cx="1261872" cy="310896"/>
           </a:xfrm>
           <a:prstGeom prst="rect">
             <a:avLst/>
@@ -4578,7 +4579,7 @@
           <a:p>
             <a:pPr algn="ctr"/>
             <a:r>
-              <a:rPr sz="1500" b="0">
+              <a:rPr sz="1400" b="0">
                 <a:solidFill>
                   <a:srgbClr val="17222D"/>
                 </a:solidFill>
@@ -4597,8 +4598,8 @@
         </p:nvSpPr>
         <p:spPr>
           <a:xfrm>
-            <a:off x="10213848" y="5047488"/>
-            <a:ext cx="1133856" cy="493776"/>
+            <a:off x="10113264" y="4992624"/>
+            <a:ext cx="1261872" cy="530352"/>
           </a:xfrm>
           <a:prstGeom prst="roundRect">
             <a:avLst/>
@@ -4642,8 +4643,8 @@
         </p:nvSpPr>
         <p:spPr>
           <a:xfrm>
-            <a:off x="10213848" y="5175504"/>
-            <a:ext cx="1133856" cy="182880"/>
+            <a:off x="10113264" y="5074920"/>
+            <a:ext cx="1261872" cy="310896"/>
           </a:xfrm>
           <a:prstGeom prst="rect">
             <a:avLst/>
@@ -4658,13 +4659,13 @@
           <a:p>
             <a:pPr algn="ctr"/>
             <a:r>
-              <a:rPr sz="1500" b="0">
+              <a:rPr sz="1400" b="0">
                 <a:solidFill>
                   <a:srgbClr val="17222D"/>
                 </a:solidFill>
                 <a:latin typeface="Aptos"/>
               </a:rPr>
-              <a:t>Execution</a:t>
+              <a:t>Exécution</a:t>
             </a:r>
           </a:p>
         </p:txBody>
@@ -4763,8 +4764,8 @@
         </p:nvSpPr>
         <p:spPr>
           <a:xfrm>
-            <a:off x="914400" y="5669280"/>
-            <a:ext cx="10332720" cy="219456"/>
+            <a:off x="914400" y="5577840"/>
+            <a:ext cx="10332720" cy="384048"/>
           </a:xfrm>
           <a:prstGeom prst="rect">
             <a:avLst/>
@@ -4779,13 +4780,13 @@
           <a:p>
             <a:pPr algn="ctr"/>
             <a:r>
-              <a:rPr sz="1700" b="1">
+              <a:rPr sz="1600" b="1">
                 <a:solidFill>
                   <a:srgbClr val="BF5A24"/>
                 </a:solidFill>
                 <a:latin typeface="Aptos"/>
               </a:rPr>
-              <a:t>Le Prompt Engineering sert ici à cadrer la boucle, les outils, les règles et le bon niveau de contexte.</a:t>
+              <a:t>Le Prompt Engineering sert à cadrer la boucle, les outils, les règles d'exécution et le bon niveau de contexte.</a:t>
             </a:r>
           </a:p>
         </p:txBody>
@@ -6616,8 +6617,8 @@
         </p:nvSpPr>
         <p:spPr>
           <a:xfrm>
-            <a:off x="713232" y="2907792"/>
-            <a:ext cx="3063240" cy="1389888"/>
+            <a:off x="713232" y="2816352"/>
+            <a:ext cx="3063240" cy="1554480"/>
           </a:xfrm>
           <a:prstGeom prst="roundRect">
             <a:avLst/>
@@ -6661,8 +6662,8 @@
         </p:nvSpPr>
         <p:spPr>
           <a:xfrm>
-            <a:off x="3703320" y="2359152"/>
-            <a:ext cx="3246120" cy="1938528"/>
+            <a:off x="3703320" y="2249424"/>
+            <a:ext cx="3291840" cy="2121408"/>
           </a:xfrm>
           <a:prstGeom prst="roundRect">
             <a:avLst/>
@@ -6706,8 +6707,8 @@
         </p:nvSpPr>
         <p:spPr>
           <a:xfrm>
-            <a:off x="6931152" y="1810512"/>
-            <a:ext cx="3675887" cy="2487168"/>
+            <a:off x="6839712" y="1627632"/>
+            <a:ext cx="3767328" cy="2743200"/>
           </a:xfrm>
           <a:prstGeom prst="roundRect">
             <a:avLst/>
@@ -6751,8 +6752,8 @@
         </p:nvSpPr>
         <p:spPr>
           <a:xfrm>
-            <a:off x="868680" y="2139696"/>
-            <a:ext cx="2697480" cy="1993392"/>
+            <a:off x="868680" y="2066543"/>
+            <a:ext cx="2697480" cy="2304288"/>
           </a:xfrm>
           <a:prstGeom prst="roundRect">
             <a:avLst/>
@@ -6796,7 +6797,7 @@
         </p:nvSpPr>
         <p:spPr>
           <a:xfrm>
-            <a:off x="1088136" y="2304288"/>
+            <a:off x="1088136" y="2231135"/>
             <a:ext cx="1078992" cy="310896"/>
           </a:xfrm>
           <a:prstGeom prst="roundRect">
@@ -6841,7 +6842,7 @@
         </p:nvSpPr>
         <p:spPr>
           <a:xfrm>
-            <a:off x="1088136" y="2331720"/>
+            <a:off x="1088136" y="2258567"/>
             <a:ext cx="1078992" cy="310896"/>
           </a:xfrm>
           <a:prstGeom prst="rect">
@@ -6876,8 +6877,8 @@
         </p:nvSpPr>
         <p:spPr>
           <a:xfrm>
-            <a:off x="1088136" y="2706624"/>
-            <a:ext cx="2258568" cy="310896"/>
+            <a:off x="1088136" y="2596895"/>
+            <a:ext cx="2258568" cy="512064"/>
           </a:xfrm>
           <a:prstGeom prst="rect">
             <a:avLst/>
@@ -6892,7 +6893,7 @@
           <a:p>
             <a:pPr algn="ctr"/>
             <a:r>
-              <a:rPr sz="2400" b="1">
+              <a:rPr sz="2200" b="1">
                 <a:solidFill>
                   <a:srgbClr val="215472"/>
                 </a:solidFill>
@@ -6911,7 +6912,7 @@
         </p:nvSpPr>
         <p:spPr>
           <a:xfrm>
-            <a:off x="1088136" y="3072384"/>
+            <a:off x="1088136" y="3108958"/>
             <a:ext cx="2258568" cy="219456"/>
           </a:xfrm>
           <a:prstGeom prst="rect">
@@ -6927,7 +6928,7 @@
           <a:p>
             <a:pPr algn="ctr"/>
             <a:r>
-              <a:rPr sz="1600" b="1">
+              <a:rPr sz="1500" b="1">
                 <a:solidFill>
                   <a:srgbClr val="BF5A24"/>
                 </a:solidFill>
@@ -6946,8 +6947,8 @@
         </p:nvSpPr>
         <p:spPr>
           <a:xfrm>
-            <a:off x="1124712" y="3438144"/>
-            <a:ext cx="2185416" cy="658368"/>
+            <a:off x="1124712" y="3383279"/>
+            <a:ext cx="2185416" cy="365760"/>
           </a:xfrm>
           <a:prstGeom prst="rect">
             <a:avLst/>
@@ -6962,14 +6963,14 @@
           <a:p>
             <a:pPr algn="ctr"/>
             <a:r>
-              <a:rPr sz="1700" b="0">
+              <a:rPr sz="1400" b="0">
                 <a:solidFill>
                   <a:srgbClr val="5E656B"/>
                 </a:solidFill>
                 <a:latin typeface="Aptos"/>
               </a:rPr>
               <a:t>• copier-coller
-• tests à la main</a:t>
+• tests manuels</a:t>
             </a:r>
           </a:p>
         </p:txBody>
@@ -6982,8 +6983,8 @@
         </p:nvSpPr>
         <p:spPr>
           <a:xfrm>
-            <a:off x="1440180" y="3639312"/>
-            <a:ext cx="1554480" cy="347472"/>
+            <a:off x="1495044" y="4023359"/>
+            <a:ext cx="1444752" cy="292608"/>
           </a:xfrm>
           <a:prstGeom prst="roundRect">
             <a:avLst/>
@@ -7027,8 +7028,8 @@
         </p:nvSpPr>
         <p:spPr>
           <a:xfrm>
-            <a:off x="1440180" y="3666744"/>
-            <a:ext cx="1554480" cy="347472"/>
+            <a:off x="1495044" y="4050791"/>
+            <a:ext cx="1444752" cy="292608"/>
           </a:xfrm>
           <a:prstGeom prst="rect">
             <a:avLst/>
@@ -7043,7 +7044,7 @@
           <a:p>
             <a:pPr algn="ctr"/>
             <a:r>
-              <a:rPr sz="1100" b="1">
+              <a:rPr sz="1000" b="1">
                 <a:solidFill>
                   <a:srgbClr val="BF5A24"/>
                 </a:solidFill>
@@ -7062,8 +7063,8 @@
         </p:nvSpPr>
         <p:spPr>
           <a:xfrm>
-            <a:off x="3913632" y="1792224"/>
-            <a:ext cx="2834640" cy="2340864"/>
+            <a:off x="3877056" y="1700784"/>
+            <a:ext cx="2889504" cy="2578608"/>
           </a:xfrm>
           <a:prstGeom prst="roundRect">
             <a:avLst/>
@@ -7107,7 +7108,7 @@
         </p:nvSpPr>
         <p:spPr>
           <a:xfrm>
-            <a:off x="4133088" y="1956816"/>
+            <a:off x="4096512" y="1865376"/>
             <a:ext cx="1078992" cy="310896"/>
           </a:xfrm>
           <a:prstGeom prst="roundRect">
@@ -7152,7 +7153,7 @@
         </p:nvSpPr>
         <p:spPr>
           <a:xfrm>
-            <a:off x="4133088" y="1984248"/>
+            <a:off x="4096512" y="1892808"/>
             <a:ext cx="1078992" cy="310896"/>
           </a:xfrm>
           <a:prstGeom prst="rect">
@@ -7187,8 +7188,8 @@
         </p:nvSpPr>
         <p:spPr>
           <a:xfrm>
-            <a:off x="4133088" y="2359152"/>
-            <a:ext cx="2395728" cy="310896"/>
+            <a:off x="4096512" y="2231136"/>
+            <a:ext cx="2450592" cy="512064"/>
           </a:xfrm>
           <a:prstGeom prst="rect">
             <a:avLst/>
@@ -7203,7 +7204,7 @@
           <a:p>
             <a:pPr algn="ctr"/>
             <a:r>
-              <a:rPr sz="2400" b="1">
+              <a:rPr sz="2200" b="1">
                 <a:solidFill>
                   <a:srgbClr val="215472"/>
                 </a:solidFill>
@@ -7222,8 +7223,8 @@
         </p:nvSpPr>
         <p:spPr>
           <a:xfrm>
-            <a:off x="4133088" y="2724912"/>
-            <a:ext cx="2395728" cy="219456"/>
+            <a:off x="4096512" y="2743199"/>
+            <a:ext cx="2450592" cy="219456"/>
           </a:xfrm>
           <a:prstGeom prst="rect">
             <a:avLst/>
@@ -7238,7 +7239,7 @@
           <a:p>
             <a:pPr algn="ctr"/>
             <a:r>
-              <a:rPr sz="1600" b="1">
+              <a:rPr sz="1500" b="1">
                 <a:solidFill>
                   <a:srgbClr val="BF5A24"/>
                 </a:solidFill>
@@ -7257,8 +7258,8 @@
         </p:nvSpPr>
         <p:spPr>
           <a:xfrm>
-            <a:off x="4169664" y="3090672"/>
-            <a:ext cx="2322576" cy="658368"/>
+            <a:off x="4133088" y="3054096"/>
+            <a:ext cx="2377440" cy="402336"/>
           </a:xfrm>
           <a:prstGeom prst="rect">
             <a:avLst/>
@@ -7273,7 +7274,7 @@
           <a:p>
             <a:pPr algn="ctr"/>
             <a:r>
-              <a:rPr sz="1700" b="0">
+              <a:rPr sz="1400" b="0">
                 <a:solidFill>
                   <a:srgbClr val="5E656B"/>
                 </a:solidFill>
@@ -7293,8 +7294,8 @@
         </p:nvSpPr>
         <p:spPr>
           <a:xfrm>
-            <a:off x="4553712" y="3639312"/>
-            <a:ext cx="1554480" cy="347472"/>
+            <a:off x="4599432" y="3913632"/>
+            <a:ext cx="1444752" cy="292608"/>
           </a:xfrm>
           <a:prstGeom prst="roundRect">
             <a:avLst/>
@@ -7338,8 +7339,8 @@
         </p:nvSpPr>
         <p:spPr>
           <a:xfrm>
-            <a:off x="4553712" y="3666744"/>
-            <a:ext cx="1554480" cy="347472"/>
+            <a:off x="4599432" y="3941064"/>
+            <a:ext cx="1444752" cy="292608"/>
           </a:xfrm>
           <a:prstGeom prst="rect">
             <a:avLst/>
@@ -7354,7 +7355,7 @@
           <a:p>
             <a:pPr algn="ctr"/>
             <a:r>
-              <a:rPr sz="1100" b="1">
+              <a:rPr sz="1000" b="1">
                 <a:solidFill>
                   <a:srgbClr val="BF5A24"/>
                 </a:solidFill>
@@ -7373,8 +7374,8 @@
         </p:nvSpPr>
         <p:spPr>
           <a:xfrm>
-            <a:off x="7269480" y="1389888"/>
-            <a:ext cx="3246120" cy="2743200"/>
+            <a:off x="7150608" y="1298448"/>
+            <a:ext cx="3401568" cy="2944368"/>
           </a:xfrm>
           <a:prstGeom prst="roundRect">
             <a:avLst/>
@@ -7418,7 +7419,7 @@
         </p:nvSpPr>
         <p:spPr>
           <a:xfrm>
-            <a:off x="7488936" y="1554480"/>
+            <a:off x="7370064" y="1463040"/>
             <a:ext cx="1078992" cy="310896"/>
           </a:xfrm>
           <a:prstGeom prst="roundRect">
@@ -7463,7 +7464,7 @@
         </p:nvSpPr>
         <p:spPr>
           <a:xfrm>
-            <a:off x="7488936" y="1581912"/>
+            <a:off x="7370064" y="1490472"/>
             <a:ext cx="1078992" cy="310896"/>
           </a:xfrm>
           <a:prstGeom prst="rect">
@@ -7498,8 +7499,8 @@
         </p:nvSpPr>
         <p:spPr>
           <a:xfrm>
-            <a:off x="7488936" y="1956816"/>
-            <a:ext cx="2807208" cy="310896"/>
+            <a:off x="7370064" y="1828800"/>
+            <a:ext cx="2962656" cy="512064"/>
           </a:xfrm>
           <a:prstGeom prst="rect">
             <a:avLst/>
@@ -7514,13 +7515,14 @@
           <a:p>
             <a:pPr algn="ctr"/>
             <a:r>
-              <a:rPr sz="2400" b="1">
+              <a:rPr sz="2000" b="1">
                 <a:solidFill>
                   <a:srgbClr val="215472"/>
                 </a:solidFill>
                 <a:latin typeface="Aptos"/>
               </a:rPr>
-              <a:t>Agent multi-skill</a:t>
+              <a:t>Agent
+multi-skill</a:t>
             </a:r>
           </a:p>
         </p:txBody>
@@ -7533,8 +7535,8 @@
         </p:nvSpPr>
         <p:spPr>
           <a:xfrm>
-            <a:off x="7488936" y="2322576"/>
-            <a:ext cx="2807208" cy="219456"/>
+            <a:off x="7370064" y="2340863"/>
+            <a:ext cx="2962656" cy="219456"/>
           </a:xfrm>
           <a:prstGeom prst="rect">
             <a:avLst/>
@@ -7549,7 +7551,7 @@
           <a:p>
             <a:pPr algn="ctr"/>
             <a:r>
-              <a:rPr sz="1600" b="1">
+              <a:rPr sz="1500" b="1">
                 <a:solidFill>
                   <a:srgbClr val="BF5A24"/>
                 </a:solidFill>
@@ -7568,8 +7570,8 @@
         </p:nvSpPr>
         <p:spPr>
           <a:xfrm>
-            <a:off x="7525512" y="2688336"/>
-            <a:ext cx="2734056" cy="658368"/>
+            <a:off x="7406640" y="2670048"/>
+            <a:ext cx="2889504" cy="402336"/>
           </a:xfrm>
           <a:prstGeom prst="rect">
             <a:avLst/>
@@ -7584,7 +7586,7 @@
           <a:p>
             <a:pPr algn="ctr"/>
             <a:r>
-              <a:rPr sz="1700" b="0">
+              <a:rPr sz="1400" b="0">
                 <a:solidFill>
                   <a:srgbClr val="5E656B"/>
                 </a:solidFill>
@@ -7604,8 +7606,8 @@
         </p:nvSpPr>
         <p:spPr>
           <a:xfrm>
-            <a:off x="8115300" y="3639312"/>
-            <a:ext cx="1554480" cy="347472"/>
+            <a:off x="8129016" y="3877056"/>
+            <a:ext cx="1444752" cy="292608"/>
           </a:xfrm>
           <a:prstGeom prst="roundRect">
             <a:avLst/>
@@ -7649,8 +7651,8 @@
         </p:nvSpPr>
         <p:spPr>
           <a:xfrm>
-            <a:off x="8115300" y="3666744"/>
-            <a:ext cx="1554480" cy="347472"/>
+            <a:off x="8129016" y="3904488"/>
+            <a:ext cx="1444752" cy="292608"/>
           </a:xfrm>
           <a:prstGeom prst="rect">
             <a:avLst/>
@@ -7665,7 +7667,7 @@
           <a:p>
             <a:pPr algn="ctr"/>
             <a:r>
-              <a:rPr sz="1100" b="1">
+              <a:rPr sz="1000" b="1">
                 <a:solidFill>
                   <a:srgbClr val="BF5A24"/>
                 </a:solidFill>
@@ -7727,8 +7729,8 @@
         </p:nvSpPr>
         <p:spPr>
           <a:xfrm>
-            <a:off x="1417320" y="5102352"/>
-            <a:ext cx="8961120" cy="347472"/>
+            <a:off x="1417320" y="5065776"/>
+            <a:ext cx="8961120" cy="438912"/>
           </a:xfrm>
           <a:prstGeom prst="rect">
             <a:avLst/>
@@ -7743,7 +7745,7 @@
           <a:p>
             <a:pPr algn="ctr"/>
             <a:r>
-              <a:rPr sz="2100" b="1">
+              <a:rPr sz="2000" b="1">
                 <a:solidFill>
                   <a:srgbClr val="BF5A24"/>
                 </a:solidFill>
@@ -8335,8 +8337,8 @@
         </p:nvSpPr>
         <p:spPr>
           <a:xfrm>
-            <a:off x="914400" y="4709160"/>
-            <a:ext cx="10058400" cy="658368"/>
+            <a:off x="914400" y="4617720"/>
+            <a:ext cx="10058400" cy="822960"/>
           </a:xfrm>
           <a:prstGeom prst="roundRect">
             <a:avLst/>
@@ -8380,8 +8382,8 @@
         </p:nvSpPr>
         <p:spPr>
           <a:xfrm>
-            <a:off x="1143000" y="4919472"/>
-            <a:ext cx="9601200" cy="219456"/>
+            <a:off x="1143000" y="4791456"/>
+            <a:ext cx="9601200" cy="420624"/>
           </a:xfrm>
           <a:prstGeom prst="rect">
             <a:avLst/>
@@ -8415,8 +8417,8 @@
         </p:nvSpPr>
         <p:spPr>
           <a:xfrm>
-            <a:off x="914400" y="5504688"/>
-            <a:ext cx="10058400" cy="713232"/>
+            <a:off x="914400" y="5559552"/>
+            <a:ext cx="10058400" cy="640080"/>
           </a:xfrm>
           <a:prstGeom prst="roundRect">
             <a:avLst/>
@@ -8460,8 +8462,8 @@
         </p:nvSpPr>
         <p:spPr>
           <a:xfrm>
-            <a:off x="1188720" y="5650992"/>
-            <a:ext cx="9509760" cy="274320"/>
+            <a:off x="1188720" y="5705856"/>
+            <a:ext cx="9509760" cy="237744"/>
           </a:xfrm>
           <a:prstGeom prst="rect">
             <a:avLst/>
@@ -8476,7 +8478,7 @@
           <a:p>
             <a:pPr algn="ctr"/>
             <a:r>
-              <a:rPr sz="1600" b="1">
+              <a:rPr sz="1500" b="1">
                 <a:solidFill>
                   <a:srgbClr val="215472"/>
                 </a:solidFill>
@@ -8634,8 +8636,8 @@
         </p:nvSpPr>
         <p:spPr>
           <a:xfrm>
-            <a:off x="841248" y="2331720"/>
-            <a:ext cx="2057400" cy="1188720"/>
+            <a:off x="804672" y="2331720"/>
+            <a:ext cx="2212848" cy="1225296"/>
           </a:xfrm>
           <a:prstGeom prst="roundRect">
             <a:avLst/>
@@ -8679,7 +8681,7 @@
         </p:nvSpPr>
         <p:spPr>
           <a:xfrm>
-            <a:off x="1591056" y="1993392"/>
+            <a:off x="1682496" y="1956816"/>
             <a:ext cx="566928" cy="329184"/>
           </a:xfrm>
           <a:prstGeom prst="roundRect">
@@ -8724,7 +8726,7 @@
         </p:nvSpPr>
         <p:spPr>
           <a:xfrm>
-            <a:off x="1591056" y="2020824"/>
+            <a:off x="1682496" y="1984248"/>
             <a:ext cx="566928" cy="329184"/>
           </a:xfrm>
           <a:prstGeom prst="rect">
@@ -8759,8 +8761,8 @@
         </p:nvSpPr>
         <p:spPr>
           <a:xfrm>
-            <a:off x="950976" y="2743200"/>
-            <a:ext cx="1828800" cy="219456"/>
+            <a:off x="950976" y="2770632"/>
+            <a:ext cx="2029968" cy="310896"/>
           </a:xfrm>
           <a:prstGeom prst="rect">
             <a:avLst/>
@@ -8775,13 +8777,13 @@
           <a:p>
             <a:pPr algn="ctr"/>
             <a:r>
-              <a:rPr sz="1800" b="1">
+              <a:rPr sz="1700" b="1">
                 <a:solidFill>
                   <a:srgbClr val="1A1F24"/>
                 </a:solidFill>
                 <a:latin typeface="Aptos"/>
               </a:rPr>
-              <a:t>métadonnées</a:t>
+              <a:t>métadonnées repo</a:t>
             </a:r>
           </a:p>
         </p:txBody>
@@ -8794,8 +8796,8 @@
         </p:nvSpPr>
         <p:spPr>
           <a:xfrm>
-            <a:off x="2743200" y="2743200"/>
-            <a:ext cx="347472" cy="256032"/>
+            <a:off x="3172968" y="2816352"/>
+            <a:ext cx="310896" cy="219456"/>
           </a:xfrm>
           <a:prstGeom prst="chevron">
             <a:avLst/>
@@ -8837,8 +8839,8 @@
         </p:nvSpPr>
         <p:spPr>
           <a:xfrm>
-            <a:off x="3493008" y="2331720"/>
-            <a:ext cx="2057400" cy="1188720"/>
+            <a:off x="3547872" y="2331720"/>
+            <a:ext cx="2212848" cy="1225296"/>
           </a:xfrm>
           <a:prstGeom prst="roundRect">
             <a:avLst/>
@@ -8882,7 +8884,7 @@
         </p:nvSpPr>
         <p:spPr>
           <a:xfrm>
-            <a:off x="4242816" y="1993392"/>
+            <a:off x="4425696" y="1956816"/>
             <a:ext cx="566928" cy="329184"/>
           </a:xfrm>
           <a:prstGeom prst="roundRect">
@@ -8927,7 +8929,7 @@
         </p:nvSpPr>
         <p:spPr>
           <a:xfrm>
-            <a:off x="4242816" y="2020824"/>
+            <a:off x="4425696" y="1984248"/>
             <a:ext cx="566928" cy="329184"/>
           </a:xfrm>
           <a:prstGeom prst="rect">
@@ -8962,8 +8964,8 @@
         </p:nvSpPr>
         <p:spPr>
           <a:xfrm>
-            <a:off x="3602736" y="2743200"/>
-            <a:ext cx="1828800" cy="219456"/>
+            <a:off x="3694176" y="2770632"/>
+            <a:ext cx="2029968" cy="310896"/>
           </a:xfrm>
           <a:prstGeom prst="rect">
             <a:avLst/>
@@ -8978,7 +8980,7 @@
           <a:p>
             <a:pPr algn="ctr"/>
             <a:r>
-              <a:rPr sz="1800" b="1">
+              <a:rPr sz="1700" b="1">
                 <a:solidFill>
                   <a:srgbClr val="1A1F24"/>
                 </a:solidFill>
@@ -8997,8 +8999,8 @@
         </p:nvSpPr>
         <p:spPr>
           <a:xfrm>
-            <a:off x="5394960" y="2743200"/>
-            <a:ext cx="347472" cy="256032"/>
+            <a:off x="5916168" y="2816352"/>
+            <a:ext cx="310896" cy="219456"/>
           </a:xfrm>
           <a:prstGeom prst="chevron">
             <a:avLst/>
@@ -9040,8 +9042,8 @@
         </p:nvSpPr>
         <p:spPr>
           <a:xfrm>
-            <a:off x="6144768" y="2331720"/>
-            <a:ext cx="2057400" cy="1188720"/>
+            <a:off x="6291072" y="2331720"/>
+            <a:ext cx="2212848" cy="1225296"/>
           </a:xfrm>
           <a:prstGeom prst="roundRect">
             <a:avLst/>
@@ -9085,7 +9087,7 @@
         </p:nvSpPr>
         <p:spPr>
           <a:xfrm>
-            <a:off x="6894576" y="1993392"/>
+            <a:off x="7168896" y="1956816"/>
             <a:ext cx="566928" cy="329184"/>
           </a:xfrm>
           <a:prstGeom prst="roundRect">
@@ -9130,7 +9132,7 @@
         </p:nvSpPr>
         <p:spPr>
           <a:xfrm>
-            <a:off x="6894576" y="2020824"/>
+            <a:off x="7168896" y="1984248"/>
             <a:ext cx="566928" cy="329184"/>
           </a:xfrm>
           <a:prstGeom prst="rect">
@@ -9165,8 +9167,8 @@
         </p:nvSpPr>
         <p:spPr>
           <a:xfrm>
-            <a:off x="6254496" y="2743200"/>
-            <a:ext cx="1828800" cy="219456"/>
+            <a:off x="6437376" y="2770632"/>
+            <a:ext cx="2029968" cy="310896"/>
           </a:xfrm>
           <a:prstGeom prst="rect">
             <a:avLst/>
@@ -9181,7 +9183,7 @@
           <a:p>
             <a:pPr algn="ctr"/>
             <a:r>
-              <a:rPr sz="1800" b="1">
+              <a:rPr sz="1700" b="1">
                 <a:solidFill>
                   <a:srgbClr val="1A1F24"/>
                 </a:solidFill>
@@ -9200,8 +9202,8 @@
         </p:nvSpPr>
         <p:spPr>
           <a:xfrm>
-            <a:off x="8046720" y="2743200"/>
-            <a:ext cx="347472" cy="256032"/>
+            <a:off x="8659368" y="2816352"/>
+            <a:ext cx="310896" cy="219456"/>
           </a:xfrm>
           <a:prstGeom prst="chevron">
             <a:avLst/>
@@ -9243,8 +9245,8 @@
         </p:nvSpPr>
         <p:spPr>
           <a:xfrm>
-            <a:off x="8796528" y="2331720"/>
-            <a:ext cx="2057400" cy="1188720"/>
+            <a:off x="9034272" y="2331720"/>
+            <a:ext cx="2212848" cy="1225296"/>
           </a:xfrm>
           <a:prstGeom prst="roundRect">
             <a:avLst/>
@@ -9288,7 +9290,7 @@
         </p:nvSpPr>
         <p:spPr>
           <a:xfrm>
-            <a:off x="9546336" y="1993392"/>
+            <a:off x="9912096" y="1956816"/>
             <a:ext cx="566928" cy="329184"/>
           </a:xfrm>
           <a:prstGeom prst="roundRect">
@@ -9333,7 +9335,7 @@
         </p:nvSpPr>
         <p:spPr>
           <a:xfrm>
-            <a:off x="9546336" y="2020824"/>
+            <a:off x="9912096" y="1984248"/>
             <a:ext cx="566928" cy="329184"/>
           </a:xfrm>
           <a:prstGeom prst="rect">
@@ -9368,8 +9370,8 @@
         </p:nvSpPr>
         <p:spPr>
           <a:xfrm>
-            <a:off x="8906256" y="2743200"/>
-            <a:ext cx="1828800" cy="219456"/>
+            <a:off x="9180576" y="2770632"/>
+            <a:ext cx="2029968" cy="310896"/>
           </a:xfrm>
           <a:prstGeom prst="rect">
             <a:avLst/>
@@ -9384,7 +9386,7 @@
           <a:p>
             <a:pPr algn="ctr"/>
             <a:r>
-              <a:rPr sz="1800" b="1">
+              <a:rPr sz="1700" b="1">
                 <a:solidFill>
                   <a:srgbClr val="1A1F24"/>
                 </a:solidFill>

</xml_diff>

<commit_message>
docs(slides): simplify prompt deck layout
</commit_message>
<xml_diff>
--- a/docs/source/TP Prompt Ingénierie.pptx
+++ b/docs/source/TP Prompt Ingénierie.pptx
@@ -3170,7 +3170,7 @@
                 </a:solidFill>
                 <a:latin typeface="Aptos"/>
               </a:rPr>
-              <a:t>Le prompt ne cadre pas seulement le modèle. Il cadre le système d'exécution : modèle, boucle agentique et runtime.</a:t>
+              <a:t>Le prompt cadre le système d'exécution : modèle, boucle agentique et runtime.</a:t>
             </a:r>
           </a:p>
         </p:txBody>
@@ -3227,7 +3227,7 @@
         <p:spPr>
           <a:xfrm>
             <a:off x="3822191" y="1828800"/>
-            <a:ext cx="4617720" cy="475488"/>
+            <a:ext cx="4663440" cy="420624"/>
           </a:xfrm>
           <a:prstGeom prst="rect">
             <a:avLst/>
@@ -3242,7 +3242,7 @@
           <a:p>
             <a:pPr algn="ctr"/>
             <a:r>
-              <a:rPr sz="2000" b="1">
+              <a:rPr sz="1900" b="1">
                 <a:solidFill>
                   <a:srgbClr val="17222D"/>
                 </a:solidFill>
@@ -3262,7 +3262,7 @@
         <p:spPr>
           <a:xfrm>
             <a:off x="640080" y="2267712"/>
-            <a:ext cx="2560320" cy="2999232"/>
+            <a:ext cx="2596896" cy="2944368"/>
           </a:xfrm>
           <a:prstGeom prst="roundRect">
             <a:avLst/>
@@ -3306,8 +3306,8 @@
         </p:nvSpPr>
         <p:spPr>
           <a:xfrm>
-            <a:off x="3730752" y="2267712"/>
-            <a:ext cx="4315968" cy="2999232"/>
+            <a:off x="3675887" y="2267712"/>
+            <a:ext cx="4480560" cy="2944368"/>
           </a:xfrm>
           <a:prstGeom prst="roundRect">
             <a:avLst/>
@@ -3351,8 +3351,8 @@
         </p:nvSpPr>
         <p:spPr>
           <a:xfrm>
-            <a:off x="8577072" y="2267712"/>
-            <a:ext cx="2971800" cy="2999232"/>
+            <a:off x="8485632" y="2267712"/>
+            <a:ext cx="3127248" cy="2944368"/>
           </a:xfrm>
           <a:prstGeom prst="roundRect">
             <a:avLst/>
@@ -3396,8 +3396,8 @@
         </p:nvSpPr>
         <p:spPr>
           <a:xfrm>
-            <a:off x="886968" y="2542032"/>
-            <a:ext cx="2057400" cy="292608"/>
+            <a:off x="886968" y="2523744"/>
+            <a:ext cx="2103120" cy="292608"/>
           </a:xfrm>
           <a:prstGeom prst="rect">
             <a:avLst/>
@@ -3412,7 +3412,7 @@
           <a:p>
             <a:pPr algn="ctr"/>
             <a:r>
-              <a:rPr sz="2200" b="0">
+              <a:rPr sz="2100" b="0">
                 <a:solidFill>
                   <a:srgbClr val="17222D"/>
                 </a:solidFill>
@@ -3431,8 +3431,8 @@
         </p:nvSpPr>
         <p:spPr>
           <a:xfrm>
-            <a:off x="1024128" y="3163824"/>
-            <a:ext cx="1810512" cy="859536"/>
+            <a:off x="1005840" y="3054096"/>
+            <a:ext cx="1847088" cy="877824"/>
           </a:xfrm>
           <a:prstGeom prst="roundRect">
             <a:avLst/>
@@ -3476,8 +3476,8 @@
         </p:nvSpPr>
         <p:spPr>
           <a:xfrm>
-            <a:off x="1115568" y="3456432"/>
-            <a:ext cx="1627632" cy="219456"/>
+            <a:off x="1115568" y="3319272"/>
+            <a:ext cx="1627632" cy="310896"/>
           </a:xfrm>
           <a:prstGeom prst="rect">
             <a:avLst/>
@@ -3492,7 +3492,7 @@
           <a:p>
             <a:pPr algn="ctr"/>
             <a:r>
-              <a:rPr sz="2000" b="0">
+              <a:rPr sz="1900" b="0">
                 <a:solidFill>
                   <a:srgbClr val="17222D"/>
                 </a:solidFill>
@@ -3511,8 +3511,8 @@
         </p:nvSpPr>
         <p:spPr>
           <a:xfrm rot="5400000">
-            <a:off x="1764792" y="4078224"/>
-            <a:ext cx="310896" cy="310896"/>
+            <a:off x="1773936" y="3968496"/>
+            <a:ext cx="292608" cy="292608"/>
           </a:xfrm>
           <a:prstGeom prst="chevron">
             <a:avLst/>
@@ -3554,8 +3554,8 @@
         </p:nvSpPr>
         <p:spPr>
           <a:xfrm>
-            <a:off x="1024128" y="4462272"/>
-            <a:ext cx="1810512" cy="859536"/>
+            <a:off x="1005840" y="4315968"/>
+            <a:ext cx="1847088" cy="877824"/>
           </a:xfrm>
           <a:prstGeom prst="roundRect">
             <a:avLst/>
@@ -3599,7 +3599,7 @@
         </p:nvSpPr>
         <p:spPr>
           <a:xfrm>
-            <a:off x="1115568" y="4681728"/>
+            <a:off x="1115568" y="4535424"/>
             <a:ext cx="1627632" cy="384048"/>
           </a:xfrm>
           <a:prstGeom prst="rect">
@@ -3615,7 +3615,7 @@
           <a:p>
             <a:pPr algn="ctr"/>
             <a:r>
-              <a:rPr sz="2000" b="0">
+              <a:rPr sz="1900" b="0">
                 <a:solidFill>
                   <a:srgbClr val="17222D"/>
                 </a:solidFill>
@@ -3635,7 +3635,7 @@
         </p:nvSpPr>
         <p:spPr>
           <a:xfrm>
-            <a:off x="4663440" y="2542032"/>
+            <a:off x="4700016" y="2523744"/>
             <a:ext cx="2487168" cy="292608"/>
           </a:xfrm>
           <a:prstGeom prst="rect">
@@ -3651,7 +3651,7 @@
           <a:p>
             <a:pPr algn="ctr"/>
             <a:r>
-              <a:rPr sz="2200" b="0">
+              <a:rPr sz="2100" b="0">
                 <a:solidFill>
                   <a:srgbClr val="17222D"/>
                 </a:solidFill>
@@ -3670,8 +3670,8 @@
         </p:nvSpPr>
         <p:spPr>
           <a:xfrm>
-            <a:off x="4169663" y="3511296"/>
-            <a:ext cx="1353312" cy="566928"/>
+            <a:off x="4187952" y="3401568"/>
+            <a:ext cx="1463040" cy="566928"/>
           </a:xfrm>
           <a:prstGeom prst="roundRect">
             <a:avLst/>
@@ -3715,8 +3715,8 @@
         </p:nvSpPr>
         <p:spPr>
           <a:xfrm>
-            <a:off x="4169663" y="3666744"/>
-            <a:ext cx="1353312" cy="182880"/>
+            <a:off x="4187952" y="3547872"/>
+            <a:ext cx="1463040" cy="201168"/>
           </a:xfrm>
           <a:prstGeom prst="rect">
             <a:avLst/>
@@ -3731,7 +3731,7 @@
           <a:p>
             <a:pPr algn="ctr"/>
             <a:r>
-              <a:rPr sz="1900" b="0">
+              <a:rPr sz="1800" b="0">
                 <a:solidFill>
                   <a:srgbClr val="17222D"/>
                 </a:solidFill>
@@ -3750,8 +3750,8 @@
         </p:nvSpPr>
         <p:spPr>
           <a:xfrm>
-            <a:off x="6016752" y="3511296"/>
-            <a:ext cx="1353312" cy="566928"/>
+            <a:off x="6144768" y="3401568"/>
+            <a:ext cx="1463040" cy="566928"/>
           </a:xfrm>
           <a:prstGeom prst="roundRect">
             <a:avLst/>
@@ -3795,8 +3795,8 @@
         </p:nvSpPr>
         <p:spPr>
           <a:xfrm>
-            <a:off x="6016752" y="3666744"/>
-            <a:ext cx="1353312" cy="182880"/>
+            <a:off x="6144768" y="3547872"/>
+            <a:ext cx="1463040" cy="201168"/>
           </a:xfrm>
           <a:prstGeom prst="rect">
             <a:avLst/>
@@ -3811,7 +3811,7 @@
           <a:p>
             <a:pPr algn="ctr"/>
             <a:r>
-              <a:rPr sz="1900" b="0">
+              <a:rPr sz="1800" b="0">
                 <a:solidFill>
                   <a:srgbClr val="17222D"/>
                 </a:solidFill>
@@ -3830,8 +3830,8 @@
         </p:nvSpPr>
         <p:spPr>
           <a:xfrm>
-            <a:off x="4169663" y="4590288"/>
-            <a:ext cx="1353312" cy="566928"/>
+            <a:off x="4187952" y="4498848"/>
+            <a:ext cx="1463040" cy="566928"/>
           </a:xfrm>
           <a:prstGeom prst="roundRect">
             <a:avLst/>
@@ -3875,8 +3875,8 @@
         </p:nvSpPr>
         <p:spPr>
           <a:xfrm>
-            <a:off x="4169663" y="4745736"/>
-            <a:ext cx="1353312" cy="182880"/>
+            <a:off x="4187952" y="4645152"/>
+            <a:ext cx="1463040" cy="201168"/>
           </a:xfrm>
           <a:prstGeom prst="rect">
             <a:avLst/>
@@ -3891,7 +3891,7 @@
           <a:p>
             <a:pPr algn="ctr"/>
             <a:r>
-              <a:rPr sz="1900" b="0">
+              <a:rPr sz="1800" b="0">
                 <a:solidFill>
                   <a:srgbClr val="17222D"/>
                 </a:solidFill>
@@ -3910,8 +3910,8 @@
         </p:nvSpPr>
         <p:spPr>
           <a:xfrm>
-            <a:off x="6016752" y="4590288"/>
-            <a:ext cx="1353312" cy="566928"/>
+            <a:off x="6144768" y="4498848"/>
+            <a:ext cx="1463040" cy="566928"/>
           </a:xfrm>
           <a:prstGeom prst="roundRect">
             <a:avLst/>
@@ -3955,8 +3955,8 @@
         </p:nvSpPr>
         <p:spPr>
           <a:xfrm>
-            <a:off x="6016752" y="4745736"/>
-            <a:ext cx="1353312" cy="182880"/>
+            <a:off x="6144768" y="4645152"/>
+            <a:ext cx="1463040" cy="201168"/>
           </a:xfrm>
           <a:prstGeom prst="rect">
             <a:avLst/>
@@ -3971,7 +3971,7 @@
           <a:p>
             <a:pPr algn="ctr"/>
             <a:r>
-              <a:rPr sz="1900" b="0">
+              <a:rPr sz="1800" b="0">
                 <a:solidFill>
                   <a:srgbClr val="17222D"/>
                 </a:solidFill>
@@ -3990,8 +3990,8 @@
         </p:nvSpPr>
         <p:spPr>
           <a:xfrm>
-            <a:off x="5541264" y="3712463"/>
-            <a:ext cx="256032" cy="164592"/>
+            <a:off x="5724144" y="3611880"/>
+            <a:ext cx="237744" cy="146304"/>
           </a:xfrm>
           <a:prstGeom prst="chevron">
             <a:avLst/>
@@ -4033,8 +4033,8 @@
         </p:nvSpPr>
         <p:spPr>
           <a:xfrm rot="5400000">
-            <a:off x="6547104" y="4096512"/>
-            <a:ext cx="164592" cy="256032"/>
+            <a:off x="6793992" y="3941063"/>
+            <a:ext cx="146304" cy="237744"/>
           </a:xfrm>
           <a:prstGeom prst="chevron">
             <a:avLst/>
@@ -4076,8 +4076,8 @@
         </p:nvSpPr>
         <p:spPr>
           <a:xfrm rot="10800000">
-            <a:off x="5541264" y="4828032"/>
-            <a:ext cx="256032" cy="164592"/>
+            <a:off x="5724144" y="4672584"/>
+            <a:ext cx="237744" cy="146304"/>
           </a:xfrm>
           <a:prstGeom prst="chevron">
             <a:avLst/>
@@ -4119,8 +4119,8 @@
         </p:nvSpPr>
         <p:spPr>
           <a:xfrm rot="16200000">
-            <a:off x="4718304" y="4078224"/>
-            <a:ext cx="164592" cy="256032"/>
+            <a:off x="4910328" y="3968496"/>
+            <a:ext cx="146304" cy="237744"/>
           </a:xfrm>
           <a:prstGeom prst="chevron">
             <a:avLst/>
@@ -4162,8 +4162,8 @@
         </p:nvSpPr>
         <p:spPr>
           <a:xfrm>
-            <a:off x="8686800" y="2542032"/>
-            <a:ext cx="2724912" cy="292608"/>
+            <a:off x="8650224" y="2523744"/>
+            <a:ext cx="2761488" cy="292608"/>
           </a:xfrm>
           <a:prstGeom prst="rect">
             <a:avLst/>
@@ -4197,8 +4197,8 @@
         </p:nvSpPr>
         <p:spPr>
           <a:xfrm>
-            <a:off x="8778240" y="3456432"/>
-            <a:ext cx="1261872" cy="530352"/>
+            <a:off x="8741664" y="3346704"/>
+            <a:ext cx="1316736" cy="548640"/>
           </a:xfrm>
           <a:prstGeom prst="roundRect">
             <a:avLst/>
@@ -4242,8 +4242,8 @@
         </p:nvSpPr>
         <p:spPr>
           <a:xfrm>
-            <a:off x="8778240" y="3538728"/>
-            <a:ext cx="1261872" cy="310896"/>
+            <a:off x="8741664" y="3438144"/>
+            <a:ext cx="1316736" cy="310896"/>
           </a:xfrm>
           <a:prstGeom prst="rect">
             <a:avLst/>
@@ -4258,7 +4258,7 @@
           <a:p>
             <a:pPr algn="ctr"/>
             <a:r>
-              <a:rPr sz="1400" b="0">
+              <a:rPr sz="1300" b="0">
                 <a:solidFill>
                   <a:srgbClr val="17222D"/>
                 </a:solidFill>
@@ -4278,8 +4278,8 @@
         </p:nvSpPr>
         <p:spPr>
           <a:xfrm>
-            <a:off x="10113264" y="3456432"/>
-            <a:ext cx="1261872" cy="530352"/>
+            <a:off x="10168128" y="3346704"/>
+            <a:ext cx="1316736" cy="548640"/>
           </a:xfrm>
           <a:prstGeom prst="roundRect">
             <a:avLst/>
@@ -4323,8 +4323,8 @@
         </p:nvSpPr>
         <p:spPr>
           <a:xfrm>
-            <a:off x="10113264" y="3538728"/>
-            <a:ext cx="1261872" cy="310896"/>
+            <a:off x="10168128" y="3438144"/>
+            <a:ext cx="1316736" cy="310896"/>
           </a:xfrm>
           <a:prstGeom prst="rect">
             <a:avLst/>
@@ -4339,7 +4339,7 @@
           <a:p>
             <a:pPr algn="ctr"/>
             <a:r>
-              <a:rPr sz="1400" b="0">
+              <a:rPr sz="1300" b="0">
                 <a:solidFill>
                   <a:srgbClr val="17222D"/>
                 </a:solidFill>
@@ -4358,8 +4358,8 @@
         </p:nvSpPr>
         <p:spPr>
           <a:xfrm>
-            <a:off x="8778240" y="4224528"/>
-            <a:ext cx="1261872" cy="530352"/>
+            <a:off x="8741664" y="4142232"/>
+            <a:ext cx="1316736" cy="548640"/>
           </a:xfrm>
           <a:prstGeom prst="roundRect">
             <a:avLst/>
@@ -4403,8 +4403,8 @@
         </p:nvSpPr>
         <p:spPr>
           <a:xfrm>
-            <a:off x="8778240" y="4306824"/>
-            <a:ext cx="1261872" cy="310896"/>
+            <a:off x="8741664" y="4233672"/>
+            <a:ext cx="1316736" cy="310896"/>
           </a:xfrm>
           <a:prstGeom prst="rect">
             <a:avLst/>
@@ -4419,7 +4419,7 @@
           <a:p>
             <a:pPr algn="ctr"/>
             <a:r>
-              <a:rPr sz="1400" b="0">
+              <a:rPr sz="1300" b="0">
                 <a:solidFill>
                   <a:srgbClr val="17222D"/>
                 </a:solidFill>
@@ -4438,8 +4438,8 @@
         </p:nvSpPr>
         <p:spPr>
           <a:xfrm>
-            <a:off x="10113264" y="4224528"/>
-            <a:ext cx="1261872" cy="530352"/>
+            <a:off x="10168128" y="4142232"/>
+            <a:ext cx="1316736" cy="548640"/>
           </a:xfrm>
           <a:prstGeom prst="roundRect">
             <a:avLst/>
@@ -4483,8 +4483,8 @@
         </p:nvSpPr>
         <p:spPr>
           <a:xfrm>
-            <a:off x="10113264" y="4306824"/>
-            <a:ext cx="1261872" cy="310896"/>
+            <a:off x="10168128" y="4233672"/>
+            <a:ext cx="1316736" cy="310896"/>
           </a:xfrm>
           <a:prstGeom prst="rect">
             <a:avLst/>
@@ -4499,7 +4499,7 @@
           <a:p>
             <a:pPr algn="ctr"/>
             <a:r>
-              <a:rPr sz="1400" b="0">
+              <a:rPr sz="1300" b="0">
                 <a:solidFill>
                   <a:srgbClr val="17222D"/>
                 </a:solidFill>
@@ -4518,8 +4518,8 @@
         </p:nvSpPr>
         <p:spPr>
           <a:xfrm>
-            <a:off x="8778240" y="4992624"/>
-            <a:ext cx="1261872" cy="530352"/>
+            <a:off x="8741664" y="4937760"/>
+            <a:ext cx="1316736" cy="548640"/>
           </a:xfrm>
           <a:prstGeom prst="roundRect">
             <a:avLst/>
@@ -4563,8 +4563,8 @@
         </p:nvSpPr>
         <p:spPr>
           <a:xfrm>
-            <a:off x="8778240" y="5074920"/>
-            <a:ext cx="1261872" cy="310896"/>
+            <a:off x="8741664" y="5029200"/>
+            <a:ext cx="1316736" cy="310896"/>
           </a:xfrm>
           <a:prstGeom prst="rect">
             <a:avLst/>
@@ -4579,7 +4579,7 @@
           <a:p>
             <a:pPr algn="ctr"/>
             <a:r>
-              <a:rPr sz="1400" b="0">
+              <a:rPr sz="1300" b="0">
                 <a:solidFill>
                   <a:srgbClr val="17222D"/>
                 </a:solidFill>
@@ -4598,8 +4598,8 @@
         </p:nvSpPr>
         <p:spPr>
           <a:xfrm>
-            <a:off x="10113264" y="4992624"/>
-            <a:ext cx="1261872" cy="530352"/>
+            <a:off x="10168128" y="4937760"/>
+            <a:ext cx="1316736" cy="548640"/>
           </a:xfrm>
           <a:prstGeom prst="roundRect">
             <a:avLst/>
@@ -4643,8 +4643,8 @@
         </p:nvSpPr>
         <p:spPr>
           <a:xfrm>
-            <a:off x="10113264" y="5074920"/>
-            <a:ext cx="1261872" cy="310896"/>
+            <a:off x="10168128" y="5029200"/>
+            <a:ext cx="1316736" cy="310896"/>
           </a:xfrm>
           <a:prstGeom prst="rect">
             <a:avLst/>
@@ -4659,7 +4659,7 @@
           <a:p>
             <a:pPr algn="ctr"/>
             <a:r>
-              <a:rPr sz="1400" b="0">
+              <a:rPr sz="1300" b="0">
                 <a:solidFill>
                   <a:srgbClr val="17222D"/>
                 </a:solidFill>
@@ -4758,14 +4758,59 @@
       </p:sp>
       <p:sp>
         <p:nvSpPr>
-          <p:cNvPr id="43" name="TextBox 42"/>
+          <p:cNvPr id="43" name="Rounded Rectangle 42"/>
+          <p:cNvSpPr/>
+          <p:nvPr/>
+        </p:nvSpPr>
+        <p:spPr>
+          <a:xfrm>
+            <a:off x="987552" y="5468112"/>
+            <a:ext cx="10149840" cy="676656"/>
+          </a:xfrm>
+          <a:prstGeom prst="roundRect">
+            <a:avLst/>
+          </a:prstGeom>
+          <a:solidFill>
+            <a:srgbClr val="F4ECE0"/>
+          </a:solidFill>
+          <a:ln w="15240">
+            <a:solidFill>
+              <a:srgbClr val="F4ECE0"/>
+            </a:solidFill>
+          </a:ln>
+        </p:spPr>
+        <p:style>
+          <a:lnRef idx="1">
+            <a:schemeClr val="accent1"/>
+          </a:lnRef>
+          <a:fillRef idx="3">
+            <a:schemeClr val="accent1"/>
+          </a:fillRef>
+          <a:effectRef idx="2">
+            <a:schemeClr val="accent1"/>
+          </a:effectRef>
+          <a:fontRef idx="minor">
+            <a:schemeClr val="lt1"/>
+          </a:fontRef>
+        </p:style>
+        <p:txBody>
+          <a:bodyPr rtlCol="0" anchor="ctr"/>
+          <a:lstStyle/>
+          <a:p>
+            <a:pPr algn="ctr"/>
+          </a:p>
+        </p:txBody>
+      </p:sp>
+      <p:sp>
+        <p:nvSpPr>
+          <p:cNvPr id="44" name="TextBox 43"/>
           <p:cNvSpPr txBox="1"/>
           <p:nvPr/>
         </p:nvSpPr>
         <p:spPr>
           <a:xfrm>
-            <a:off x="914400" y="5577840"/>
-            <a:ext cx="10332720" cy="384048"/>
+            <a:off x="1225296" y="5650992"/>
+            <a:ext cx="9692640" cy="256032"/>
           </a:xfrm>
           <a:prstGeom prst="rect">
             <a:avLst/>
@@ -4786,7 +4831,7 @@
                 </a:solidFill>
                 <a:latin typeface="Aptos"/>
               </a:rPr>
-              <a:t>Le Prompt Engineering sert à cadrer la boucle, les outils, les règles d'exécution et le bon niveau de contexte.</a:t>
+              <a:t>Le Prompt Engineering cadre la boucle, les outils et le bon niveau de contexte.</a:t>
             </a:r>
           </a:p>
         </p:txBody>
@@ -6248,8 +6293,8 @@
         </p:nvSpPr>
         <p:spPr>
           <a:xfrm>
-            <a:off x="896112" y="4572000"/>
-            <a:ext cx="4800600" cy="841248"/>
+            <a:off x="896112" y="4590288"/>
+            <a:ext cx="4800600" cy="896112"/>
           </a:xfrm>
           <a:prstGeom prst="roundRect">
             <a:avLst/>
@@ -6329,7 +6374,7 @@
         <p:spPr>
           <a:xfrm>
             <a:off x="1078992" y="4974336"/>
-            <a:ext cx="4443984" cy="292608"/>
+            <a:ext cx="4443984" cy="384048"/>
           </a:xfrm>
           <a:prstGeom prst="rect">
             <a:avLst/>
@@ -6344,7 +6389,7 @@
           <a:p>
             <a:pPr algn="ctr"/>
             <a:r>
-              <a:rPr sz="1900" b="1">
+              <a:rPr sz="1800" b="1">
                 <a:solidFill>
                   <a:srgbClr val="215472"/>
                 </a:solidFill>
@@ -6363,8 +6408,8 @@
         </p:nvSpPr>
         <p:spPr>
           <a:xfrm>
-            <a:off x="5989320" y="4572000"/>
-            <a:ext cx="5285232" cy="841248"/>
+            <a:off x="5989320" y="4590288"/>
+            <a:ext cx="5285232" cy="896112"/>
           </a:xfrm>
           <a:prstGeom prst="roundRect">
             <a:avLst/>
@@ -6444,7 +6489,7 @@
         <p:spPr>
           <a:xfrm>
             <a:off x="6199632" y="4974336"/>
-            <a:ext cx="4864608" cy="292608"/>
+            <a:ext cx="4864608" cy="384048"/>
           </a:xfrm>
           <a:prstGeom prst="rect">
             <a:avLst/>
@@ -6459,7 +6504,7 @@
           <a:p>
             <a:pPr algn="ctr"/>
             <a:r>
-              <a:rPr sz="1900" b="1">
+              <a:rPr sz="1800" b="1">
                 <a:solidFill>
                   <a:srgbClr val="215472"/>
                 </a:solidFill>
@@ -6617,143 +6662,8 @@
         </p:nvSpPr>
         <p:spPr>
           <a:xfrm>
-            <a:off x="713232" y="2816352"/>
-            <a:ext cx="3063240" cy="1554480"/>
-          </a:xfrm>
-          <a:prstGeom prst="roundRect">
-            <a:avLst/>
-          </a:prstGeom>
-          <a:solidFill>
-            <a:srgbClr val="F4F0EB"/>
-          </a:solidFill>
-          <a:ln w="15240">
-            <a:solidFill>
-              <a:srgbClr val="F4F0EB"/>
-            </a:solidFill>
-          </a:ln>
-        </p:spPr>
-        <p:style>
-          <a:lnRef idx="1">
-            <a:schemeClr val="accent1"/>
-          </a:lnRef>
-          <a:fillRef idx="3">
-            <a:schemeClr val="accent1"/>
-          </a:fillRef>
-          <a:effectRef idx="2">
-            <a:schemeClr val="accent1"/>
-          </a:effectRef>
-          <a:fontRef idx="minor">
-            <a:schemeClr val="lt1"/>
-          </a:fontRef>
-        </p:style>
-        <p:txBody>
-          <a:bodyPr rtlCol="0" anchor="ctr"/>
-          <a:lstStyle/>
-          <a:p>
-            <a:pPr algn="ctr"/>
-          </a:p>
-        </p:txBody>
-      </p:sp>
-      <p:sp>
-        <p:nvSpPr>
-          <p:cNvPr id="6" name="Rounded Rectangle 5"/>
-          <p:cNvSpPr/>
-          <p:nvPr/>
-        </p:nvSpPr>
-        <p:spPr>
-          <a:xfrm>
-            <a:off x="3703320" y="2249424"/>
-            <a:ext cx="3291840" cy="2121408"/>
-          </a:xfrm>
-          <a:prstGeom prst="roundRect">
-            <a:avLst/>
-          </a:prstGeom>
-          <a:solidFill>
-            <a:srgbClr val="F2EBE3"/>
-          </a:solidFill>
-          <a:ln w="15240">
-            <a:solidFill>
-              <a:srgbClr val="F2EBE3"/>
-            </a:solidFill>
-          </a:ln>
-        </p:spPr>
-        <p:style>
-          <a:lnRef idx="1">
-            <a:schemeClr val="accent1"/>
-          </a:lnRef>
-          <a:fillRef idx="3">
-            <a:schemeClr val="accent1"/>
-          </a:fillRef>
-          <a:effectRef idx="2">
-            <a:schemeClr val="accent1"/>
-          </a:effectRef>
-          <a:fontRef idx="minor">
-            <a:schemeClr val="lt1"/>
-          </a:fontRef>
-        </p:style>
-        <p:txBody>
-          <a:bodyPr rtlCol="0" anchor="ctr"/>
-          <a:lstStyle/>
-          <a:p>
-            <a:pPr algn="ctr"/>
-          </a:p>
-        </p:txBody>
-      </p:sp>
-      <p:sp>
-        <p:nvSpPr>
-          <p:cNvPr id="7" name="Rounded Rectangle 6"/>
-          <p:cNvSpPr/>
-          <p:nvPr/>
-        </p:nvSpPr>
-        <p:spPr>
-          <a:xfrm>
-            <a:off x="6839712" y="1627632"/>
-            <a:ext cx="3767328" cy="2743200"/>
-          </a:xfrm>
-          <a:prstGeom prst="roundRect">
-            <a:avLst/>
-          </a:prstGeom>
-          <a:solidFill>
-            <a:srgbClr val="EFE3D6"/>
-          </a:solidFill>
-          <a:ln w="15240">
-            <a:solidFill>
-              <a:srgbClr val="EFE3D6"/>
-            </a:solidFill>
-          </a:ln>
-        </p:spPr>
-        <p:style>
-          <a:lnRef idx="1">
-            <a:schemeClr val="accent1"/>
-          </a:lnRef>
-          <a:fillRef idx="3">
-            <a:schemeClr val="accent1"/>
-          </a:fillRef>
-          <a:effectRef idx="2">
-            <a:schemeClr val="accent1"/>
-          </a:effectRef>
-          <a:fontRef idx="minor">
-            <a:schemeClr val="lt1"/>
-          </a:fontRef>
-        </p:style>
-        <p:txBody>
-          <a:bodyPr rtlCol="0" anchor="ctr"/>
-          <a:lstStyle/>
-          <a:p>
-            <a:pPr algn="ctr"/>
-          </a:p>
-        </p:txBody>
-      </p:sp>
-      <p:sp>
-        <p:nvSpPr>
-          <p:cNvPr id="8" name="Rounded Rectangle 7"/>
-          <p:cNvSpPr/>
-          <p:nvPr/>
-        </p:nvSpPr>
-        <p:spPr>
-          <a:xfrm>
-            <a:off x="868680" y="2066543"/>
-            <a:ext cx="2697480" cy="2304288"/>
+            <a:off x="822960" y="1901952"/>
+            <a:ext cx="2926080" cy="2468880"/>
           </a:xfrm>
           <a:prstGeom prst="roundRect">
             <a:avLst/>
@@ -6791,13 +6701,13 @@
       </p:sp>
       <p:sp>
         <p:nvSpPr>
-          <p:cNvPr id="9" name="Rounded Rectangle 8"/>
+          <p:cNvPr id="6" name="Rounded Rectangle 5"/>
           <p:cNvSpPr/>
           <p:nvPr/>
         </p:nvSpPr>
         <p:spPr>
           <a:xfrm>
-            <a:off x="1088136" y="2231135"/>
+            <a:off x="1042416" y="2066544"/>
             <a:ext cx="1078992" cy="310896"/>
           </a:xfrm>
           <a:prstGeom prst="roundRect">
@@ -6836,13 +6746,13 @@
       </p:sp>
       <p:sp>
         <p:nvSpPr>
-          <p:cNvPr id="10" name="TextBox 9"/>
+          <p:cNvPr id="7" name="TextBox 6"/>
           <p:cNvSpPr txBox="1"/>
           <p:nvPr/>
         </p:nvSpPr>
         <p:spPr>
           <a:xfrm>
-            <a:off x="1088136" y="2258567"/>
+            <a:off x="1042416" y="2093976"/>
             <a:ext cx="1078992" cy="310896"/>
           </a:xfrm>
           <a:prstGeom prst="rect">
@@ -6871,14 +6781,14 @@
       </p:sp>
       <p:sp>
         <p:nvSpPr>
-          <p:cNvPr id="11" name="TextBox 10"/>
+          <p:cNvPr id="8" name="TextBox 7"/>
           <p:cNvSpPr txBox="1"/>
           <p:nvPr/>
         </p:nvSpPr>
         <p:spPr>
           <a:xfrm>
-            <a:off x="1088136" y="2596895"/>
-            <a:ext cx="2258568" cy="512064"/>
+            <a:off x="1042416" y="2468880"/>
+            <a:ext cx="2487168" cy="365760"/>
           </a:xfrm>
           <a:prstGeom prst="rect">
             <a:avLst/>
@@ -6906,14 +6816,14 @@
       </p:sp>
       <p:sp>
         <p:nvSpPr>
-          <p:cNvPr id="12" name="TextBox 11"/>
+          <p:cNvPr id="9" name="TextBox 8"/>
           <p:cNvSpPr txBox="1"/>
           <p:nvPr/>
         </p:nvSpPr>
         <p:spPr>
           <a:xfrm>
-            <a:off x="1088136" y="3108958"/>
-            <a:ext cx="2258568" cy="219456"/>
+            <a:off x="1042416" y="2889504"/>
+            <a:ext cx="2487168" cy="219456"/>
           </a:xfrm>
           <a:prstGeom prst="rect">
             <a:avLst/>
@@ -6941,14 +6851,14 @@
       </p:sp>
       <p:sp>
         <p:nvSpPr>
-          <p:cNvPr id="13" name="TextBox 12"/>
+          <p:cNvPr id="10" name="TextBox 9"/>
           <p:cNvSpPr txBox="1"/>
           <p:nvPr/>
         </p:nvSpPr>
         <p:spPr>
           <a:xfrm>
-            <a:off x="1124712" y="3383279"/>
-            <a:ext cx="2185416" cy="365760"/>
+            <a:off x="1133856" y="3291840"/>
+            <a:ext cx="2304288" cy="475488"/>
           </a:xfrm>
           <a:prstGeom prst="rect">
             <a:avLst/>
@@ -6977,14 +6887,14 @@
       </p:sp>
       <p:sp>
         <p:nvSpPr>
-          <p:cNvPr id="14" name="Rounded Rectangle 13"/>
+          <p:cNvPr id="11" name="Rounded Rectangle 10"/>
           <p:cNvSpPr/>
           <p:nvPr/>
         </p:nvSpPr>
         <p:spPr>
           <a:xfrm>
-            <a:off x="1495044" y="4023359"/>
-            <a:ext cx="1444752" cy="292608"/>
+            <a:off x="1554480" y="3877056"/>
+            <a:ext cx="1463040" cy="310896"/>
           </a:xfrm>
           <a:prstGeom prst="roundRect">
             <a:avLst/>
@@ -7022,14 +6932,14 @@
       </p:sp>
       <p:sp>
         <p:nvSpPr>
-          <p:cNvPr id="15" name="TextBox 14"/>
+          <p:cNvPr id="12" name="TextBox 11"/>
           <p:cNvSpPr txBox="1"/>
           <p:nvPr/>
         </p:nvSpPr>
         <p:spPr>
           <a:xfrm>
-            <a:off x="1495044" y="4050791"/>
-            <a:ext cx="1444752" cy="292608"/>
+            <a:off x="1554480" y="3904488"/>
+            <a:ext cx="1463040" cy="310896"/>
           </a:xfrm>
           <a:prstGeom prst="rect">
             <a:avLst/>
@@ -7057,14 +6967,14 @@
       </p:sp>
       <p:sp>
         <p:nvSpPr>
-          <p:cNvPr id="16" name="Rounded Rectangle 15"/>
+          <p:cNvPr id="13" name="Rounded Rectangle 12"/>
           <p:cNvSpPr/>
           <p:nvPr/>
         </p:nvSpPr>
         <p:spPr>
           <a:xfrm>
-            <a:off x="3877056" y="1700784"/>
-            <a:ext cx="2889504" cy="2578608"/>
+            <a:off x="4005072" y="1901952"/>
+            <a:ext cx="2926080" cy="2468880"/>
           </a:xfrm>
           <a:prstGeom prst="roundRect">
             <a:avLst/>
@@ -7102,13 +7012,13 @@
       </p:sp>
       <p:sp>
         <p:nvSpPr>
-          <p:cNvPr id="17" name="Rounded Rectangle 16"/>
+          <p:cNvPr id="14" name="Rounded Rectangle 13"/>
           <p:cNvSpPr/>
           <p:nvPr/>
         </p:nvSpPr>
         <p:spPr>
           <a:xfrm>
-            <a:off x="4096512" y="1865376"/>
+            <a:off x="4224528" y="2066544"/>
             <a:ext cx="1078992" cy="310896"/>
           </a:xfrm>
           <a:prstGeom prst="roundRect">
@@ -7147,13 +7057,13 @@
       </p:sp>
       <p:sp>
         <p:nvSpPr>
-          <p:cNvPr id="18" name="TextBox 17"/>
+          <p:cNvPr id="15" name="TextBox 14"/>
           <p:cNvSpPr txBox="1"/>
           <p:nvPr/>
         </p:nvSpPr>
         <p:spPr>
           <a:xfrm>
-            <a:off x="4096512" y="1892808"/>
+            <a:off x="4224528" y="2093976"/>
             <a:ext cx="1078992" cy="310896"/>
           </a:xfrm>
           <a:prstGeom prst="rect">
@@ -7182,14 +7092,14 @@
       </p:sp>
       <p:sp>
         <p:nvSpPr>
-          <p:cNvPr id="19" name="TextBox 18"/>
+          <p:cNvPr id="16" name="TextBox 15"/>
           <p:cNvSpPr txBox="1"/>
           <p:nvPr/>
         </p:nvSpPr>
         <p:spPr>
           <a:xfrm>
-            <a:off x="4096512" y="2231136"/>
-            <a:ext cx="2450592" cy="512064"/>
+            <a:off x="4224528" y="2468880"/>
+            <a:ext cx="2487168" cy="365760"/>
           </a:xfrm>
           <a:prstGeom prst="rect">
             <a:avLst/>
@@ -7217,14 +7127,14 @@
       </p:sp>
       <p:sp>
         <p:nvSpPr>
-          <p:cNvPr id="20" name="TextBox 19"/>
+          <p:cNvPr id="17" name="TextBox 16"/>
           <p:cNvSpPr txBox="1"/>
           <p:nvPr/>
         </p:nvSpPr>
         <p:spPr>
           <a:xfrm>
-            <a:off x="4096512" y="2743199"/>
-            <a:ext cx="2450592" cy="219456"/>
+            <a:off x="4224528" y="2889504"/>
+            <a:ext cx="2487168" cy="219456"/>
           </a:xfrm>
           <a:prstGeom prst="rect">
             <a:avLst/>
@@ -7252,14 +7162,14 @@
       </p:sp>
       <p:sp>
         <p:nvSpPr>
-          <p:cNvPr id="21" name="TextBox 20"/>
+          <p:cNvPr id="18" name="TextBox 17"/>
           <p:cNvSpPr txBox="1"/>
           <p:nvPr/>
         </p:nvSpPr>
         <p:spPr>
           <a:xfrm>
-            <a:off x="4133088" y="3054096"/>
-            <a:ext cx="2377440" cy="402336"/>
+            <a:off x="4315968" y="3291840"/>
+            <a:ext cx="2304288" cy="475488"/>
           </a:xfrm>
           <a:prstGeom prst="rect">
             <a:avLst/>
@@ -7288,14 +7198,14 @@
       </p:sp>
       <p:sp>
         <p:nvSpPr>
-          <p:cNvPr id="22" name="Rounded Rectangle 21"/>
+          <p:cNvPr id="19" name="Rounded Rectangle 18"/>
           <p:cNvSpPr/>
           <p:nvPr/>
         </p:nvSpPr>
         <p:spPr>
           <a:xfrm>
-            <a:off x="4599432" y="3913632"/>
-            <a:ext cx="1444752" cy="292608"/>
+            <a:off x="4736592" y="3877056"/>
+            <a:ext cx="1463040" cy="310896"/>
           </a:xfrm>
           <a:prstGeom prst="roundRect">
             <a:avLst/>
@@ -7333,14 +7243,14 @@
       </p:sp>
       <p:sp>
         <p:nvSpPr>
-          <p:cNvPr id="23" name="TextBox 22"/>
+          <p:cNvPr id="20" name="TextBox 19"/>
           <p:cNvSpPr txBox="1"/>
           <p:nvPr/>
         </p:nvSpPr>
         <p:spPr>
           <a:xfrm>
-            <a:off x="4599432" y="3941064"/>
-            <a:ext cx="1444752" cy="292608"/>
+            <a:off x="4736592" y="3904488"/>
+            <a:ext cx="1463040" cy="310896"/>
           </a:xfrm>
           <a:prstGeom prst="rect">
             <a:avLst/>
@@ -7368,14 +7278,14 @@
       </p:sp>
       <p:sp>
         <p:nvSpPr>
-          <p:cNvPr id="24" name="Rounded Rectangle 23"/>
+          <p:cNvPr id="21" name="Rounded Rectangle 20"/>
           <p:cNvSpPr/>
           <p:nvPr/>
         </p:nvSpPr>
         <p:spPr>
           <a:xfrm>
-            <a:off x="7150608" y="1298448"/>
-            <a:ext cx="3401568" cy="2944368"/>
+            <a:off x="7187184" y="1901952"/>
+            <a:ext cx="3291840" cy="2468880"/>
           </a:xfrm>
           <a:prstGeom prst="roundRect">
             <a:avLst/>
@@ -7413,13 +7323,13 @@
       </p:sp>
       <p:sp>
         <p:nvSpPr>
-          <p:cNvPr id="25" name="Rounded Rectangle 24"/>
+          <p:cNvPr id="22" name="Rounded Rectangle 21"/>
           <p:cNvSpPr/>
           <p:nvPr/>
         </p:nvSpPr>
         <p:spPr>
           <a:xfrm>
-            <a:off x="7370064" y="1463040"/>
+            <a:off x="7406640" y="2066544"/>
             <a:ext cx="1078992" cy="310896"/>
           </a:xfrm>
           <a:prstGeom prst="roundRect">
@@ -7458,13 +7368,13 @@
       </p:sp>
       <p:sp>
         <p:nvSpPr>
-          <p:cNvPr id="26" name="TextBox 25"/>
+          <p:cNvPr id="23" name="TextBox 22"/>
           <p:cNvSpPr txBox="1"/>
           <p:nvPr/>
         </p:nvSpPr>
         <p:spPr>
           <a:xfrm>
-            <a:off x="7370064" y="1490472"/>
+            <a:off x="7406640" y="2093976"/>
             <a:ext cx="1078992" cy="310896"/>
           </a:xfrm>
           <a:prstGeom prst="rect">
@@ -7493,14 +7403,14 @@
       </p:sp>
       <p:sp>
         <p:nvSpPr>
-          <p:cNvPr id="27" name="TextBox 26"/>
+          <p:cNvPr id="24" name="TextBox 23"/>
           <p:cNvSpPr txBox="1"/>
           <p:nvPr/>
         </p:nvSpPr>
         <p:spPr>
           <a:xfrm>
-            <a:off x="7370064" y="1828800"/>
-            <a:ext cx="2962656" cy="512064"/>
+            <a:off x="7406640" y="2468880"/>
+            <a:ext cx="2852928" cy="365760"/>
           </a:xfrm>
           <a:prstGeom prst="rect">
             <a:avLst/>
@@ -7515,28 +7425,27 @@
           <a:p>
             <a:pPr algn="ctr"/>
             <a:r>
-              <a:rPr sz="2000" b="1">
+              <a:rPr sz="1900" b="1">
                 <a:solidFill>
                   <a:srgbClr val="215472"/>
                 </a:solidFill>
                 <a:latin typeface="Aptos"/>
               </a:rPr>
-              <a:t>Agent
-multi-skill</a:t>
-            </a:r>
-          </a:p>
-        </p:txBody>
-      </p:sp>
-      <p:sp>
-        <p:nvSpPr>
-          <p:cNvPr id="28" name="TextBox 27"/>
+              <a:t>Agent multi-skill</a:t>
+            </a:r>
+          </a:p>
+        </p:txBody>
+      </p:sp>
+      <p:sp>
+        <p:nvSpPr>
+          <p:cNvPr id="25" name="TextBox 24"/>
           <p:cNvSpPr txBox="1"/>
           <p:nvPr/>
         </p:nvSpPr>
         <p:spPr>
           <a:xfrm>
-            <a:off x="7370064" y="2340863"/>
-            <a:ext cx="2962656" cy="219456"/>
+            <a:off x="7406640" y="2889504"/>
+            <a:ext cx="2852928" cy="219456"/>
           </a:xfrm>
           <a:prstGeom prst="rect">
             <a:avLst/>
@@ -7564,14 +7473,14 @@
       </p:sp>
       <p:sp>
         <p:nvSpPr>
-          <p:cNvPr id="29" name="TextBox 28"/>
+          <p:cNvPr id="26" name="TextBox 25"/>
           <p:cNvSpPr txBox="1"/>
           <p:nvPr/>
         </p:nvSpPr>
         <p:spPr>
           <a:xfrm>
-            <a:off x="7406640" y="2670048"/>
-            <a:ext cx="2889504" cy="402336"/>
+            <a:off x="7498080" y="3291840"/>
+            <a:ext cx="2670048" cy="475488"/>
           </a:xfrm>
           <a:prstGeom prst="rect">
             <a:avLst/>
@@ -7600,14 +7509,14 @@
       </p:sp>
       <p:sp>
         <p:nvSpPr>
-          <p:cNvPr id="30" name="Rounded Rectangle 29"/>
+          <p:cNvPr id="27" name="Rounded Rectangle 26"/>
           <p:cNvSpPr/>
           <p:nvPr/>
         </p:nvSpPr>
         <p:spPr>
           <a:xfrm>
-            <a:off x="8129016" y="3877056"/>
-            <a:ext cx="1444752" cy="292608"/>
+            <a:off x="8101584" y="3877056"/>
+            <a:ext cx="1463040" cy="310896"/>
           </a:xfrm>
           <a:prstGeom prst="roundRect">
             <a:avLst/>
@@ -7645,14 +7554,14 @@
       </p:sp>
       <p:sp>
         <p:nvSpPr>
-          <p:cNvPr id="31" name="TextBox 30"/>
+          <p:cNvPr id="28" name="TextBox 27"/>
           <p:cNvSpPr txBox="1"/>
           <p:nvPr/>
         </p:nvSpPr>
         <p:spPr>
           <a:xfrm>
-            <a:off x="8129016" y="3904488"/>
-            <a:ext cx="1444752" cy="292608"/>
+            <a:off x="8101584" y="3904488"/>
+            <a:ext cx="1463040" cy="310896"/>
           </a:xfrm>
           <a:prstGeom prst="rect">
             <a:avLst/>
@@ -7680,13 +7589,13 @@
       </p:sp>
       <p:sp>
         <p:nvSpPr>
-          <p:cNvPr id="32" name="Chevron 31"/>
+          <p:cNvPr id="29" name="Chevron 28"/>
           <p:cNvSpPr/>
           <p:nvPr/>
         </p:nvSpPr>
         <p:spPr>
           <a:xfrm>
-            <a:off x="1371600" y="4663440"/>
+            <a:off x="1371600" y="4736592"/>
             <a:ext cx="9052560" cy="384048"/>
           </a:xfrm>
           <a:prstGeom prst="chevron">
@@ -7723,13 +7632,13 @@
       </p:sp>
       <p:sp>
         <p:nvSpPr>
-          <p:cNvPr id="33" name="TextBox 32"/>
+          <p:cNvPr id="30" name="TextBox 29"/>
           <p:cNvSpPr txBox="1"/>
           <p:nvPr/>
         </p:nvSpPr>
         <p:spPr>
           <a:xfrm>
-            <a:off x="1417320" y="5065776"/>
+            <a:off x="1417320" y="5157216"/>
             <a:ext cx="8961120" cy="438912"/>
           </a:xfrm>
           <a:prstGeom prst="rect">
@@ -8121,8 +8030,9 @@
                 </a:solidFill>
                 <a:latin typeface="Aptos"/>
               </a:rPr>
-              <a:t>prompt + AGENTS.md
-+ skills du repo</a:t>
+              <a:t>prompt
+AGENTS.md
+skills du repo</a:t>
             </a:r>
           </a:p>
         </p:txBody>
@@ -8337,8 +8247,8 @@
         </p:nvSpPr>
         <p:spPr>
           <a:xfrm>
-            <a:off x="914400" y="4617720"/>
-            <a:ext cx="10058400" cy="822960"/>
+            <a:off x="914400" y="4608576"/>
+            <a:ext cx="10058400" cy="768096"/>
           </a:xfrm>
           <a:prstGeom prst="roundRect">
             <a:avLst/>
@@ -8383,7 +8293,7 @@
         <p:spPr>
           <a:xfrm>
             <a:off x="1143000" y="4791456"/>
-            <a:ext cx="9601200" cy="420624"/>
+            <a:ext cx="9601200" cy="310896"/>
           </a:xfrm>
           <a:prstGeom prst="rect">
             <a:avLst/>
@@ -8398,7 +8308,7 @@
           <a:p>
             <a:pPr algn="ctr"/>
             <a:r>
-              <a:rPr sz="1800" b="1">
+              <a:rPr sz="1700" b="1">
                 <a:solidFill>
                   <a:srgbClr val="BF5A24"/>
                 </a:solidFill>
@@ -8417,8 +8327,8 @@
         </p:nvSpPr>
         <p:spPr>
           <a:xfrm>
-            <a:off x="914400" y="5559552"/>
-            <a:ext cx="10058400" cy="640080"/>
+            <a:off x="914400" y="5486400"/>
+            <a:ext cx="10058400" cy="676656"/>
           </a:xfrm>
           <a:prstGeom prst="roundRect">
             <a:avLst/>
@@ -8462,8 +8372,8 @@
         </p:nvSpPr>
         <p:spPr>
           <a:xfrm>
-            <a:off x="1188720" y="5705856"/>
-            <a:ext cx="9509760" cy="237744"/>
+            <a:off x="1188720" y="5650992"/>
+            <a:ext cx="9509760" cy="256032"/>
           </a:xfrm>
           <a:prstGeom prst="rect">
             <a:avLst/>
@@ -8636,8 +8546,8 @@
         </p:nvSpPr>
         <p:spPr>
           <a:xfrm>
-            <a:off x="804672" y="2331720"/>
-            <a:ext cx="2212848" cy="1225296"/>
+            <a:off x="786384" y="2359152"/>
+            <a:ext cx="2267712" cy="1170432"/>
           </a:xfrm>
           <a:prstGeom prst="roundRect">
             <a:avLst/>
@@ -8681,7 +8591,7 @@
         </p:nvSpPr>
         <p:spPr>
           <a:xfrm>
-            <a:off x="1682496" y="1956816"/>
+            <a:off x="1700784" y="1993392"/>
             <a:ext cx="566928" cy="329184"/>
           </a:xfrm>
           <a:prstGeom prst="roundRect">
@@ -8726,7 +8636,7 @@
         </p:nvSpPr>
         <p:spPr>
           <a:xfrm>
-            <a:off x="1682496" y="1984248"/>
+            <a:off x="1700784" y="2020824"/>
             <a:ext cx="566928" cy="329184"/>
           </a:xfrm>
           <a:prstGeom prst="rect">
@@ -8761,8 +8671,8 @@
         </p:nvSpPr>
         <p:spPr>
           <a:xfrm>
-            <a:off x="950976" y="2770632"/>
-            <a:ext cx="2029968" cy="310896"/>
+            <a:off x="932688" y="2788920"/>
+            <a:ext cx="2066543" cy="310896"/>
           </a:xfrm>
           <a:prstGeom prst="rect">
             <a:avLst/>
@@ -8796,8 +8706,8 @@
         </p:nvSpPr>
         <p:spPr>
           <a:xfrm>
-            <a:off x="3172968" y="2816352"/>
-            <a:ext cx="310896" cy="219456"/>
+            <a:off x="3227832" y="2852928"/>
+            <a:ext cx="274320" cy="201168"/>
           </a:xfrm>
           <a:prstGeom prst="chevron">
             <a:avLst/>
@@ -8839,8 +8749,8 @@
         </p:nvSpPr>
         <p:spPr>
           <a:xfrm>
-            <a:off x="3547872" y="2331720"/>
-            <a:ext cx="2212848" cy="1225296"/>
+            <a:off x="3575303" y="2359152"/>
+            <a:ext cx="2267712" cy="1170432"/>
           </a:xfrm>
           <a:prstGeom prst="roundRect">
             <a:avLst/>
@@ -8884,7 +8794,7 @@
         </p:nvSpPr>
         <p:spPr>
           <a:xfrm>
-            <a:off x="4425696" y="1956816"/>
+            <a:off x="4489703" y="1993392"/>
             <a:ext cx="566928" cy="329184"/>
           </a:xfrm>
           <a:prstGeom prst="roundRect">
@@ -8929,7 +8839,7 @@
         </p:nvSpPr>
         <p:spPr>
           <a:xfrm>
-            <a:off x="4425696" y="1984248"/>
+            <a:off x="4489703" y="2020824"/>
             <a:ext cx="566928" cy="329184"/>
           </a:xfrm>
           <a:prstGeom prst="rect">
@@ -8964,8 +8874,8 @@
         </p:nvSpPr>
         <p:spPr>
           <a:xfrm>
-            <a:off x="3694176" y="2770632"/>
-            <a:ext cx="2029968" cy="310896"/>
+            <a:off x="3721607" y="2788920"/>
+            <a:ext cx="2066543" cy="310896"/>
           </a:xfrm>
           <a:prstGeom prst="rect">
             <a:avLst/>
@@ -8999,8 +8909,8 @@
         </p:nvSpPr>
         <p:spPr>
           <a:xfrm>
-            <a:off x="5916168" y="2816352"/>
-            <a:ext cx="310896" cy="219456"/>
+            <a:off x="6016752" y="2852928"/>
+            <a:ext cx="274320" cy="201168"/>
           </a:xfrm>
           <a:prstGeom prst="chevron">
             <a:avLst/>
@@ -9042,8 +8952,8 @@
         </p:nvSpPr>
         <p:spPr>
           <a:xfrm>
-            <a:off x="6291072" y="2331720"/>
-            <a:ext cx="2212848" cy="1225296"/>
+            <a:off x="6364224" y="2359152"/>
+            <a:ext cx="2267712" cy="1170432"/>
           </a:xfrm>
           <a:prstGeom prst="roundRect">
             <a:avLst/>
@@ -9087,7 +8997,7 @@
         </p:nvSpPr>
         <p:spPr>
           <a:xfrm>
-            <a:off x="7168896" y="1956816"/>
+            <a:off x="7278624" y="1993392"/>
             <a:ext cx="566928" cy="329184"/>
           </a:xfrm>
           <a:prstGeom prst="roundRect">
@@ -9132,7 +9042,7 @@
         </p:nvSpPr>
         <p:spPr>
           <a:xfrm>
-            <a:off x="7168896" y="1984248"/>
+            <a:off x="7278624" y="2020824"/>
             <a:ext cx="566928" cy="329184"/>
           </a:xfrm>
           <a:prstGeom prst="rect">
@@ -9167,8 +9077,8 @@
         </p:nvSpPr>
         <p:spPr>
           <a:xfrm>
-            <a:off x="6437376" y="2770632"/>
-            <a:ext cx="2029968" cy="310896"/>
+            <a:off x="6510528" y="2788920"/>
+            <a:ext cx="2066543" cy="310896"/>
           </a:xfrm>
           <a:prstGeom prst="rect">
             <a:avLst/>
@@ -9202,8 +9112,8 @@
         </p:nvSpPr>
         <p:spPr>
           <a:xfrm>
-            <a:off x="8659368" y="2816352"/>
-            <a:ext cx="310896" cy="219456"/>
+            <a:off x="8805672" y="2852928"/>
+            <a:ext cx="274320" cy="201168"/>
           </a:xfrm>
           <a:prstGeom prst="chevron">
             <a:avLst/>
@@ -9245,8 +9155,8 @@
         </p:nvSpPr>
         <p:spPr>
           <a:xfrm>
-            <a:off x="9034272" y="2331720"/>
-            <a:ext cx="2212848" cy="1225296"/>
+            <a:off x="9153143" y="2359152"/>
+            <a:ext cx="2267712" cy="1170432"/>
           </a:xfrm>
           <a:prstGeom prst="roundRect">
             <a:avLst/>
@@ -9290,7 +9200,7 @@
         </p:nvSpPr>
         <p:spPr>
           <a:xfrm>
-            <a:off x="9912096" y="1956816"/>
+            <a:off x="10067543" y="1993392"/>
             <a:ext cx="566928" cy="329184"/>
           </a:xfrm>
           <a:prstGeom prst="roundRect">
@@ -9335,7 +9245,7 @@
         </p:nvSpPr>
         <p:spPr>
           <a:xfrm>
-            <a:off x="9912096" y="1984248"/>
+            <a:off x="10067543" y="2020824"/>
             <a:ext cx="566928" cy="329184"/>
           </a:xfrm>
           <a:prstGeom prst="rect">
@@ -9370,8 +9280,8 @@
         </p:nvSpPr>
         <p:spPr>
           <a:xfrm>
-            <a:off x="9180576" y="2770632"/>
-            <a:ext cx="2029968" cy="310896"/>
+            <a:off x="9299447" y="2788920"/>
+            <a:ext cx="2066543" cy="310896"/>
           </a:xfrm>
           <a:prstGeom prst="rect">
             <a:avLst/>
@@ -9405,8 +9315,8 @@
         </p:nvSpPr>
         <p:spPr>
           <a:xfrm>
-            <a:off x="1097280" y="4572000"/>
-            <a:ext cx="9875520" cy="786384"/>
+            <a:off x="1051560" y="4590288"/>
+            <a:ext cx="10012680" cy="749808"/>
           </a:xfrm>
           <a:prstGeom prst="roundRect">
             <a:avLst/>
@@ -9450,8 +9360,8 @@
         </p:nvSpPr>
         <p:spPr>
           <a:xfrm>
-            <a:off x="1325880" y="4818888"/>
-            <a:ext cx="9326880" cy="219456"/>
+            <a:off x="1298448" y="4800600"/>
+            <a:ext cx="9509760" cy="310896"/>
           </a:xfrm>
           <a:prstGeom prst="rect">
             <a:avLst/>
@@ -9466,7 +9376,7 @@
           <a:p>
             <a:pPr algn="ctr"/>
             <a:r>
-              <a:rPr sz="1900" b="1">
+              <a:rPr sz="1800" b="1">
                 <a:solidFill>
                   <a:srgbClr val="BF5A24"/>
                 </a:solidFill>

</xml_diff>

<commit_message>
docs(slides): normalize prompt deck arrows
</commit_message>
<xml_diff>
--- a/docs/source/TP Prompt Ingénierie.pptx
+++ b/docs/source/TP Prompt Ingénierie.pptx
@@ -3990,8 +3990,8 @@
         </p:nvSpPr>
         <p:spPr>
           <a:xfrm>
-            <a:off x="5724144" y="3611880"/>
-            <a:ext cx="237744" cy="146304"/>
+            <a:off x="5742432" y="3657600"/>
+            <a:ext cx="201168" cy="128016"/>
           </a:xfrm>
           <a:prstGeom prst="chevron">
             <a:avLst/>
@@ -4033,8 +4033,8 @@
         </p:nvSpPr>
         <p:spPr>
           <a:xfrm rot="5400000">
-            <a:off x="6793992" y="3941063"/>
-            <a:ext cx="146304" cy="237744"/>
+            <a:off x="6803136" y="3977639"/>
+            <a:ext cx="128016" cy="201168"/>
           </a:xfrm>
           <a:prstGeom prst="chevron">
             <a:avLst/>
@@ -4076,8 +4076,8 @@
         </p:nvSpPr>
         <p:spPr>
           <a:xfrm rot="10800000">
-            <a:off x="5724144" y="4672584"/>
-            <a:ext cx="237744" cy="146304"/>
+            <a:off x="5742432" y="4718304"/>
+            <a:ext cx="201168" cy="128016"/>
           </a:xfrm>
           <a:prstGeom prst="chevron">
             <a:avLst/>
@@ -4119,8 +4119,8 @@
         </p:nvSpPr>
         <p:spPr>
           <a:xfrm rot="16200000">
-            <a:off x="4910328" y="3968496"/>
-            <a:ext cx="146304" cy="237744"/>
+            <a:off x="4956048" y="3977639"/>
+            <a:ext cx="128016" cy="201168"/>
           </a:xfrm>
           <a:prstGeom prst="chevron">
             <a:avLst/>
@@ -4678,8 +4678,8 @@
         </p:nvSpPr>
         <p:spPr>
           <a:xfrm>
-            <a:off x="3255264" y="3767328"/>
-            <a:ext cx="310896" cy="256032"/>
+            <a:off x="3346704" y="3803904"/>
+            <a:ext cx="219456" cy="201168"/>
           </a:xfrm>
           <a:prstGeom prst="chevron">
             <a:avLst/>
@@ -4721,8 +4721,8 @@
         </p:nvSpPr>
         <p:spPr>
           <a:xfrm>
-            <a:off x="8174736" y="3767328"/>
-            <a:ext cx="310896" cy="256032"/>
+            <a:off x="8211312" y="3803904"/>
+            <a:ext cx="219456" cy="201168"/>
           </a:xfrm>
           <a:prstGeom prst="chevron">
             <a:avLst/>
@@ -6164,8 +6164,8 @@
         </p:nvSpPr>
         <p:spPr>
           <a:xfrm>
-            <a:off x="3017520" y="2999232"/>
-            <a:ext cx="438912" cy="365760"/>
+            <a:off x="3310128" y="3072384"/>
+            <a:ext cx="274320" cy="256032"/>
           </a:xfrm>
           <a:prstGeom prst="chevron">
             <a:avLst/>
@@ -6207,8 +6207,8 @@
         </p:nvSpPr>
         <p:spPr>
           <a:xfrm>
-            <a:off x="5870448" y="2999232"/>
-            <a:ext cx="438912" cy="365760"/>
+            <a:off x="6163056" y="3072384"/>
+            <a:ext cx="274320" cy="256032"/>
           </a:xfrm>
           <a:prstGeom prst="chevron">
             <a:avLst/>
@@ -6250,8 +6250,8 @@
         </p:nvSpPr>
         <p:spPr>
           <a:xfrm>
-            <a:off x="8723376" y="2999232"/>
-            <a:ext cx="438912" cy="365760"/>
+            <a:off x="9015984" y="3072384"/>
+            <a:ext cx="274320" cy="256032"/>
           </a:xfrm>
           <a:prstGeom prst="chevron">
             <a:avLst/>
@@ -11064,8 +11064,8 @@
         </p:nvSpPr>
         <p:spPr>
           <a:xfrm>
-            <a:off x="1828800" y="4992624"/>
-            <a:ext cx="8549640" cy="694944"/>
+            <a:off x="868680" y="4992624"/>
+            <a:ext cx="10469880" cy="694944"/>
           </a:xfrm>
           <a:prstGeom prst="roundRect">
             <a:avLst/>
@@ -11109,8 +11109,8 @@
         </p:nvSpPr>
         <p:spPr>
           <a:xfrm>
-            <a:off x="2011680" y="5230368"/>
-            <a:ext cx="8183879" cy="256032"/>
+            <a:off x="1078992" y="5230368"/>
+            <a:ext cx="10058400" cy="219456"/>
           </a:xfrm>
           <a:prstGeom prst="rect">
             <a:avLst/>
@@ -11125,7 +11125,7 @@
           <a:p>
             <a:pPr algn="ctr"/>
             <a:r>
-              <a:rPr sz="2000" b="1">
+              <a:rPr sz="1600" b="1">
                 <a:solidFill>
                   <a:srgbClr val="215472"/>
                 </a:solidFill>

</xml_diff>

<commit_message>
test: expand coverage and refine prompt decks
</commit_message>
<xml_diff>
--- a/docs/source/TP Prompt Ingénierie.pptx
+++ b/docs/source/TP Prompt Ingénierie.pptx
@@ -4,19 +4,22 @@
   <p:sldMasterIdLst>
     <p:sldMasterId id="2147483648" r:id="rId1"/>
   </p:sldMasterIdLst>
+  <p:notesMasterIdLst>
+    <p:notesMasterId r:id="rId12"/>
+  </p:notesMasterIdLst>
   <p:sldIdLst>
-    <p:sldId id="256" r:id="rId7"/>
-    <p:sldId id="257" r:id="rId8"/>
-    <p:sldId id="258" r:id="rId9"/>
-    <p:sldId id="259" r:id="rId10"/>
-    <p:sldId id="260" r:id="rId11"/>
-    <p:sldId id="261" r:id="rId12"/>
-    <p:sldId id="262" r:id="rId13"/>
-    <p:sldId id="263" r:id="rId14"/>
-    <p:sldId id="264" r:id="rId15"/>
-    <p:sldId id="265" r:id="rId16"/>
+    <p:sldId id="256" r:id="rId2"/>
+    <p:sldId id="257" r:id="rId3"/>
+    <p:sldId id="258" r:id="rId4"/>
+    <p:sldId id="259" r:id="rId5"/>
+    <p:sldId id="260" r:id="rId6"/>
+    <p:sldId id="261" r:id="rId7"/>
+    <p:sldId id="262" r:id="rId8"/>
+    <p:sldId id="263" r:id="rId9"/>
+    <p:sldId id="264" r:id="rId10"/>
+    <p:sldId id="265" r:id="rId11"/>
   </p:sldIdLst>
-  <p:sldSz cx="12191695" cy="6858000" type="screen4x3"/>
+  <p:sldSz cx="12192000" cy="6858000"/>
   <p:notesSz cx="6858000" cy="9144000"/>
   <p:defaultTextStyle>
     <a:defPPr>
@@ -113,7 +116,457 @@
       </a:defRPr>
     </a:lvl9pPr>
   </p:defaultTextStyle>
+  <p:extLst>
+    <p:ext uri="{EFAFB233-063F-42B5-8137-9DF3F51BA10A}">
+      <p15:sldGuideLst xmlns:p15="http://schemas.microsoft.com/office/powerpoint/2012/main">
+        <p15:guide id="1" orient="horz" pos="2160">
+          <p15:clr>
+            <a:srgbClr val="A4A3A4"/>
+          </p15:clr>
+        </p15:guide>
+        <p15:guide id="2" pos="2880">
+          <p15:clr>
+            <a:srgbClr val="A4A3A4"/>
+          </p15:clr>
+        </p15:guide>
+      </p15:sldGuideLst>
+    </p:ext>
+  </p:extLst>
 </p:presentation>
+</file>
+
+<file path=ppt/notesMasters/notesMaster1.xml><?xml version="1.0" encoding="utf-8"?>
+<p:notesMaster xmlns:a="http://schemas.openxmlformats.org/drawingml/2006/main" xmlns:r="http://schemas.openxmlformats.org/officeDocument/2006/relationships" xmlns:p="http://schemas.openxmlformats.org/presentationml/2006/main">
+  <p:cSld>
+    <p:bg>
+      <p:bgRef idx="1001">
+        <a:schemeClr val="bg1"/>
+      </p:bgRef>
+    </p:bg>
+    <p:spTree>
+      <p:nvGrpSpPr>
+        <p:cNvPr id="1" name=""/>
+        <p:cNvGrpSpPr/>
+        <p:nvPr/>
+      </p:nvGrpSpPr>
+      <p:grpSpPr>
+        <a:xfrm>
+          <a:off x="0" y="0"/>
+          <a:ext cx="0" cy="0"/>
+          <a:chOff x="0" y="0"/>
+          <a:chExt cx="0" cy="0"/>
+        </a:xfrm>
+      </p:grpSpPr>
+      <p:sp>
+        <p:nvSpPr>
+          <p:cNvPr id="2" name="Header Placeholder 1"/>
+          <p:cNvSpPr>
+            <a:spLocks noGrp="1"/>
+          </p:cNvSpPr>
+          <p:nvPr>
+            <p:ph type="hdr" sz="quarter"/>
+          </p:nvPr>
+        </p:nvSpPr>
+        <p:spPr>
+          <a:xfrm>
+            <a:off x="0" y="0"/>
+            <a:ext cx="2971800" cy="458788"/>
+          </a:xfrm>
+          <a:prstGeom prst="rect">
+            <a:avLst/>
+          </a:prstGeom>
+        </p:spPr>
+        <p:txBody>
+          <a:bodyPr vert="horz" lIns="91440" tIns="45720" rIns="91440" bIns="45720" rtlCol="0"/>
+          <a:lstStyle>
+            <a:lvl1pPr algn="l">
+              <a:defRPr sz="1200"/>
+            </a:lvl1pPr>
+          </a:lstStyle>
+          <a:p>
+            <a:endParaRPr lang="fr-FR"/>
+          </a:p>
+        </p:txBody>
+      </p:sp>
+      <p:sp>
+        <p:nvSpPr>
+          <p:cNvPr id="3" name="Date Placeholder 2"/>
+          <p:cNvSpPr>
+            <a:spLocks noGrp="1"/>
+          </p:cNvSpPr>
+          <p:nvPr>
+            <p:ph type="dt" idx="1"/>
+          </p:nvPr>
+        </p:nvSpPr>
+        <p:spPr>
+          <a:xfrm>
+            <a:off x="3884613" y="0"/>
+            <a:ext cx="2971800" cy="458788"/>
+          </a:xfrm>
+          <a:prstGeom prst="rect">
+            <a:avLst/>
+          </a:prstGeom>
+        </p:spPr>
+        <p:txBody>
+          <a:bodyPr vert="horz" lIns="91440" tIns="45720" rIns="91440" bIns="45720" rtlCol="0"/>
+          <a:lstStyle>
+            <a:lvl1pPr algn="r">
+              <a:defRPr sz="1200"/>
+            </a:lvl1pPr>
+          </a:lstStyle>
+          <a:p>
+            <a:fld id="{26361D52-3F77-7740-AEA3-A94937B14596}" type="datetimeFigureOut">
+              <a:rPr lang="fr-FR" smtClean="0"/>
+              <a:t>13/04/2026</a:t>
+            </a:fld>
+            <a:endParaRPr lang="fr-FR"/>
+          </a:p>
+        </p:txBody>
+      </p:sp>
+      <p:sp>
+        <p:nvSpPr>
+          <p:cNvPr id="4" name="Slide Image Placeholder 3"/>
+          <p:cNvSpPr>
+            <a:spLocks noGrp="1" noRot="1" noChangeAspect="1"/>
+          </p:cNvSpPr>
+          <p:nvPr>
+            <p:ph type="sldImg" idx="2"/>
+          </p:nvPr>
+        </p:nvSpPr>
+        <p:spPr>
+          <a:xfrm>
+            <a:off x="685800" y="1143000"/>
+            <a:ext cx="5486400" cy="3086100"/>
+          </a:xfrm>
+          <a:prstGeom prst="rect">
+            <a:avLst/>
+          </a:prstGeom>
+          <a:noFill/>
+          <a:ln w="12700">
+            <a:solidFill>
+              <a:prstClr val="black"/>
+            </a:solidFill>
+          </a:ln>
+        </p:spPr>
+        <p:txBody>
+          <a:bodyPr vert="horz" lIns="91440" tIns="45720" rIns="91440" bIns="45720" rtlCol="0" anchor="ctr"/>
+          <a:lstStyle/>
+          <a:p>
+            <a:endParaRPr lang="fr-FR"/>
+          </a:p>
+        </p:txBody>
+      </p:sp>
+      <p:sp>
+        <p:nvSpPr>
+          <p:cNvPr id="5" name="Notes Placeholder 4"/>
+          <p:cNvSpPr>
+            <a:spLocks noGrp="1"/>
+          </p:cNvSpPr>
+          <p:nvPr>
+            <p:ph type="body" sz="quarter" idx="3"/>
+          </p:nvPr>
+        </p:nvSpPr>
+        <p:spPr>
+          <a:xfrm>
+            <a:off x="685800" y="4400550"/>
+            <a:ext cx="5486400" cy="3600450"/>
+          </a:xfrm>
+          <a:prstGeom prst="rect">
+            <a:avLst/>
+          </a:prstGeom>
+        </p:spPr>
+        <p:txBody>
+          <a:bodyPr vert="horz" lIns="91440" tIns="45720" rIns="91440" bIns="45720" rtlCol="0"/>
+          <a:lstStyle/>
+          <a:p>
+            <a:pPr lvl="0"/>
+            <a:r>
+              <a:rPr lang="en-GB"/>
+              <a:t>Click to edit Master text styles</a:t>
+            </a:r>
+          </a:p>
+          <a:p>
+            <a:pPr lvl="1"/>
+            <a:r>
+              <a:rPr lang="en-GB"/>
+              <a:t>Second level</a:t>
+            </a:r>
+          </a:p>
+          <a:p>
+            <a:pPr lvl="2"/>
+            <a:r>
+              <a:rPr lang="en-GB"/>
+              <a:t>Third level</a:t>
+            </a:r>
+          </a:p>
+          <a:p>
+            <a:pPr lvl="3"/>
+            <a:r>
+              <a:rPr lang="en-GB"/>
+              <a:t>Fourth level</a:t>
+            </a:r>
+          </a:p>
+          <a:p>
+            <a:pPr lvl="4"/>
+            <a:r>
+              <a:rPr lang="en-GB"/>
+              <a:t>Fifth level</a:t>
+            </a:r>
+            <a:endParaRPr lang="fr-FR"/>
+          </a:p>
+        </p:txBody>
+      </p:sp>
+      <p:sp>
+        <p:nvSpPr>
+          <p:cNvPr id="6" name="Footer Placeholder 5"/>
+          <p:cNvSpPr>
+            <a:spLocks noGrp="1"/>
+          </p:cNvSpPr>
+          <p:nvPr>
+            <p:ph type="ftr" sz="quarter" idx="4"/>
+          </p:nvPr>
+        </p:nvSpPr>
+        <p:spPr>
+          <a:xfrm>
+            <a:off x="0" y="8685213"/>
+            <a:ext cx="2971800" cy="458787"/>
+          </a:xfrm>
+          <a:prstGeom prst="rect">
+            <a:avLst/>
+          </a:prstGeom>
+        </p:spPr>
+        <p:txBody>
+          <a:bodyPr vert="horz" lIns="91440" tIns="45720" rIns="91440" bIns="45720" rtlCol="0" anchor="b"/>
+          <a:lstStyle>
+            <a:lvl1pPr algn="l">
+              <a:defRPr sz="1200"/>
+            </a:lvl1pPr>
+          </a:lstStyle>
+          <a:p>
+            <a:endParaRPr lang="fr-FR"/>
+          </a:p>
+        </p:txBody>
+      </p:sp>
+      <p:sp>
+        <p:nvSpPr>
+          <p:cNvPr id="7" name="Slide Number Placeholder 6"/>
+          <p:cNvSpPr>
+            <a:spLocks noGrp="1"/>
+          </p:cNvSpPr>
+          <p:nvPr>
+            <p:ph type="sldNum" sz="quarter" idx="5"/>
+          </p:nvPr>
+        </p:nvSpPr>
+        <p:spPr>
+          <a:xfrm>
+            <a:off x="3884613" y="8685213"/>
+            <a:ext cx="2971800" cy="458787"/>
+          </a:xfrm>
+          <a:prstGeom prst="rect">
+            <a:avLst/>
+          </a:prstGeom>
+        </p:spPr>
+        <p:txBody>
+          <a:bodyPr vert="horz" lIns="91440" tIns="45720" rIns="91440" bIns="45720" rtlCol="0" anchor="b"/>
+          <a:lstStyle>
+            <a:lvl1pPr algn="r">
+              <a:defRPr sz="1200"/>
+            </a:lvl1pPr>
+          </a:lstStyle>
+          <a:p>
+            <a:fld id="{5A08E842-F3E3-C74A-9F46-D5E8BD4FC3EA}" type="slidenum">
+              <a:rPr lang="fr-FR" smtClean="0"/>
+              <a:t>‹#›</a:t>
+            </a:fld>
+            <a:endParaRPr lang="fr-FR"/>
+          </a:p>
+        </p:txBody>
+      </p:sp>
+    </p:spTree>
+    <p:extLst>
+      <p:ext uri="{BB962C8B-B14F-4D97-AF65-F5344CB8AC3E}">
+        <p14:creationId xmlns:p14="http://schemas.microsoft.com/office/powerpoint/2010/main" val="3248415340"/>
+      </p:ext>
+    </p:extLst>
+  </p:cSld>
+  <p:clrMap bg1="lt1" tx1="dk1" bg2="lt2" tx2="dk2" accent1="accent1" accent2="accent2" accent3="accent3" accent4="accent4" accent5="accent5" accent6="accent6" hlink="hlink" folHlink="folHlink"/>
+  <p:notesStyle>
+    <a:lvl1pPr marL="0" algn="l" defTabSz="914400" rtl="0" eaLnBrk="1" latinLnBrk="0" hangingPunct="1">
+      <a:defRPr sz="1200" kern="1200">
+        <a:solidFill>
+          <a:schemeClr val="tx1"/>
+        </a:solidFill>
+        <a:latin typeface="+mn-lt"/>
+        <a:ea typeface="+mn-ea"/>
+        <a:cs typeface="+mn-cs"/>
+      </a:defRPr>
+    </a:lvl1pPr>
+    <a:lvl2pPr marL="457200" algn="l" defTabSz="914400" rtl="0" eaLnBrk="1" latinLnBrk="0" hangingPunct="1">
+      <a:defRPr sz="1200" kern="1200">
+        <a:solidFill>
+          <a:schemeClr val="tx1"/>
+        </a:solidFill>
+        <a:latin typeface="+mn-lt"/>
+        <a:ea typeface="+mn-ea"/>
+        <a:cs typeface="+mn-cs"/>
+      </a:defRPr>
+    </a:lvl2pPr>
+    <a:lvl3pPr marL="914400" algn="l" defTabSz="914400" rtl="0" eaLnBrk="1" latinLnBrk="0" hangingPunct="1">
+      <a:defRPr sz="1200" kern="1200">
+        <a:solidFill>
+          <a:schemeClr val="tx1"/>
+        </a:solidFill>
+        <a:latin typeface="+mn-lt"/>
+        <a:ea typeface="+mn-ea"/>
+        <a:cs typeface="+mn-cs"/>
+      </a:defRPr>
+    </a:lvl3pPr>
+    <a:lvl4pPr marL="1371600" algn="l" defTabSz="914400" rtl="0" eaLnBrk="1" latinLnBrk="0" hangingPunct="1">
+      <a:defRPr sz="1200" kern="1200">
+        <a:solidFill>
+          <a:schemeClr val="tx1"/>
+        </a:solidFill>
+        <a:latin typeface="+mn-lt"/>
+        <a:ea typeface="+mn-ea"/>
+        <a:cs typeface="+mn-cs"/>
+      </a:defRPr>
+    </a:lvl4pPr>
+    <a:lvl5pPr marL="1828800" algn="l" defTabSz="914400" rtl="0" eaLnBrk="1" latinLnBrk="0" hangingPunct="1">
+      <a:defRPr sz="1200" kern="1200">
+        <a:solidFill>
+          <a:schemeClr val="tx1"/>
+        </a:solidFill>
+        <a:latin typeface="+mn-lt"/>
+        <a:ea typeface="+mn-ea"/>
+        <a:cs typeface="+mn-cs"/>
+      </a:defRPr>
+    </a:lvl5pPr>
+    <a:lvl6pPr marL="2286000" algn="l" defTabSz="914400" rtl="0" eaLnBrk="1" latinLnBrk="0" hangingPunct="1">
+      <a:defRPr sz="1200" kern="1200">
+        <a:solidFill>
+          <a:schemeClr val="tx1"/>
+        </a:solidFill>
+        <a:latin typeface="+mn-lt"/>
+        <a:ea typeface="+mn-ea"/>
+        <a:cs typeface="+mn-cs"/>
+      </a:defRPr>
+    </a:lvl6pPr>
+    <a:lvl7pPr marL="2743200" algn="l" defTabSz="914400" rtl="0" eaLnBrk="1" latinLnBrk="0" hangingPunct="1">
+      <a:defRPr sz="1200" kern="1200">
+        <a:solidFill>
+          <a:schemeClr val="tx1"/>
+        </a:solidFill>
+        <a:latin typeface="+mn-lt"/>
+        <a:ea typeface="+mn-ea"/>
+        <a:cs typeface="+mn-cs"/>
+      </a:defRPr>
+    </a:lvl7pPr>
+    <a:lvl8pPr marL="3200400" algn="l" defTabSz="914400" rtl="0" eaLnBrk="1" latinLnBrk="0" hangingPunct="1">
+      <a:defRPr sz="1200" kern="1200">
+        <a:solidFill>
+          <a:schemeClr val="tx1"/>
+        </a:solidFill>
+        <a:latin typeface="+mn-lt"/>
+        <a:ea typeface="+mn-ea"/>
+        <a:cs typeface="+mn-cs"/>
+      </a:defRPr>
+    </a:lvl8pPr>
+    <a:lvl9pPr marL="3657600" algn="l" defTabSz="914400" rtl="0" eaLnBrk="1" latinLnBrk="0" hangingPunct="1">
+      <a:defRPr sz="1200" kern="1200">
+        <a:solidFill>
+          <a:schemeClr val="tx1"/>
+        </a:solidFill>
+        <a:latin typeface="+mn-lt"/>
+        <a:ea typeface="+mn-ea"/>
+        <a:cs typeface="+mn-cs"/>
+      </a:defRPr>
+    </a:lvl9pPr>
+  </p:notesStyle>
+</p:notesMaster>
+</file>
+
+<file path=ppt/notesSlides/notesSlide1.xml><?xml version="1.0" encoding="utf-8"?>
+<p:notes xmlns:a="http://schemas.openxmlformats.org/drawingml/2006/main" xmlns:r="http://schemas.openxmlformats.org/officeDocument/2006/relationships" xmlns:p="http://schemas.openxmlformats.org/presentationml/2006/main">
+  <p:cSld>
+    <p:spTree>
+      <p:nvGrpSpPr>
+        <p:cNvPr id="1" name=""/>
+        <p:cNvGrpSpPr/>
+        <p:nvPr/>
+      </p:nvGrpSpPr>
+      <p:grpSpPr>
+        <a:xfrm>
+          <a:off x="0" y="0"/>
+          <a:ext cx="0" cy="0"/>
+          <a:chOff x="0" y="0"/>
+          <a:chExt cx="0" cy="0"/>
+        </a:xfrm>
+      </p:grpSpPr>
+      <p:sp>
+        <p:nvSpPr>
+          <p:cNvPr id="2" name="Slide Image Placeholder 1"/>
+          <p:cNvSpPr>
+            <a:spLocks noGrp="1" noRot="1" noChangeAspect="1"/>
+          </p:cNvSpPr>
+          <p:nvPr>
+            <p:ph type="sldImg"/>
+          </p:nvPr>
+        </p:nvSpPr>
+        <p:spPr/>
+      </p:sp>
+      <p:sp>
+        <p:nvSpPr>
+          <p:cNvPr id="3" name="Notes Placeholder 2"/>
+          <p:cNvSpPr>
+            <a:spLocks noGrp="1"/>
+          </p:cNvSpPr>
+          <p:nvPr>
+            <p:ph type="body" idx="1"/>
+          </p:nvPr>
+        </p:nvSpPr>
+        <p:spPr/>
+        <p:txBody>
+          <a:bodyPr/>
+          <a:lstStyle/>
+          <a:p>
+            <a:endParaRPr lang="fr-FR" dirty="0"/>
+          </a:p>
+        </p:txBody>
+      </p:sp>
+      <p:sp>
+        <p:nvSpPr>
+          <p:cNvPr id="4" name="Slide Number Placeholder 3"/>
+          <p:cNvSpPr>
+            <a:spLocks noGrp="1"/>
+          </p:cNvSpPr>
+          <p:nvPr>
+            <p:ph type="sldNum" sz="quarter" idx="5"/>
+          </p:nvPr>
+        </p:nvSpPr>
+        <p:spPr/>
+        <p:txBody>
+          <a:bodyPr/>
+          <a:lstStyle/>
+          <a:p>
+            <a:fld id="{5A08E842-F3E3-C74A-9F46-D5E8BD4FC3EA}" type="slidenum">
+              <a:rPr lang="fr-FR" smtClean="0"/>
+              <a:t>6</a:t>
+            </a:fld>
+            <a:endParaRPr lang="fr-FR"/>
+          </a:p>
+        </p:txBody>
+      </p:sp>
+    </p:spTree>
+    <p:extLst>
+      <p:ext uri="{BB962C8B-B14F-4D97-AF65-F5344CB8AC3E}">
+        <p14:creationId xmlns:p14="http://schemas.microsoft.com/office/powerpoint/2010/main" val="1836134409"/>
+      </p:ext>
+    </p:extLst>
+  </p:cSld>
+  <p:clrMapOvr>
+    <a:masterClrMapping/>
+  </p:clrMapOvr>
+</p:notes>
 </file>
 
 <file path=ppt/slideLayouts/slideLayout1.xml><?xml version="1.0" encoding="utf-8"?>
@@ -154,10 +607,9 @@
           <a:lstStyle/>
           <a:p>
             <a:r>
-              <a:rPr lang="en-US" smtClean="0"/>
+              <a:rPr lang="en-US"/>
               <a:t>Click to edit Master title style</a:t>
             </a:r>
-            <a:endParaRPr lang="en-US"/>
           </a:p>
         </p:txBody>
       </p:sp>
@@ -273,10 +725,9 @@
           </a:lstStyle>
           <a:p>
             <a:r>
-              <a:rPr lang="en-US" smtClean="0"/>
+              <a:rPr lang="en-US"/>
               <a:t>Click to edit Master subtitle style</a:t>
             </a:r>
-            <a:endParaRPr lang="en-US"/>
           </a:p>
         </p:txBody>
       </p:sp>
@@ -297,7 +748,7 @@
           <a:p>
             <a:fld id="{5BCAD085-E8A6-8845-BD4E-CB4CCA059FC4}" type="datetimeFigureOut">
               <a:rPr lang="en-US" smtClean="0"/>
-              <a:t>1/27/13</a:t>
+              <a:t>4/13/26</a:t>
             </a:fld>
             <a:endParaRPr lang="en-US"/>
           </a:p>
@@ -391,10 +842,9 @@
           <a:lstStyle/>
           <a:p>
             <a:r>
-              <a:rPr lang="en-US" smtClean="0"/>
+              <a:rPr lang="en-US"/>
               <a:t>Click to edit Master title style</a:t>
             </a:r>
-            <a:endParaRPr lang="en-US"/>
           </a:p>
         </p:txBody>
       </p:sp>
@@ -415,38 +865,37 @@
           <a:p>
             <a:pPr lvl="0"/>
             <a:r>
-              <a:rPr lang="en-US" smtClean="0"/>
+              <a:rPr lang="en-US"/>
               <a:t>Click to edit Master text styles</a:t>
             </a:r>
           </a:p>
           <a:p>
             <a:pPr lvl="1"/>
             <a:r>
-              <a:rPr lang="en-US" smtClean="0"/>
+              <a:rPr lang="en-US"/>
               <a:t>Second level</a:t>
             </a:r>
           </a:p>
           <a:p>
             <a:pPr lvl="2"/>
             <a:r>
-              <a:rPr lang="en-US" smtClean="0"/>
+              <a:rPr lang="en-US"/>
               <a:t>Third level</a:t>
             </a:r>
           </a:p>
           <a:p>
             <a:pPr lvl="3"/>
             <a:r>
-              <a:rPr lang="en-US" smtClean="0"/>
+              <a:rPr lang="en-US"/>
               <a:t>Fourth level</a:t>
             </a:r>
           </a:p>
           <a:p>
             <a:pPr lvl="4"/>
             <a:r>
-              <a:rPr lang="en-US" smtClean="0"/>
+              <a:rPr lang="en-US"/>
               <a:t>Fifth level</a:t>
             </a:r>
-            <a:endParaRPr lang="en-US"/>
           </a:p>
         </p:txBody>
       </p:sp>
@@ -467,7 +916,7 @@
           <a:p>
             <a:fld id="{5BCAD085-E8A6-8845-BD4E-CB4CCA059FC4}" type="datetimeFigureOut">
               <a:rPr lang="en-US" smtClean="0"/>
-              <a:t>1/27/13</a:t>
+              <a:t>4/13/26</a:t>
             </a:fld>
             <a:endParaRPr lang="en-US"/>
           </a:p>
@@ -566,10 +1015,9 @@
           <a:lstStyle/>
           <a:p>
             <a:r>
-              <a:rPr lang="en-US" smtClean="0"/>
+              <a:rPr lang="en-US"/>
               <a:t>Click to edit Master title style</a:t>
             </a:r>
-            <a:endParaRPr lang="en-US"/>
           </a:p>
         </p:txBody>
       </p:sp>
@@ -595,38 +1043,37 @@
           <a:p>
             <a:pPr lvl="0"/>
             <a:r>
-              <a:rPr lang="en-US" smtClean="0"/>
+              <a:rPr lang="en-US"/>
               <a:t>Click to edit Master text styles</a:t>
             </a:r>
           </a:p>
           <a:p>
             <a:pPr lvl="1"/>
             <a:r>
-              <a:rPr lang="en-US" smtClean="0"/>
+              <a:rPr lang="en-US"/>
               <a:t>Second level</a:t>
             </a:r>
           </a:p>
           <a:p>
             <a:pPr lvl="2"/>
             <a:r>
-              <a:rPr lang="en-US" smtClean="0"/>
+              <a:rPr lang="en-US"/>
               <a:t>Third level</a:t>
             </a:r>
           </a:p>
           <a:p>
             <a:pPr lvl="3"/>
             <a:r>
-              <a:rPr lang="en-US" smtClean="0"/>
+              <a:rPr lang="en-US"/>
               <a:t>Fourth level</a:t>
             </a:r>
           </a:p>
           <a:p>
             <a:pPr lvl="4"/>
             <a:r>
-              <a:rPr lang="en-US" smtClean="0"/>
+              <a:rPr lang="en-US"/>
               <a:t>Fifth level</a:t>
             </a:r>
-            <a:endParaRPr lang="en-US"/>
           </a:p>
         </p:txBody>
       </p:sp>
@@ -647,7 +1094,7 @@
           <a:p>
             <a:fld id="{5BCAD085-E8A6-8845-BD4E-CB4CCA059FC4}" type="datetimeFigureOut">
               <a:rPr lang="en-US" smtClean="0"/>
-              <a:t>1/27/13</a:t>
+              <a:t>4/13/26</a:t>
             </a:fld>
             <a:endParaRPr lang="en-US"/>
           </a:p>
@@ -741,10 +1188,9 @@
           <a:lstStyle/>
           <a:p>
             <a:r>
-              <a:rPr lang="en-US" smtClean="0"/>
+              <a:rPr lang="en-US"/>
               <a:t>Click to edit Master title style</a:t>
             </a:r>
-            <a:endParaRPr lang="en-US"/>
           </a:p>
         </p:txBody>
       </p:sp>
@@ -765,38 +1211,37 @@
           <a:p>
             <a:pPr lvl="0"/>
             <a:r>
-              <a:rPr lang="en-US" smtClean="0"/>
+              <a:rPr lang="en-US"/>
               <a:t>Click to edit Master text styles</a:t>
             </a:r>
           </a:p>
           <a:p>
             <a:pPr lvl="1"/>
             <a:r>
-              <a:rPr lang="en-US" smtClean="0"/>
+              <a:rPr lang="en-US"/>
               <a:t>Second level</a:t>
             </a:r>
           </a:p>
           <a:p>
             <a:pPr lvl="2"/>
             <a:r>
-              <a:rPr lang="en-US" smtClean="0"/>
+              <a:rPr lang="en-US"/>
               <a:t>Third level</a:t>
             </a:r>
           </a:p>
           <a:p>
             <a:pPr lvl="3"/>
             <a:r>
-              <a:rPr lang="en-US" smtClean="0"/>
+              <a:rPr lang="en-US"/>
               <a:t>Fourth level</a:t>
             </a:r>
           </a:p>
           <a:p>
             <a:pPr lvl="4"/>
             <a:r>
-              <a:rPr lang="en-US" smtClean="0"/>
+              <a:rPr lang="en-US"/>
               <a:t>Fifth level</a:t>
             </a:r>
-            <a:endParaRPr lang="en-US"/>
           </a:p>
         </p:txBody>
       </p:sp>
@@ -817,7 +1262,7 @@
           <a:p>
             <a:fld id="{5BCAD085-E8A6-8845-BD4E-CB4CCA059FC4}" type="datetimeFigureOut">
               <a:rPr lang="en-US" smtClean="0"/>
-              <a:t>1/27/13</a:t>
+              <a:t>4/13/26</a:t>
             </a:fld>
             <a:endParaRPr lang="en-US"/>
           </a:p>
@@ -920,10 +1365,9 @@
           </a:lstStyle>
           <a:p>
             <a:r>
-              <a:rPr lang="en-US" smtClean="0"/>
+              <a:rPr lang="en-US"/>
               <a:t>Click to edit Master title style</a:t>
             </a:r>
-            <a:endParaRPr lang="en-US"/>
           </a:p>
         </p:txBody>
       </p:sp>
@@ -1040,7 +1484,7 @@
           <a:p>
             <a:pPr lvl="0"/>
             <a:r>
-              <a:rPr lang="en-US" smtClean="0"/>
+              <a:rPr lang="en-US"/>
               <a:t>Click to edit Master text styles</a:t>
             </a:r>
           </a:p>
@@ -1063,7 +1507,7 @@
           <a:p>
             <a:fld id="{5BCAD085-E8A6-8845-BD4E-CB4CCA059FC4}" type="datetimeFigureOut">
               <a:rPr lang="en-US" smtClean="0"/>
-              <a:t>1/27/13</a:t>
+              <a:t>4/13/26</a:t>
             </a:fld>
             <a:endParaRPr lang="en-US"/>
           </a:p>
@@ -1157,10 +1601,9 @@
           <a:lstStyle/>
           <a:p>
             <a:r>
-              <a:rPr lang="en-US" smtClean="0"/>
+              <a:rPr lang="en-US"/>
               <a:t>Click to edit Master title style</a:t>
             </a:r>
-            <a:endParaRPr lang="en-US"/>
           </a:p>
         </p:txBody>
       </p:sp>
@@ -1214,38 +1657,37 @@
           <a:p>
             <a:pPr lvl="0"/>
             <a:r>
-              <a:rPr lang="en-US" smtClean="0"/>
+              <a:rPr lang="en-US"/>
               <a:t>Click to edit Master text styles</a:t>
             </a:r>
           </a:p>
           <a:p>
             <a:pPr lvl="1"/>
             <a:r>
-              <a:rPr lang="en-US" smtClean="0"/>
+              <a:rPr lang="en-US"/>
               <a:t>Second level</a:t>
             </a:r>
           </a:p>
           <a:p>
             <a:pPr lvl="2"/>
             <a:r>
-              <a:rPr lang="en-US" smtClean="0"/>
+              <a:rPr lang="en-US"/>
               <a:t>Third level</a:t>
             </a:r>
           </a:p>
           <a:p>
             <a:pPr lvl="3"/>
             <a:r>
-              <a:rPr lang="en-US" smtClean="0"/>
+              <a:rPr lang="en-US"/>
               <a:t>Fourth level</a:t>
             </a:r>
           </a:p>
           <a:p>
             <a:pPr lvl="4"/>
             <a:r>
-              <a:rPr lang="en-US" smtClean="0"/>
+              <a:rPr lang="en-US"/>
               <a:t>Fifth level</a:t>
             </a:r>
-            <a:endParaRPr lang="en-US"/>
           </a:p>
         </p:txBody>
       </p:sp>
@@ -1299,38 +1741,37 @@
           <a:p>
             <a:pPr lvl="0"/>
             <a:r>
-              <a:rPr lang="en-US" smtClean="0"/>
+              <a:rPr lang="en-US"/>
               <a:t>Click to edit Master text styles</a:t>
             </a:r>
           </a:p>
           <a:p>
             <a:pPr lvl="1"/>
             <a:r>
-              <a:rPr lang="en-US" smtClean="0"/>
+              <a:rPr lang="en-US"/>
               <a:t>Second level</a:t>
             </a:r>
           </a:p>
           <a:p>
             <a:pPr lvl="2"/>
             <a:r>
-              <a:rPr lang="en-US" smtClean="0"/>
+              <a:rPr lang="en-US"/>
               <a:t>Third level</a:t>
             </a:r>
           </a:p>
           <a:p>
             <a:pPr lvl="3"/>
             <a:r>
-              <a:rPr lang="en-US" smtClean="0"/>
+              <a:rPr lang="en-US"/>
               <a:t>Fourth level</a:t>
             </a:r>
           </a:p>
           <a:p>
             <a:pPr lvl="4"/>
             <a:r>
-              <a:rPr lang="en-US" smtClean="0"/>
+              <a:rPr lang="en-US"/>
               <a:t>Fifth level</a:t>
             </a:r>
-            <a:endParaRPr lang="en-US"/>
           </a:p>
         </p:txBody>
       </p:sp>
@@ -1351,7 +1792,7 @@
           <a:p>
             <a:fld id="{5BCAD085-E8A6-8845-BD4E-CB4CCA059FC4}" type="datetimeFigureOut">
               <a:rPr lang="en-US" smtClean="0"/>
-              <a:t>1/27/13</a:t>
+              <a:t>4/13/26</a:t>
             </a:fld>
             <a:endParaRPr lang="en-US"/>
           </a:p>
@@ -1449,10 +1890,9 @@
           </a:lstStyle>
           <a:p>
             <a:r>
-              <a:rPr lang="en-US" smtClean="0"/>
+              <a:rPr lang="en-US"/>
               <a:t>Click to edit Master title style</a:t>
             </a:r>
-            <a:endParaRPr lang="en-US"/>
           </a:p>
         </p:txBody>
       </p:sp>
@@ -1515,7 +1955,7 @@
           <a:p>
             <a:pPr lvl="0"/>
             <a:r>
-              <a:rPr lang="en-US" smtClean="0"/>
+              <a:rPr lang="en-US"/>
               <a:t>Click to edit Master text styles</a:t>
             </a:r>
           </a:p>
@@ -1571,38 +2011,37 @@
           <a:p>
             <a:pPr lvl="0"/>
             <a:r>
-              <a:rPr lang="en-US" smtClean="0"/>
+              <a:rPr lang="en-US"/>
               <a:t>Click to edit Master text styles</a:t>
             </a:r>
           </a:p>
           <a:p>
             <a:pPr lvl="1"/>
             <a:r>
-              <a:rPr lang="en-US" smtClean="0"/>
+              <a:rPr lang="en-US"/>
               <a:t>Second level</a:t>
             </a:r>
           </a:p>
           <a:p>
             <a:pPr lvl="2"/>
             <a:r>
-              <a:rPr lang="en-US" smtClean="0"/>
+              <a:rPr lang="en-US"/>
               <a:t>Third level</a:t>
             </a:r>
           </a:p>
           <a:p>
             <a:pPr lvl="3"/>
             <a:r>
-              <a:rPr lang="en-US" smtClean="0"/>
+              <a:rPr lang="en-US"/>
               <a:t>Fourth level</a:t>
             </a:r>
           </a:p>
           <a:p>
             <a:pPr lvl="4"/>
             <a:r>
-              <a:rPr lang="en-US" smtClean="0"/>
+              <a:rPr lang="en-US"/>
               <a:t>Fifth level</a:t>
             </a:r>
-            <a:endParaRPr lang="en-US"/>
           </a:p>
         </p:txBody>
       </p:sp>
@@ -1665,7 +2104,7 @@
           <a:p>
             <a:pPr lvl="0"/>
             <a:r>
-              <a:rPr lang="en-US" smtClean="0"/>
+              <a:rPr lang="en-US"/>
               <a:t>Click to edit Master text styles</a:t>
             </a:r>
           </a:p>
@@ -1721,38 +2160,37 @@
           <a:p>
             <a:pPr lvl="0"/>
             <a:r>
-              <a:rPr lang="en-US" smtClean="0"/>
+              <a:rPr lang="en-US"/>
               <a:t>Click to edit Master text styles</a:t>
             </a:r>
           </a:p>
           <a:p>
             <a:pPr lvl="1"/>
             <a:r>
-              <a:rPr lang="en-US" smtClean="0"/>
+              <a:rPr lang="en-US"/>
               <a:t>Second level</a:t>
             </a:r>
           </a:p>
           <a:p>
             <a:pPr lvl="2"/>
             <a:r>
-              <a:rPr lang="en-US" smtClean="0"/>
+              <a:rPr lang="en-US"/>
               <a:t>Third level</a:t>
             </a:r>
           </a:p>
           <a:p>
             <a:pPr lvl="3"/>
             <a:r>
-              <a:rPr lang="en-US" smtClean="0"/>
+              <a:rPr lang="en-US"/>
               <a:t>Fourth level</a:t>
             </a:r>
           </a:p>
           <a:p>
             <a:pPr lvl="4"/>
             <a:r>
-              <a:rPr lang="en-US" smtClean="0"/>
+              <a:rPr lang="en-US"/>
               <a:t>Fifth level</a:t>
             </a:r>
-            <a:endParaRPr lang="en-US"/>
           </a:p>
         </p:txBody>
       </p:sp>
@@ -1773,7 +2211,7 @@
           <a:p>
             <a:fld id="{5BCAD085-E8A6-8845-BD4E-CB4CCA059FC4}" type="datetimeFigureOut">
               <a:rPr lang="en-US" smtClean="0"/>
-              <a:t>1/27/13</a:t>
+              <a:t>4/13/26</a:t>
             </a:fld>
             <a:endParaRPr lang="en-US"/>
           </a:p>
@@ -1867,10 +2305,9 @@
           <a:lstStyle/>
           <a:p>
             <a:r>
-              <a:rPr lang="en-US" smtClean="0"/>
+              <a:rPr lang="en-US"/>
               <a:t>Click to edit Master title style</a:t>
             </a:r>
-            <a:endParaRPr lang="en-US"/>
           </a:p>
         </p:txBody>
       </p:sp>
@@ -1891,7 +2328,7 @@
           <a:p>
             <a:fld id="{5BCAD085-E8A6-8845-BD4E-CB4CCA059FC4}" type="datetimeFigureOut">
               <a:rPr lang="en-US" smtClean="0"/>
-              <a:t>1/27/13</a:t>
+              <a:t>4/13/26</a:t>
             </a:fld>
             <a:endParaRPr lang="en-US"/>
           </a:p>
@@ -1986,7 +2423,7 @@
           <a:p>
             <a:fld id="{5BCAD085-E8A6-8845-BD4E-CB4CCA059FC4}" type="datetimeFigureOut">
               <a:rPr lang="en-US" smtClean="0"/>
-              <a:t>1/27/13</a:t>
+              <a:t>4/13/26</a:t>
             </a:fld>
             <a:endParaRPr lang="en-US"/>
           </a:p>
@@ -2089,10 +2526,9 @@
           </a:lstStyle>
           <a:p>
             <a:r>
-              <a:rPr lang="en-US" smtClean="0"/>
+              <a:rPr lang="en-US"/>
               <a:t>Click to edit Master title style</a:t>
             </a:r>
-            <a:endParaRPr lang="en-US"/>
           </a:p>
         </p:txBody>
       </p:sp>
@@ -2146,38 +2582,37 @@
           <a:p>
             <a:pPr lvl="0"/>
             <a:r>
-              <a:rPr lang="en-US" smtClean="0"/>
+              <a:rPr lang="en-US"/>
               <a:t>Click to edit Master text styles</a:t>
             </a:r>
           </a:p>
           <a:p>
             <a:pPr lvl="1"/>
             <a:r>
-              <a:rPr lang="en-US" smtClean="0"/>
+              <a:rPr lang="en-US"/>
               <a:t>Second level</a:t>
             </a:r>
           </a:p>
           <a:p>
             <a:pPr lvl="2"/>
             <a:r>
-              <a:rPr lang="en-US" smtClean="0"/>
+              <a:rPr lang="en-US"/>
               <a:t>Third level</a:t>
             </a:r>
           </a:p>
           <a:p>
             <a:pPr lvl="3"/>
             <a:r>
-              <a:rPr lang="en-US" smtClean="0"/>
+              <a:rPr lang="en-US"/>
               <a:t>Fourth level</a:t>
             </a:r>
           </a:p>
           <a:p>
             <a:pPr lvl="4"/>
             <a:r>
-              <a:rPr lang="en-US" smtClean="0"/>
+              <a:rPr lang="en-US"/>
               <a:t>Fifth level</a:t>
             </a:r>
-            <a:endParaRPr lang="en-US"/>
           </a:p>
         </p:txBody>
       </p:sp>
@@ -2240,7 +2675,7 @@
           <a:p>
             <a:pPr lvl="0"/>
             <a:r>
-              <a:rPr lang="en-US" smtClean="0"/>
+              <a:rPr lang="en-US"/>
               <a:t>Click to edit Master text styles</a:t>
             </a:r>
           </a:p>
@@ -2263,7 +2698,7 @@
           <a:p>
             <a:fld id="{5BCAD085-E8A6-8845-BD4E-CB4CCA059FC4}" type="datetimeFigureOut">
               <a:rPr lang="en-US" smtClean="0"/>
-              <a:t>1/27/13</a:t>
+              <a:t>4/13/26</a:t>
             </a:fld>
             <a:endParaRPr lang="en-US"/>
           </a:p>
@@ -2366,10 +2801,9 @@
           </a:lstStyle>
           <a:p>
             <a:r>
-              <a:rPr lang="en-US" smtClean="0"/>
+              <a:rPr lang="en-US"/>
               <a:t>Click to edit Master title style</a:t>
             </a:r>
-            <a:endParaRPr lang="en-US"/>
           </a:p>
         </p:txBody>
       </p:sp>
@@ -2493,7 +2927,7 @@
           <a:p>
             <a:pPr lvl="0"/>
             <a:r>
-              <a:rPr lang="en-US" smtClean="0"/>
+              <a:rPr lang="en-US"/>
               <a:t>Click to edit Master text styles</a:t>
             </a:r>
           </a:p>
@@ -2516,7 +2950,7 @@
           <a:p>
             <a:fld id="{5BCAD085-E8A6-8845-BD4E-CB4CCA059FC4}" type="datetimeFigureOut">
               <a:rPr lang="en-US" smtClean="0"/>
-              <a:t>1/27/13</a:t>
+              <a:t>4/13/26</a:t>
             </a:fld>
             <a:endParaRPr lang="en-US"/>
           </a:p>
@@ -2625,10 +3059,9 @@
           <a:lstStyle/>
           <a:p>
             <a:r>
-              <a:rPr lang="en-US" smtClean="0"/>
+              <a:rPr lang="en-US"/>
               <a:t>Click to edit Master title style</a:t>
             </a:r>
-            <a:endParaRPr lang="en-US"/>
           </a:p>
         </p:txBody>
       </p:sp>
@@ -2659,38 +3092,37 @@
           <a:p>
             <a:pPr lvl="0"/>
             <a:r>
-              <a:rPr lang="en-US" smtClean="0"/>
+              <a:rPr lang="en-US"/>
               <a:t>Click to edit Master text styles</a:t>
             </a:r>
           </a:p>
           <a:p>
             <a:pPr lvl="1"/>
             <a:r>
-              <a:rPr lang="en-US" smtClean="0"/>
+              <a:rPr lang="en-US"/>
               <a:t>Second level</a:t>
             </a:r>
           </a:p>
           <a:p>
             <a:pPr lvl="2"/>
             <a:r>
-              <a:rPr lang="en-US" smtClean="0"/>
+              <a:rPr lang="en-US"/>
               <a:t>Third level</a:t>
             </a:r>
           </a:p>
           <a:p>
             <a:pPr lvl="3"/>
             <a:r>
-              <a:rPr lang="en-US" smtClean="0"/>
+              <a:rPr lang="en-US"/>
               <a:t>Fourth level</a:t>
             </a:r>
           </a:p>
           <a:p>
             <a:pPr lvl="4"/>
             <a:r>
-              <a:rPr lang="en-US" smtClean="0"/>
+              <a:rPr lang="en-US"/>
               <a:t>Fifth level</a:t>
             </a:r>
-            <a:endParaRPr lang="en-US"/>
           </a:p>
         </p:txBody>
       </p:sp>
@@ -2729,7 +3161,7 @@
           <a:p>
             <a:fld id="{5BCAD085-E8A6-8845-BD4E-CB4CCA059FC4}" type="datetimeFigureOut">
               <a:rPr lang="en-US" smtClean="0"/>
-              <a:t>1/27/13</a:t>
+              <a:t>4/13/26</a:t>
             </a:fld>
             <a:endParaRPr lang="en-US"/>
           </a:p>
@@ -3088,7 +3520,7 @@
 </file>
 
 <file path=ppt/slides/slide1.xml><?xml version="1.0" encoding="utf-8"?>
-<p:sld xmlns:a="http://schemas.openxmlformats.org/drawingml/2006/main" xmlns:p="http://schemas.openxmlformats.org/presentationml/2006/main" xmlns:r="http://schemas.openxmlformats.org/officeDocument/2006/relationships">
+<p:sld xmlns:a="http://schemas.openxmlformats.org/drawingml/2006/main" xmlns:r="http://schemas.openxmlformats.org/officeDocument/2006/relationships" xmlns:p="http://schemas.openxmlformats.org/presentationml/2006/main">
   <p:cSld>
     <p:bg>
       <p:bgPr>
@@ -3104,7 +3536,14 @@
         <p:cNvGrpSpPr/>
         <p:nvPr/>
       </p:nvGrpSpPr>
-      <p:grpSpPr/>
+      <p:grpSpPr>
+        <a:xfrm>
+          <a:off x="0" y="0"/>
+          <a:ext cx="0" cy="0"/>
+          <a:chOff x="0" y="0"/>
+          <a:chExt cx="0" cy="0"/>
+        </a:xfrm>
+      </p:grpSpPr>
       <p:sp>
         <p:nvSpPr>
           <p:cNvPr id="2" name="TextBox 1"/>
@@ -3215,6 +3654,7 @@
           <a:lstStyle/>
           <a:p>
             <a:pPr algn="ctr"/>
+            <a:endParaRPr/>
           </a:p>
         </p:txBody>
       </p:sp>
@@ -3295,6 +3735,7 @@
           <a:lstStyle/>
           <a:p>
             <a:pPr algn="ctr"/>
+            <a:endParaRPr/>
           </a:p>
         </p:txBody>
       </p:sp>
@@ -3340,6 +3781,7 @@
           <a:lstStyle/>
           <a:p>
             <a:pPr algn="ctr"/>
+            <a:endParaRPr/>
           </a:p>
         </p:txBody>
       </p:sp>
@@ -3385,6 +3827,7 @@
           <a:lstStyle/>
           <a:p>
             <a:pPr algn="ctr"/>
+            <a:endParaRPr/>
           </a:p>
         </p:txBody>
       </p:sp>
@@ -3465,6 +3908,7 @@
           <a:lstStyle/>
           <a:p>
             <a:pPr algn="ctr"/>
+            <a:endParaRPr/>
           </a:p>
         </p:txBody>
       </p:sp>
@@ -3543,6 +3987,7 @@
           <a:lstStyle/>
           <a:p>
             <a:pPr algn="ctr"/>
+            <a:endParaRPr/>
           </a:p>
         </p:txBody>
       </p:sp>
@@ -3588,6 +4033,7 @@
           <a:lstStyle/>
           <a:p>
             <a:pPr algn="ctr"/>
+            <a:endParaRPr/>
           </a:p>
         </p:txBody>
       </p:sp>
@@ -3599,7 +4045,7 @@
         </p:nvSpPr>
         <p:spPr>
           <a:xfrm>
-            <a:off x="1115568" y="4535424"/>
+            <a:off x="1115568" y="4461854"/>
             <a:ext cx="1627632" cy="384048"/>
           </a:xfrm>
           <a:prstGeom prst="rect">
@@ -3615,7 +4061,7 @@
           <a:p>
             <a:pPr algn="ctr"/>
             <a:r>
-              <a:rPr sz="1900" b="0">
+              <a:rPr sz="1900" b="0" dirty="0">
                 <a:solidFill>
                   <a:srgbClr val="17222D"/>
                 </a:solidFill>
@@ -3704,6 +4150,7 @@
           <a:lstStyle/>
           <a:p>
             <a:pPr algn="ctr"/>
+            <a:endParaRPr/>
           </a:p>
         </p:txBody>
       </p:sp>
@@ -3784,6 +4231,7 @@
           <a:lstStyle/>
           <a:p>
             <a:pPr algn="ctr"/>
+            <a:endParaRPr/>
           </a:p>
         </p:txBody>
       </p:sp>
@@ -3864,6 +4312,7 @@
           <a:lstStyle/>
           <a:p>
             <a:pPr algn="ctr"/>
+            <a:endParaRPr/>
           </a:p>
         </p:txBody>
       </p:sp>
@@ -3944,6 +4393,7 @@
           <a:lstStyle/>
           <a:p>
             <a:pPr algn="ctr"/>
+            <a:endParaRPr/>
           </a:p>
         </p:txBody>
       </p:sp>
@@ -4022,6 +4472,7 @@
           <a:lstStyle/>
           <a:p>
             <a:pPr algn="ctr"/>
+            <a:endParaRPr/>
           </a:p>
         </p:txBody>
       </p:sp>
@@ -4065,6 +4516,7 @@
           <a:lstStyle/>
           <a:p>
             <a:pPr algn="ctr"/>
+            <a:endParaRPr/>
           </a:p>
         </p:txBody>
       </p:sp>
@@ -4108,6 +4560,7 @@
           <a:lstStyle/>
           <a:p>
             <a:pPr algn="ctr"/>
+            <a:endParaRPr/>
           </a:p>
         </p:txBody>
       </p:sp>
@@ -4151,6 +4604,7 @@
           <a:lstStyle/>
           <a:p>
             <a:pPr algn="ctr"/>
+            <a:endParaRPr/>
           </a:p>
         </p:txBody>
       </p:sp>
@@ -4231,6 +4685,7 @@
           <a:lstStyle/>
           <a:p>
             <a:pPr algn="ctr"/>
+            <a:endParaRPr/>
           </a:p>
         </p:txBody>
       </p:sp>
@@ -4312,6 +4767,7 @@
           <a:lstStyle/>
           <a:p>
             <a:pPr algn="ctr"/>
+            <a:endParaRPr/>
           </a:p>
         </p:txBody>
       </p:sp>
@@ -4392,6 +4848,7 @@
           <a:lstStyle/>
           <a:p>
             <a:pPr algn="ctr"/>
+            <a:endParaRPr/>
           </a:p>
         </p:txBody>
       </p:sp>
@@ -4472,6 +4929,7 @@
           <a:lstStyle/>
           <a:p>
             <a:pPr algn="ctr"/>
+            <a:endParaRPr/>
           </a:p>
         </p:txBody>
       </p:sp>
@@ -4552,6 +5010,7 @@
           <a:lstStyle/>
           <a:p>
             <a:pPr algn="ctr"/>
+            <a:endParaRPr/>
           </a:p>
         </p:txBody>
       </p:sp>
@@ -4632,6 +5091,7 @@
           <a:lstStyle/>
           <a:p>
             <a:pPr algn="ctr"/>
+            <a:endParaRPr/>
           </a:p>
         </p:txBody>
       </p:sp>
@@ -4710,6 +5170,7 @@
           <a:lstStyle/>
           <a:p>
             <a:pPr algn="ctr"/>
+            <a:endParaRPr/>
           </a:p>
         </p:txBody>
       </p:sp>
@@ -4753,6 +5214,7 @@
           <a:lstStyle/>
           <a:p>
             <a:pPr algn="ctr"/>
+            <a:endParaRPr/>
           </a:p>
         </p:txBody>
       </p:sp>
@@ -4798,6 +5260,7 @@
           <a:lstStyle/>
           <a:p>
             <a:pPr algn="ctr"/>
+            <a:endParaRPr/>
           </a:p>
         </p:txBody>
       </p:sp>
@@ -4845,7 +5308,7 @@
 </file>
 
 <file path=ppt/slides/slide10.xml><?xml version="1.0" encoding="utf-8"?>
-<p:sld xmlns:a="http://schemas.openxmlformats.org/drawingml/2006/main" xmlns:p="http://schemas.openxmlformats.org/presentationml/2006/main" xmlns:r="http://schemas.openxmlformats.org/officeDocument/2006/relationships">
+<p:sld xmlns:a="http://schemas.openxmlformats.org/drawingml/2006/main" xmlns:r="http://schemas.openxmlformats.org/officeDocument/2006/relationships" xmlns:p="http://schemas.openxmlformats.org/presentationml/2006/main">
   <p:cSld>
     <p:bg>
       <p:bgPr>
@@ -4861,7 +5324,14 @@
         <p:cNvGrpSpPr/>
         <p:nvPr/>
       </p:nvGrpSpPr>
-      <p:grpSpPr/>
+      <p:grpSpPr>
+        <a:xfrm>
+          <a:off x="0" y="0"/>
+          <a:ext cx="0" cy="0"/>
+          <a:chOff x="0" y="0"/>
+          <a:chExt cx="0" cy="0"/>
+        </a:xfrm>
+      </p:grpSpPr>
       <p:sp>
         <p:nvSpPr>
           <p:cNvPr id="2" name="TextBox 1"/>
@@ -4937,6 +5407,7 @@
           <a:lstStyle/>
           <a:p>
             <a:pPr algn="ctr"/>
+            <a:endParaRPr/>
           </a:p>
         </p:txBody>
       </p:sp>
@@ -4982,6 +5453,7 @@
           <a:lstStyle/>
           <a:p>
             <a:pPr algn="ctr"/>
+            <a:endParaRPr/>
           </a:p>
         </p:txBody>
       </p:sp>
@@ -5063,6 +5535,7 @@
           <a:lstStyle/>
           <a:p>
             <a:pPr algn="ctr"/>
+            <a:endParaRPr/>
           </a:p>
         </p:txBody>
       </p:sp>
@@ -5179,6 +5652,7 @@
           <a:lstStyle/>
           <a:p>
             <a:pPr algn="ctr"/>
+            <a:endParaRPr/>
           </a:p>
         </p:txBody>
       </p:sp>
@@ -5295,6 +5769,7 @@
           <a:lstStyle/>
           <a:p>
             <a:pPr algn="ctr"/>
+            <a:endParaRPr/>
           </a:p>
         </p:txBody>
       </p:sp>
@@ -5378,7 +5853,7 @@
 </file>
 
 <file path=ppt/slides/slide2.xml><?xml version="1.0" encoding="utf-8"?>
-<p:sld xmlns:a="http://schemas.openxmlformats.org/drawingml/2006/main" xmlns:p="http://schemas.openxmlformats.org/presentationml/2006/main" xmlns:r="http://schemas.openxmlformats.org/officeDocument/2006/relationships">
+<p:sld xmlns:a="http://schemas.openxmlformats.org/drawingml/2006/main" xmlns:r="http://schemas.openxmlformats.org/officeDocument/2006/relationships" xmlns:p="http://schemas.openxmlformats.org/presentationml/2006/main">
   <p:cSld>
     <p:bg>
       <p:bgPr>
@@ -5394,7 +5869,14 @@
         <p:cNvGrpSpPr/>
         <p:nvPr/>
       </p:nvGrpSpPr>
-      <p:grpSpPr/>
+      <p:grpSpPr>
+        <a:xfrm>
+          <a:off x="0" y="0"/>
+          <a:ext cx="0" cy="0"/>
+          <a:chOff x="0" y="0"/>
+          <a:chExt cx="0" cy="0"/>
+        </a:xfrm>
+      </p:grpSpPr>
       <p:sp>
         <p:nvSpPr>
           <p:cNvPr id="2" name="TextBox 1"/>
@@ -5505,6 +5987,7 @@
           <a:lstStyle/>
           <a:p>
             <a:pPr algn="ctr"/>
+            <a:endParaRPr/>
           </a:p>
         </p:txBody>
       </p:sp>
@@ -5550,6 +6033,7 @@
           <a:lstStyle/>
           <a:p>
             <a:pPr algn="ctr"/>
+            <a:endParaRPr/>
           </a:p>
         </p:txBody>
       </p:sp>
@@ -5595,6 +6079,7 @@
           <a:lstStyle/>
           <a:p>
             <a:pPr algn="ctr"/>
+            <a:endParaRPr/>
           </a:p>
         </p:txBody>
       </p:sp>
@@ -5657,13 +6142,40 @@
           <a:p>
             <a:pPr algn="ctr"/>
             <a:r>
-              <a:rPr sz="1900" b="1">
+              <a:rPr sz="1900" b="1" dirty="0" err="1">
                 <a:solidFill>
                   <a:srgbClr val="17222D"/>
                 </a:solidFill>
                 <a:latin typeface="Aptos"/>
               </a:rPr>
-              <a:t>produit texte,
+              <a:t>produit</a:t>
+            </a:r>
+            <a:r>
+              <a:rPr sz="1900" b="1" dirty="0">
+                <a:solidFill>
+                  <a:srgbClr val="17222D"/>
+                </a:solidFill>
+                <a:latin typeface="Aptos"/>
+              </a:rPr>
+              <a:t> </a:t>
+            </a:r>
+            <a:r>
+              <a:rPr sz="1900" b="1" dirty="0" err="1">
+                <a:solidFill>
+                  <a:srgbClr val="17222D"/>
+                </a:solidFill>
+                <a:latin typeface="Aptos"/>
+              </a:rPr>
+              <a:t>texte</a:t>
+            </a:r>
+            <a:r>
+              <a:rPr sz="1900" b="1" dirty="0">
+                <a:solidFill>
+                  <a:srgbClr val="17222D"/>
+                </a:solidFill>
+                <a:latin typeface="Aptos"/>
+              </a:rPr>
+              <a:t>,
 code, plan,
 résumé</a:t>
             </a:r>
@@ -5712,6 +6224,7 @@
           <a:lstStyle/>
           <a:p>
             <a:pPr algn="ctr"/>
+            <a:endParaRPr/>
           </a:p>
         </p:txBody>
       </p:sp>
@@ -5757,6 +6270,7 @@
           <a:lstStyle/>
           <a:p>
             <a:pPr algn="ctr"/>
+            <a:endParaRPr/>
           </a:p>
         </p:txBody>
       </p:sp>
@@ -5874,6 +6388,7 @@
           <a:lstStyle/>
           <a:p>
             <a:pPr algn="ctr"/>
+            <a:endParaRPr/>
           </a:p>
         </p:txBody>
       </p:sp>
@@ -5919,6 +6434,7 @@
           <a:lstStyle/>
           <a:p>
             <a:pPr algn="ctr"/>
+            <a:endParaRPr/>
           </a:p>
         </p:txBody>
       </p:sp>
@@ -6036,6 +6552,7 @@
           <a:lstStyle/>
           <a:p>
             <a:pPr algn="ctr"/>
+            <a:endParaRPr/>
           </a:p>
         </p:txBody>
       </p:sp>
@@ -6081,6 +6598,7 @@
           <a:lstStyle/>
           <a:p>
             <a:pPr algn="ctr"/>
+            <a:endParaRPr/>
           </a:p>
         </p:txBody>
       </p:sp>
@@ -6196,6 +6714,7 @@
           <a:lstStyle/>
           <a:p>
             <a:pPr algn="ctr"/>
+            <a:endParaRPr/>
           </a:p>
         </p:txBody>
       </p:sp>
@@ -6239,6 +6758,7 @@
           <a:lstStyle/>
           <a:p>
             <a:pPr algn="ctr"/>
+            <a:endParaRPr/>
           </a:p>
         </p:txBody>
       </p:sp>
@@ -6282,6 +6802,7 @@
           <a:lstStyle/>
           <a:p>
             <a:pPr algn="ctr"/>
+            <a:endParaRPr/>
           </a:p>
         </p:txBody>
       </p:sp>
@@ -6327,6 +6848,7 @@
           <a:lstStyle/>
           <a:p>
             <a:pPr algn="ctr"/>
+            <a:endParaRPr/>
           </a:p>
         </p:txBody>
       </p:sp>
@@ -6442,6 +6964,7 @@
           <a:lstStyle/>
           <a:p>
             <a:pPr algn="ctr"/>
+            <a:endParaRPr/>
           </a:p>
         </p:txBody>
       </p:sp>
@@ -6524,7 +7047,7 @@
 </file>
 
 <file path=ppt/slides/slide3.xml><?xml version="1.0" encoding="utf-8"?>
-<p:sld xmlns:a="http://schemas.openxmlformats.org/drawingml/2006/main" xmlns:p="http://schemas.openxmlformats.org/presentationml/2006/main" xmlns:r="http://schemas.openxmlformats.org/officeDocument/2006/relationships">
+<p:sld xmlns:a="http://schemas.openxmlformats.org/drawingml/2006/main" xmlns:r="http://schemas.openxmlformats.org/officeDocument/2006/relationships" xmlns:p="http://schemas.openxmlformats.org/presentationml/2006/main">
   <p:cSld>
     <p:bg>
       <p:bgPr>
@@ -6540,7 +7063,14 @@
         <p:cNvGrpSpPr/>
         <p:nvPr/>
       </p:nvGrpSpPr>
-      <p:grpSpPr/>
+      <p:grpSpPr>
+        <a:xfrm>
+          <a:off x="0" y="0"/>
+          <a:ext cx="0" cy="0"/>
+          <a:chOff x="0" y="0"/>
+          <a:chExt cx="0" cy="0"/>
+        </a:xfrm>
+      </p:grpSpPr>
       <p:sp>
         <p:nvSpPr>
           <p:cNvPr id="2" name="TextBox 1"/>
@@ -6651,6 +7181,7 @@
           <a:lstStyle/>
           <a:p>
             <a:pPr algn="ctr"/>
+            <a:endParaRPr/>
           </a:p>
         </p:txBody>
       </p:sp>
@@ -6696,6 +7227,7 @@
           <a:lstStyle/>
           <a:p>
             <a:pPr algn="ctr"/>
+            <a:endParaRPr/>
           </a:p>
         </p:txBody>
       </p:sp>
@@ -6741,6 +7273,7 @@
           <a:lstStyle/>
           <a:p>
             <a:pPr algn="ctr"/>
+            <a:endParaRPr/>
           </a:p>
         </p:txBody>
       </p:sp>
@@ -6873,15 +7406,48 @@
           <a:p>
             <a:pPr algn="ctr"/>
             <a:r>
-              <a:rPr sz="1400" b="0">
+              <a:rPr sz="1400" b="0" dirty="0">
                 <a:solidFill>
                   <a:srgbClr val="5E656B"/>
                 </a:solidFill>
                 <a:latin typeface="Aptos"/>
               </a:rPr>
-              <a:t>• copier-coller
-• tests manuels</a:t>
-            </a:r>
+              <a:t>• copier-</a:t>
+            </a:r>
+            <a:r>
+              <a:rPr sz="1400" b="0" dirty="0" err="1">
+                <a:solidFill>
+                  <a:srgbClr val="5E656B"/>
+                </a:solidFill>
+                <a:latin typeface="Aptos"/>
+              </a:rPr>
+              <a:t>coller</a:t>
+            </a:r>
+            <a:r>
+              <a:rPr sz="1400" b="0" dirty="0">
+                <a:solidFill>
+                  <a:srgbClr val="5E656B"/>
+                </a:solidFill>
+                <a:latin typeface="Aptos"/>
+              </a:rPr>
+              <a:t>
+• tests </a:t>
+            </a:r>
+            <a:r>
+              <a:rPr sz="1400" b="0" dirty="0" err="1">
+                <a:solidFill>
+                  <a:srgbClr val="5E656B"/>
+                </a:solidFill>
+                <a:latin typeface="Aptos"/>
+              </a:rPr>
+              <a:t>manuels</a:t>
+            </a:r>
+            <a:endParaRPr sz="1400" b="0" dirty="0">
+              <a:solidFill>
+                <a:srgbClr val="5E656B"/>
+              </a:solidFill>
+              <a:latin typeface="Aptos"/>
+            </a:endParaRPr>
           </a:p>
         </p:txBody>
       </p:sp>
@@ -6927,6 +7493,7 @@
           <a:lstStyle/>
           <a:p>
             <a:pPr algn="ctr"/>
+            <a:endParaRPr/>
           </a:p>
         </p:txBody>
       </p:sp>
@@ -7007,6 +7574,7 @@
           <a:lstStyle/>
           <a:p>
             <a:pPr algn="ctr"/>
+            <a:endParaRPr/>
           </a:p>
         </p:txBody>
       </p:sp>
@@ -7052,6 +7620,7 @@
           <a:lstStyle/>
           <a:p>
             <a:pPr algn="ctr"/>
+            <a:endParaRPr/>
           </a:p>
         </p:txBody>
       </p:sp>
@@ -7238,6 +7807,7 @@
           <a:lstStyle/>
           <a:p>
             <a:pPr algn="ctr"/>
+            <a:endParaRPr/>
           </a:p>
         </p:txBody>
       </p:sp>
@@ -7318,6 +7888,7 @@
           <a:lstStyle/>
           <a:p>
             <a:pPr algn="ctr"/>
+            <a:endParaRPr/>
           </a:p>
         </p:txBody>
       </p:sp>
@@ -7363,6 +7934,7 @@
           <a:lstStyle/>
           <a:p>
             <a:pPr algn="ctr"/>
+            <a:endParaRPr/>
           </a:p>
         </p:txBody>
       </p:sp>
@@ -7549,6 +8121,7 @@
           <a:lstStyle/>
           <a:p>
             <a:pPr algn="ctr"/>
+            <a:endParaRPr/>
           </a:p>
         </p:txBody>
       </p:sp>
@@ -7627,6 +8200,7 @@
           <a:lstStyle/>
           <a:p>
             <a:pPr algn="ctr"/>
+            <a:endParaRPr/>
           </a:p>
         </p:txBody>
       </p:sp>
@@ -7674,7 +8248,7 @@
 </file>
 
 <file path=ppt/slides/slide4.xml><?xml version="1.0" encoding="utf-8"?>
-<p:sld xmlns:a="http://schemas.openxmlformats.org/drawingml/2006/main" xmlns:p="http://schemas.openxmlformats.org/presentationml/2006/main" xmlns:r="http://schemas.openxmlformats.org/officeDocument/2006/relationships">
+<p:sld xmlns:a="http://schemas.openxmlformats.org/drawingml/2006/main" xmlns:r="http://schemas.openxmlformats.org/officeDocument/2006/relationships" xmlns:p="http://schemas.openxmlformats.org/presentationml/2006/main">
   <p:cSld>
     <p:bg>
       <p:bgPr>
@@ -7690,7 +8264,14 @@
         <p:cNvGrpSpPr/>
         <p:nvPr/>
       </p:nvGrpSpPr>
-      <p:grpSpPr/>
+      <p:grpSpPr>
+        <a:xfrm>
+          <a:off x="0" y="0"/>
+          <a:ext cx="0" cy="0"/>
+          <a:chOff x="0" y="0"/>
+          <a:chExt cx="0" cy="0"/>
+        </a:xfrm>
+      </p:grpSpPr>
       <p:sp>
         <p:nvSpPr>
           <p:cNvPr id="2" name="TextBox 1"/>
@@ -7801,6 +8382,7 @@
           <a:lstStyle/>
           <a:p>
             <a:pPr algn="ctr"/>
+            <a:endParaRPr/>
           </a:p>
         </p:txBody>
       </p:sp>
@@ -7846,6 +8428,7 @@
           <a:lstStyle/>
           <a:p>
             <a:pPr algn="ctr"/>
+            <a:endParaRPr/>
           </a:p>
         </p:txBody>
       </p:sp>
@@ -7962,6 +8545,7 @@
           <a:lstStyle/>
           <a:p>
             <a:pPr algn="ctr"/>
+            <a:endParaRPr/>
           </a:p>
         </p:txBody>
       </p:sp>
@@ -8079,6 +8663,7 @@
           <a:lstStyle/>
           <a:p>
             <a:pPr algn="ctr"/>
+            <a:endParaRPr/>
           </a:p>
         </p:txBody>
       </p:sp>
@@ -8193,6 +8778,7 @@
           <a:lstStyle/>
           <a:p>
             <a:pPr algn="ctr"/>
+            <a:endParaRPr/>
           </a:p>
         </p:txBody>
       </p:sp>
@@ -8236,6 +8822,7 @@
           <a:lstStyle/>
           <a:p>
             <a:pPr algn="ctr"/>
+            <a:endParaRPr/>
           </a:p>
         </p:txBody>
       </p:sp>
@@ -8281,6 +8868,7 @@
           <a:lstStyle/>
           <a:p>
             <a:pPr algn="ctr"/>
+            <a:endParaRPr/>
           </a:p>
         </p:txBody>
       </p:sp>
@@ -8361,6 +8949,7 @@
           <a:lstStyle/>
           <a:p>
             <a:pPr algn="ctr"/>
+            <a:endParaRPr/>
           </a:p>
         </p:txBody>
       </p:sp>
@@ -8408,7 +8997,7 @@
 </file>
 
 <file path=ppt/slides/slide5.xml><?xml version="1.0" encoding="utf-8"?>
-<p:sld xmlns:a="http://schemas.openxmlformats.org/drawingml/2006/main" xmlns:p="http://schemas.openxmlformats.org/presentationml/2006/main" xmlns:r="http://schemas.openxmlformats.org/officeDocument/2006/relationships">
+<p:sld xmlns:a="http://schemas.openxmlformats.org/drawingml/2006/main" xmlns:r="http://schemas.openxmlformats.org/officeDocument/2006/relationships" xmlns:p="http://schemas.openxmlformats.org/presentationml/2006/main">
   <p:cSld>
     <p:bg>
       <p:bgPr>
@@ -8424,7 +9013,14 @@
         <p:cNvGrpSpPr/>
         <p:nvPr/>
       </p:nvGrpSpPr>
-      <p:grpSpPr/>
+      <p:grpSpPr>
+        <a:xfrm>
+          <a:off x="0" y="0"/>
+          <a:ext cx="0" cy="0"/>
+          <a:chOff x="0" y="0"/>
+          <a:chExt cx="0" cy="0"/>
+        </a:xfrm>
+      </p:grpSpPr>
       <p:sp>
         <p:nvSpPr>
           <p:cNvPr id="2" name="TextBox 1"/>
@@ -8535,6 +9131,7 @@
           <a:lstStyle/>
           <a:p>
             <a:pPr algn="ctr"/>
+            <a:endParaRPr/>
           </a:p>
         </p:txBody>
       </p:sp>
@@ -8580,6 +9177,7 @@
           <a:lstStyle/>
           <a:p>
             <a:pPr algn="ctr"/>
+            <a:endParaRPr/>
           </a:p>
         </p:txBody>
       </p:sp>
@@ -8625,6 +9223,7 @@
           <a:lstStyle/>
           <a:p>
             <a:pPr algn="ctr"/>
+            <a:endParaRPr/>
           </a:p>
         </p:txBody>
       </p:sp>
@@ -8738,6 +9337,7 @@
           <a:lstStyle/>
           <a:p>
             <a:pPr algn="ctr"/>
+            <a:endParaRPr/>
           </a:p>
         </p:txBody>
       </p:sp>
@@ -8783,6 +9383,7 @@
           <a:lstStyle/>
           <a:p>
             <a:pPr algn="ctr"/>
+            <a:endParaRPr/>
           </a:p>
         </p:txBody>
       </p:sp>
@@ -8828,6 +9429,7 @@
           <a:lstStyle/>
           <a:p>
             <a:pPr algn="ctr"/>
+            <a:endParaRPr/>
           </a:p>
         </p:txBody>
       </p:sp>
@@ -8941,6 +9543,7 @@
           <a:lstStyle/>
           <a:p>
             <a:pPr algn="ctr"/>
+            <a:endParaRPr/>
           </a:p>
         </p:txBody>
       </p:sp>
@@ -8986,6 +9589,7 @@
           <a:lstStyle/>
           <a:p>
             <a:pPr algn="ctr"/>
+            <a:endParaRPr/>
           </a:p>
         </p:txBody>
       </p:sp>
@@ -9031,6 +9635,7 @@
           <a:lstStyle/>
           <a:p>
             <a:pPr algn="ctr"/>
+            <a:endParaRPr/>
           </a:p>
         </p:txBody>
       </p:sp>
@@ -9144,6 +9749,7 @@
           <a:lstStyle/>
           <a:p>
             <a:pPr algn="ctr"/>
+            <a:endParaRPr/>
           </a:p>
         </p:txBody>
       </p:sp>
@@ -9189,6 +9795,7 @@
           <a:lstStyle/>
           <a:p>
             <a:pPr algn="ctr"/>
+            <a:endParaRPr/>
           </a:p>
         </p:txBody>
       </p:sp>
@@ -9234,6 +9841,7 @@
           <a:lstStyle/>
           <a:p>
             <a:pPr algn="ctr"/>
+            <a:endParaRPr/>
           </a:p>
         </p:txBody>
       </p:sp>
@@ -9349,6 +9957,7 @@
           <a:lstStyle/>
           <a:p>
             <a:pPr algn="ctr"/>
+            <a:endParaRPr/>
           </a:p>
         </p:txBody>
       </p:sp>
@@ -9396,7 +10005,7 @@
 </file>
 
 <file path=ppt/slides/slide6.xml><?xml version="1.0" encoding="utf-8"?>
-<p:sld xmlns:a="http://schemas.openxmlformats.org/drawingml/2006/main" xmlns:p="http://schemas.openxmlformats.org/presentationml/2006/main" xmlns:r="http://schemas.openxmlformats.org/officeDocument/2006/relationships">
+<p:sld xmlns:a="http://schemas.openxmlformats.org/drawingml/2006/main" xmlns:r="http://schemas.openxmlformats.org/officeDocument/2006/relationships" xmlns:p="http://schemas.openxmlformats.org/presentationml/2006/main">
   <p:cSld>
     <p:bg>
       <p:bgPr>
@@ -9412,7 +10021,14 @@
         <p:cNvGrpSpPr/>
         <p:nvPr/>
       </p:nvGrpSpPr>
-      <p:grpSpPr/>
+      <p:grpSpPr>
+        <a:xfrm>
+          <a:off x="0" y="0"/>
+          <a:ext cx="0" cy="0"/>
+          <a:chOff x="0" y="0"/>
+          <a:chExt cx="0" cy="0"/>
+        </a:xfrm>
+      </p:grpSpPr>
       <p:sp>
         <p:nvSpPr>
           <p:cNvPr id="2" name="TextBox 1"/>
@@ -9523,6 +10139,7 @@
           <a:lstStyle/>
           <a:p>
             <a:pPr algn="ctr"/>
+            <a:endParaRPr/>
           </a:p>
         </p:txBody>
       </p:sp>
@@ -9568,6 +10185,7 @@
           <a:lstStyle/>
           <a:p>
             <a:pPr algn="ctr"/>
+            <a:endParaRPr/>
           </a:p>
         </p:txBody>
       </p:sp>
@@ -9614,8 +10232,8 @@
         </p:nvSpPr>
         <p:spPr>
           <a:xfrm>
-            <a:off x="1618488" y="2852928"/>
-            <a:ext cx="1463040" cy="365760"/>
+            <a:off x="1618488" y="2852927"/>
+            <a:ext cx="1463040" cy="482317"/>
           </a:xfrm>
           <a:prstGeom prst="roundRect">
             <a:avLst/>
@@ -9648,6 +10266,7 @@
           <a:lstStyle/>
           <a:p>
             <a:pPr algn="ctr"/>
+            <a:endParaRPr sz="3600"/>
           </a:p>
         </p:txBody>
       </p:sp>
@@ -9659,8 +10278,8 @@
         </p:nvSpPr>
         <p:spPr>
           <a:xfrm>
-            <a:off x="1618488" y="2880360"/>
-            <a:ext cx="1463040" cy="365760"/>
+            <a:off x="1618488" y="2827810"/>
+            <a:ext cx="1463040" cy="461665"/>
           </a:xfrm>
           <a:prstGeom prst="rect">
             <a:avLst/>
@@ -9675,7 +10294,7 @@
           <a:p>
             <a:pPr algn="ctr"/>
             <a:r>
-              <a:rPr sz="1200" b="1">
+              <a:rPr sz="2400" b="1" dirty="0" err="1">
                 <a:solidFill>
                   <a:srgbClr val="BF5A24"/>
                 </a:solidFill>
@@ -9683,6 +10302,12 @@
               </a:rPr>
               <a:t>exécute</a:t>
             </a:r>
+            <a:endParaRPr sz="2400" b="1" dirty="0">
+              <a:solidFill>
+                <a:srgbClr val="BF5A24"/>
+              </a:solidFill>
+              <a:latin typeface="Aptos"/>
+            </a:endParaRPr>
           </a:p>
         </p:txBody>
       </p:sp>
@@ -9710,16 +10335,67 @@
           <a:p>
             <a:pPr algn="ctr"/>
             <a:r>
-              <a:rPr sz="1800" b="0">
+              <a:rPr sz="1800" b="0" dirty="0">
                 <a:solidFill>
                   <a:srgbClr val="5E656B"/>
                 </a:solidFill>
                 <a:latin typeface="Aptos"/>
               </a:rPr>
-              <a:t>CLI déterministe
-run_eval.py
-collect_metrics.py</a:t>
-            </a:r>
+              <a:t>CLI </a:t>
+            </a:r>
+            <a:r>
+              <a:rPr sz="1800" b="0" dirty="0" err="1">
+                <a:solidFill>
+                  <a:srgbClr val="5E656B"/>
+                </a:solidFill>
+                <a:latin typeface="Aptos"/>
+              </a:rPr>
+              <a:t>déterministe</a:t>
+            </a:r>
+            <a:r>
+              <a:rPr sz="1800" b="0" dirty="0">
+                <a:solidFill>
+                  <a:srgbClr val="5E656B"/>
+                </a:solidFill>
+                <a:latin typeface="Aptos"/>
+              </a:rPr>
+              <a:t>
+</a:t>
+            </a:r>
+            <a:r>
+              <a:rPr sz="1800" b="0" dirty="0" err="1">
+                <a:solidFill>
+                  <a:srgbClr val="5E656B"/>
+                </a:solidFill>
+                <a:latin typeface="Aptos"/>
+              </a:rPr>
+              <a:t>run_eval.py</a:t>
+            </a:r>
+            <a:r>
+              <a:rPr sz="1800" b="0" dirty="0">
+                <a:solidFill>
+                  <a:srgbClr val="5E656B"/>
+                </a:solidFill>
+                <a:latin typeface="Aptos"/>
+              </a:rPr>
+              <a:t>
+</a:t>
+            </a:r>
+            <a:r>
+              <a:rPr sz="1800" b="0" dirty="0" err="1">
+                <a:solidFill>
+                  <a:srgbClr val="5E656B"/>
+                </a:solidFill>
+                <a:latin typeface="Aptos"/>
+              </a:rPr>
+              <a:t>collect_metrics.py</a:t>
+            </a:r>
+            <a:endParaRPr sz="1800" b="0" dirty="0">
+              <a:solidFill>
+                <a:srgbClr val="5E656B"/>
+              </a:solidFill>
+              <a:latin typeface="Aptos"/>
+            </a:endParaRPr>
           </a:p>
         </p:txBody>
       </p:sp>
@@ -9765,6 +10441,7 @@
           <a:lstStyle/>
           <a:p>
             <a:pPr algn="ctr"/>
+            <a:endParaRPr/>
           </a:p>
         </p:txBody>
       </p:sp>
@@ -9811,8 +10488,8 @@
         </p:nvSpPr>
         <p:spPr>
           <a:xfrm>
-            <a:off x="5303520" y="2852928"/>
-            <a:ext cx="1463040" cy="365760"/>
+            <a:off x="5303520" y="2852927"/>
+            <a:ext cx="1463040" cy="482317"/>
           </a:xfrm>
           <a:prstGeom prst="roundRect">
             <a:avLst/>
@@ -9845,6 +10522,7 @@
           <a:lstStyle/>
           <a:p>
             <a:pPr algn="ctr"/>
+            <a:endParaRPr sz="3600"/>
           </a:p>
         </p:txBody>
       </p:sp>
@@ -9857,7 +10535,7 @@
         <p:spPr>
           <a:xfrm>
             <a:off x="5303520" y="2880360"/>
-            <a:ext cx="1463040" cy="365760"/>
+            <a:ext cx="1463040" cy="461665"/>
           </a:xfrm>
           <a:prstGeom prst="rect">
             <a:avLst/>
@@ -9872,7 +10550,7 @@
           <a:p>
             <a:pPr algn="ctr"/>
             <a:r>
-              <a:rPr sz="1200" b="1">
+              <a:rPr sz="2400" b="1">
                 <a:solidFill>
                   <a:srgbClr val="BF5A24"/>
                 </a:solidFill>
@@ -9962,6 +10640,7 @@
           <a:lstStyle/>
           <a:p>
             <a:pPr algn="ctr"/>
+            <a:endParaRPr/>
           </a:p>
         </p:txBody>
       </p:sp>
@@ -10008,8 +10687,8 @@
         </p:nvSpPr>
         <p:spPr>
           <a:xfrm>
-            <a:off x="8988552" y="2852928"/>
-            <a:ext cx="1463040" cy="365760"/>
+            <a:off x="8988552" y="2852927"/>
+            <a:ext cx="1463040" cy="482317"/>
           </a:xfrm>
           <a:prstGeom prst="roundRect">
             <a:avLst/>
@@ -10042,6 +10721,7 @@
           <a:lstStyle/>
           <a:p>
             <a:pPr algn="ctr"/>
+            <a:endParaRPr sz="3600"/>
           </a:p>
         </p:txBody>
       </p:sp>
@@ -10054,7 +10734,7 @@
         <p:spPr>
           <a:xfrm>
             <a:off x="8988552" y="2880360"/>
-            <a:ext cx="1463040" cy="365760"/>
+            <a:ext cx="1463040" cy="461665"/>
           </a:xfrm>
           <a:prstGeom prst="rect">
             <a:avLst/>
@@ -10069,7 +10749,7 @@
           <a:p>
             <a:pPr algn="ctr"/>
             <a:r>
-              <a:rPr sz="1200" b="1">
+              <a:rPr sz="2400" b="1">
                 <a:solidFill>
                   <a:srgbClr val="BF5A24"/>
                 </a:solidFill>
@@ -10126,7 +10806,7 @@
 </file>
 
 <file path=ppt/slides/slide7.xml><?xml version="1.0" encoding="utf-8"?>
-<p:sld xmlns:a="http://schemas.openxmlformats.org/drawingml/2006/main" xmlns:p="http://schemas.openxmlformats.org/presentationml/2006/main" xmlns:r="http://schemas.openxmlformats.org/officeDocument/2006/relationships">
+<p:sld xmlns:a="http://schemas.openxmlformats.org/drawingml/2006/main" xmlns:r="http://schemas.openxmlformats.org/officeDocument/2006/relationships" xmlns:p="http://schemas.openxmlformats.org/presentationml/2006/main">
   <p:cSld>
     <p:bg>
       <p:bgPr>
@@ -10142,7 +10822,14 @@
         <p:cNvGrpSpPr/>
         <p:nvPr/>
       </p:nvGrpSpPr>
-      <p:grpSpPr/>
+      <p:grpSpPr>
+        <a:xfrm>
+          <a:off x="0" y="0"/>
+          <a:ext cx="0" cy="0"/>
+          <a:chOff x="0" y="0"/>
+          <a:chExt cx="0" cy="0"/>
+        </a:xfrm>
+      </p:grpSpPr>
       <p:sp>
         <p:nvSpPr>
           <p:cNvPr id="2" name="TextBox 1"/>
@@ -10253,6 +10940,7 @@
           <a:lstStyle/>
           <a:p>
             <a:pPr algn="ctr"/>
+            <a:endParaRPr/>
           </a:p>
         </p:txBody>
       </p:sp>
@@ -10298,6 +10986,7 @@
           <a:lstStyle/>
           <a:p>
             <a:pPr algn="ctr"/>
+            <a:endParaRPr/>
           </a:p>
         </p:txBody>
       </p:sp>
@@ -10343,6 +11032,7 @@
           <a:lstStyle/>
           <a:p>
             <a:pPr algn="ctr"/>
+            <a:endParaRPr/>
           </a:p>
         </p:txBody>
       </p:sp>
@@ -10355,7 +11045,7 @@
         <p:spPr>
           <a:xfrm>
             <a:off x="1188720" y="2359152"/>
-            <a:ext cx="1554480" cy="384048"/>
+            <a:ext cx="1554480" cy="338554"/>
           </a:xfrm>
           <a:prstGeom prst="rect">
             <a:avLst/>
@@ -10370,7 +11060,7 @@
           <a:p>
             <a:pPr algn="ctr"/>
             <a:r>
-              <a:rPr sz="1200" b="1">
+              <a:rPr sz="1600" b="1" dirty="0">
                 <a:solidFill>
                   <a:srgbClr val="BF5A24"/>
                 </a:solidFill>
@@ -10459,6 +11149,7 @@
           <a:lstStyle/>
           <a:p>
             <a:pPr algn="ctr"/>
+            <a:endParaRPr/>
           </a:p>
         </p:txBody>
       </p:sp>
@@ -10471,7 +11162,7 @@
         <p:spPr>
           <a:xfrm>
             <a:off x="6931152" y="2331720"/>
-            <a:ext cx="2148840" cy="384048"/>
+            <a:ext cx="2843468" cy="384048"/>
           </a:xfrm>
           <a:prstGeom prst="roundRect">
             <a:avLst/>
@@ -10504,6 +11195,7 @@
           <a:lstStyle/>
           <a:p>
             <a:pPr algn="ctr"/>
+            <a:endParaRPr/>
           </a:p>
         </p:txBody>
       </p:sp>
@@ -10515,8 +11207,8 @@
         </p:nvSpPr>
         <p:spPr>
           <a:xfrm>
-            <a:off x="6931152" y="2359152"/>
-            <a:ext cx="2148840" cy="384048"/>
+            <a:off x="6931151" y="2359152"/>
+            <a:ext cx="2843469" cy="338554"/>
           </a:xfrm>
           <a:prstGeom prst="rect">
             <a:avLst/>
@@ -10531,7 +11223,7 @@
           <a:p>
             <a:pPr algn="ctr"/>
             <a:r>
-              <a:rPr sz="1200" b="1">
+              <a:rPr sz="1600" b="1" dirty="0">
                 <a:solidFill>
                   <a:srgbClr val="BF5A24"/>
                 </a:solidFill>
@@ -10622,7 +11314,7 @@
 </file>
 
 <file path=ppt/slides/slide8.xml><?xml version="1.0" encoding="utf-8"?>
-<p:sld xmlns:a="http://schemas.openxmlformats.org/drawingml/2006/main" xmlns:p="http://schemas.openxmlformats.org/presentationml/2006/main" xmlns:r="http://schemas.openxmlformats.org/officeDocument/2006/relationships">
+<p:sld xmlns:a="http://schemas.openxmlformats.org/drawingml/2006/main" xmlns:r="http://schemas.openxmlformats.org/officeDocument/2006/relationships" xmlns:p="http://schemas.openxmlformats.org/presentationml/2006/main">
   <p:cSld>
     <p:bg>
       <p:bgPr>
@@ -10638,7 +11330,14 @@
         <p:cNvGrpSpPr/>
         <p:nvPr/>
       </p:nvGrpSpPr>
-      <p:grpSpPr/>
+      <p:grpSpPr>
+        <a:xfrm>
+          <a:off x="0" y="0"/>
+          <a:ext cx="0" cy="0"/>
+          <a:chOff x="0" y="0"/>
+          <a:chExt cx="0" cy="0"/>
+        </a:xfrm>
+      </p:grpSpPr>
       <p:sp>
         <p:nvSpPr>
           <p:cNvPr id="2" name="TextBox 1"/>
@@ -10749,6 +11448,7 @@
           <a:lstStyle/>
           <a:p>
             <a:pPr algn="ctr"/>
+            <a:endParaRPr/>
           </a:p>
         </p:txBody>
       </p:sp>
@@ -10794,6 +11494,7 @@
           <a:lstStyle/>
           <a:p>
             <a:pPr algn="ctr"/>
+            <a:endParaRPr/>
           </a:p>
         </p:txBody>
       </p:sp>
@@ -10946,6 +11647,7 @@
           <a:lstStyle/>
           <a:p>
             <a:pPr algn="ctr"/>
+            <a:endParaRPr/>
           </a:p>
         </p:txBody>
       </p:sp>
@@ -11098,6 +11800,7 @@
           <a:lstStyle/>
           <a:p>
             <a:pPr algn="ctr"/>
+            <a:endParaRPr/>
           </a:p>
         </p:txBody>
       </p:sp>
@@ -11145,7 +11848,7 @@
 </file>
 
 <file path=ppt/slides/slide9.xml><?xml version="1.0" encoding="utf-8"?>
-<p:sld xmlns:a="http://schemas.openxmlformats.org/drawingml/2006/main" xmlns:p="http://schemas.openxmlformats.org/presentationml/2006/main" xmlns:r="http://schemas.openxmlformats.org/officeDocument/2006/relationships">
+<p:sld xmlns:a="http://schemas.openxmlformats.org/drawingml/2006/main" xmlns:r="http://schemas.openxmlformats.org/officeDocument/2006/relationships" xmlns:p="http://schemas.openxmlformats.org/presentationml/2006/main">
   <p:cSld>
     <p:bg>
       <p:bgPr>
@@ -11161,7 +11864,14 @@
         <p:cNvGrpSpPr/>
         <p:nvPr/>
       </p:nvGrpSpPr>
-      <p:grpSpPr/>
+      <p:grpSpPr>
+        <a:xfrm>
+          <a:off x="0" y="0"/>
+          <a:ext cx="0" cy="0"/>
+          <a:chOff x="0" y="0"/>
+          <a:chExt cx="0" cy="0"/>
+        </a:xfrm>
+      </p:grpSpPr>
       <p:sp>
         <p:nvSpPr>
           <p:cNvPr id="2" name="TextBox 1"/>
@@ -11272,6 +11982,7 @@
           <a:lstStyle/>
           <a:p>
             <a:pPr algn="ctr"/>
+            <a:endParaRPr/>
           </a:p>
         </p:txBody>
       </p:sp>
@@ -11317,6 +12028,7 @@
           <a:lstStyle/>
           <a:p>
             <a:pPr algn="ctr"/>
+            <a:endParaRPr/>
           </a:p>
         </p:txBody>
       </p:sp>
@@ -11362,6 +12074,7 @@
           <a:lstStyle/>
           <a:p>
             <a:pPr algn="ctr"/>
+            <a:endParaRPr/>
           </a:p>
         </p:txBody>
       </p:sp>
@@ -11549,6 +12262,7 @@
           <a:lstStyle/>
           <a:p>
             <a:pPr algn="ctr"/>
+            <a:endParaRPr/>
           </a:p>
         </p:txBody>
       </p:sp>
@@ -11878,4 +12592,319 @@
   </a:objectDefaults>
   <a:extraClrSchemeLst/>
 </a:theme>
+</file>
+
+<file path=ppt/theme/theme2.xml><?xml version="1.0" encoding="utf-8"?>
+<a:theme xmlns:a="http://schemas.openxmlformats.org/drawingml/2006/main" name="Office Theme">
+  <a:themeElements>
+    <a:clrScheme name="Office">
+      <a:dk1>
+        <a:sysClr val="windowText" lastClr="000000"/>
+      </a:dk1>
+      <a:lt1>
+        <a:sysClr val="window" lastClr="FFFFFF"/>
+      </a:lt1>
+      <a:dk2>
+        <a:srgbClr val="0E2841"/>
+      </a:dk2>
+      <a:lt2>
+        <a:srgbClr val="E8E8E8"/>
+      </a:lt2>
+      <a:accent1>
+        <a:srgbClr val="156082"/>
+      </a:accent1>
+      <a:accent2>
+        <a:srgbClr val="E97132"/>
+      </a:accent2>
+      <a:accent3>
+        <a:srgbClr val="196B24"/>
+      </a:accent3>
+      <a:accent4>
+        <a:srgbClr val="0F9ED5"/>
+      </a:accent4>
+      <a:accent5>
+        <a:srgbClr val="A02B93"/>
+      </a:accent5>
+      <a:accent6>
+        <a:srgbClr val="4EA72E"/>
+      </a:accent6>
+      <a:hlink>
+        <a:srgbClr val="467886"/>
+      </a:hlink>
+      <a:folHlink>
+        <a:srgbClr val="96607D"/>
+      </a:folHlink>
+    </a:clrScheme>
+    <a:fontScheme name="Office">
+      <a:majorFont>
+        <a:latin typeface="Aptos Display" panose="02110004020202020204"/>
+        <a:ea typeface=""/>
+        <a:cs typeface=""/>
+        <a:font script="Jpan" typeface="游ゴシック Light"/>
+        <a:font script="Hang" typeface="맑은 고딕"/>
+        <a:font script="Hans" typeface="等线 Light"/>
+        <a:font script="Hant" typeface="新細明體"/>
+        <a:font script="Arab" typeface="Times New Roman"/>
+        <a:font script="Hebr" typeface="Times New Roman"/>
+        <a:font script="Thai" typeface="Angsana New"/>
+        <a:font script="Ethi" typeface="Nyala"/>
+        <a:font script="Beng" typeface="Vrinda"/>
+        <a:font script="Gujr" typeface="Shruti"/>
+        <a:font script="Khmr" typeface="MoolBoran"/>
+        <a:font script="Knda" typeface="Tunga"/>
+        <a:font script="Guru" typeface="Raavi"/>
+        <a:font script="Cans" typeface="Euphemia"/>
+        <a:font script="Cher" typeface="Plantagenet Cherokee"/>
+        <a:font script="Yiii" typeface="Microsoft Yi Baiti"/>
+        <a:font script="Tibt" typeface="Microsoft Himalaya"/>
+        <a:font script="Thaa" typeface="MV Boli"/>
+        <a:font script="Deva" typeface="Mangal"/>
+        <a:font script="Telu" typeface="Gautami"/>
+        <a:font script="Taml" typeface="Latha"/>
+        <a:font script="Syrc" typeface="Estrangelo Edessa"/>
+        <a:font script="Orya" typeface="Kalinga"/>
+        <a:font script="Mlym" typeface="Kartika"/>
+        <a:font script="Laoo" typeface="DokChampa"/>
+        <a:font script="Sinh" typeface="Iskoola Pota"/>
+        <a:font script="Mong" typeface="Mongolian Baiti"/>
+        <a:font script="Viet" typeface="Times New Roman"/>
+        <a:font script="Uigh" typeface="Microsoft Uighur"/>
+        <a:font script="Geor" typeface="Sylfaen"/>
+        <a:font script="Armn" typeface="Arial"/>
+        <a:font script="Bugi" typeface="Leelawadee UI"/>
+        <a:font script="Bopo" typeface="Microsoft JhengHei"/>
+        <a:font script="Java" typeface="Javanese Text"/>
+        <a:font script="Lisu" typeface="Segoe UI"/>
+        <a:font script="Mymr" typeface="Myanmar Text"/>
+        <a:font script="Nkoo" typeface="Ebrima"/>
+        <a:font script="Olck" typeface="Nirmala UI"/>
+        <a:font script="Osma" typeface="Ebrima"/>
+        <a:font script="Phag" typeface="Phagspa"/>
+        <a:font script="Syrn" typeface="Estrangelo Edessa"/>
+        <a:font script="Syrj" typeface="Estrangelo Edessa"/>
+        <a:font script="Syre" typeface="Estrangelo Edessa"/>
+        <a:font script="Sora" typeface="Nirmala UI"/>
+        <a:font script="Tale" typeface="Microsoft Tai Le"/>
+        <a:font script="Talu" typeface="Microsoft New Tai Lue"/>
+        <a:font script="Tfng" typeface="Ebrima"/>
+      </a:majorFont>
+      <a:minorFont>
+        <a:latin typeface="Aptos" panose="02110004020202020204"/>
+        <a:ea typeface=""/>
+        <a:cs typeface=""/>
+        <a:font script="Jpan" typeface="游ゴシック"/>
+        <a:font script="Hang" typeface="맑은 고딕"/>
+        <a:font script="Hans" typeface="等线"/>
+        <a:font script="Hant" typeface="新細明體"/>
+        <a:font script="Arab" typeface="Arial"/>
+        <a:font script="Hebr" typeface="Arial"/>
+        <a:font script="Thai" typeface="Cordia New"/>
+        <a:font script="Ethi" typeface="Nyala"/>
+        <a:font script="Beng" typeface="Vrinda"/>
+        <a:font script="Gujr" typeface="Shruti"/>
+        <a:font script="Khmr" typeface="DaunPenh"/>
+        <a:font script="Knda" typeface="Tunga"/>
+        <a:font script="Guru" typeface="Raavi"/>
+        <a:font script="Cans" typeface="Euphemia"/>
+        <a:font script="Cher" typeface="Plantagenet Cherokee"/>
+        <a:font script="Yiii" typeface="Microsoft Yi Baiti"/>
+        <a:font script="Tibt" typeface="Microsoft Himalaya"/>
+        <a:font script="Thaa" typeface="MV Boli"/>
+        <a:font script="Deva" typeface="Mangal"/>
+        <a:font script="Telu" typeface="Gautami"/>
+        <a:font script="Taml" typeface="Latha"/>
+        <a:font script="Syrc" typeface="Estrangelo Edessa"/>
+        <a:font script="Orya" typeface="Kalinga"/>
+        <a:font script="Mlym" typeface="Kartika"/>
+        <a:font script="Laoo" typeface="DokChampa"/>
+        <a:font script="Sinh" typeface="Iskoola Pota"/>
+        <a:font script="Mong" typeface="Mongolian Baiti"/>
+        <a:font script="Viet" typeface="Arial"/>
+        <a:font script="Uigh" typeface="Microsoft Uighur"/>
+        <a:font script="Geor" typeface="Sylfaen"/>
+        <a:font script="Armn" typeface="Arial"/>
+        <a:font script="Bugi" typeface="Leelawadee UI"/>
+        <a:font script="Bopo" typeface="Microsoft JhengHei"/>
+        <a:font script="Java" typeface="Javanese Text"/>
+        <a:font script="Lisu" typeface="Segoe UI"/>
+        <a:font script="Mymr" typeface="Myanmar Text"/>
+        <a:font script="Nkoo" typeface="Ebrima"/>
+        <a:font script="Olck" typeface="Nirmala UI"/>
+        <a:font script="Osma" typeface="Ebrima"/>
+        <a:font script="Phag" typeface="Phagspa"/>
+        <a:font script="Syrn" typeface="Estrangelo Edessa"/>
+        <a:font script="Syrj" typeface="Estrangelo Edessa"/>
+        <a:font script="Syre" typeface="Estrangelo Edessa"/>
+        <a:font script="Sora" typeface="Nirmala UI"/>
+        <a:font script="Tale" typeface="Microsoft Tai Le"/>
+        <a:font script="Talu" typeface="Microsoft New Tai Lue"/>
+        <a:font script="Tfng" typeface="Ebrima"/>
+      </a:minorFont>
+    </a:fontScheme>
+    <a:fmtScheme name="Office">
+      <a:fillStyleLst>
+        <a:solidFill>
+          <a:schemeClr val="phClr"/>
+        </a:solidFill>
+        <a:gradFill rotWithShape="1">
+          <a:gsLst>
+            <a:gs pos="0">
+              <a:schemeClr val="phClr">
+                <a:lumMod val="110000"/>
+                <a:satMod val="105000"/>
+                <a:tint val="67000"/>
+              </a:schemeClr>
+            </a:gs>
+            <a:gs pos="50000">
+              <a:schemeClr val="phClr">
+                <a:lumMod val="105000"/>
+                <a:satMod val="103000"/>
+                <a:tint val="73000"/>
+              </a:schemeClr>
+            </a:gs>
+            <a:gs pos="100000">
+              <a:schemeClr val="phClr">
+                <a:lumMod val="105000"/>
+                <a:satMod val="109000"/>
+                <a:tint val="81000"/>
+              </a:schemeClr>
+            </a:gs>
+          </a:gsLst>
+          <a:lin ang="5400000" scaled="0"/>
+        </a:gradFill>
+        <a:gradFill rotWithShape="1">
+          <a:gsLst>
+            <a:gs pos="0">
+              <a:schemeClr val="phClr">
+                <a:satMod val="103000"/>
+                <a:lumMod val="102000"/>
+                <a:tint val="94000"/>
+              </a:schemeClr>
+            </a:gs>
+            <a:gs pos="50000">
+              <a:schemeClr val="phClr">
+                <a:satMod val="110000"/>
+                <a:lumMod val="100000"/>
+                <a:shade val="100000"/>
+              </a:schemeClr>
+            </a:gs>
+            <a:gs pos="100000">
+              <a:schemeClr val="phClr">
+                <a:lumMod val="99000"/>
+                <a:satMod val="120000"/>
+                <a:shade val="78000"/>
+              </a:schemeClr>
+            </a:gs>
+          </a:gsLst>
+          <a:lin ang="5400000" scaled="0"/>
+        </a:gradFill>
+      </a:fillStyleLst>
+      <a:lnStyleLst>
+        <a:ln w="12700" cap="flat" cmpd="sng" algn="ctr">
+          <a:solidFill>
+            <a:schemeClr val="phClr"/>
+          </a:solidFill>
+          <a:prstDash val="solid"/>
+          <a:miter lim="800000"/>
+        </a:ln>
+        <a:ln w="19050" cap="flat" cmpd="sng" algn="ctr">
+          <a:solidFill>
+            <a:schemeClr val="phClr"/>
+          </a:solidFill>
+          <a:prstDash val="solid"/>
+          <a:miter lim="800000"/>
+        </a:ln>
+        <a:ln w="25400" cap="flat" cmpd="sng" algn="ctr">
+          <a:solidFill>
+            <a:schemeClr val="phClr"/>
+          </a:solidFill>
+          <a:prstDash val="solid"/>
+          <a:miter lim="800000"/>
+        </a:ln>
+      </a:lnStyleLst>
+      <a:effectStyleLst>
+        <a:effectStyle>
+          <a:effectLst/>
+        </a:effectStyle>
+        <a:effectStyle>
+          <a:effectLst/>
+        </a:effectStyle>
+        <a:effectStyle>
+          <a:effectLst>
+            <a:outerShdw blurRad="57150" dist="19050" dir="5400000" algn="ctr" rotWithShape="0">
+              <a:srgbClr val="000000">
+                <a:alpha val="63000"/>
+              </a:srgbClr>
+            </a:outerShdw>
+          </a:effectLst>
+        </a:effectStyle>
+      </a:effectStyleLst>
+      <a:bgFillStyleLst>
+        <a:solidFill>
+          <a:schemeClr val="phClr"/>
+        </a:solidFill>
+        <a:solidFill>
+          <a:schemeClr val="phClr">
+            <a:tint val="95000"/>
+            <a:satMod val="170000"/>
+          </a:schemeClr>
+        </a:solidFill>
+        <a:gradFill rotWithShape="1">
+          <a:gsLst>
+            <a:gs pos="0">
+              <a:schemeClr val="phClr">
+                <a:tint val="93000"/>
+                <a:satMod val="150000"/>
+                <a:shade val="98000"/>
+                <a:lumMod val="102000"/>
+              </a:schemeClr>
+            </a:gs>
+            <a:gs pos="50000">
+              <a:schemeClr val="phClr">
+                <a:tint val="98000"/>
+                <a:satMod val="130000"/>
+                <a:shade val="90000"/>
+                <a:lumMod val="103000"/>
+              </a:schemeClr>
+            </a:gs>
+            <a:gs pos="100000">
+              <a:schemeClr val="phClr">
+                <a:shade val="63000"/>
+                <a:satMod val="120000"/>
+              </a:schemeClr>
+            </a:gs>
+          </a:gsLst>
+          <a:lin ang="5400000" scaled="0"/>
+        </a:gradFill>
+      </a:bgFillStyleLst>
+    </a:fmtScheme>
+  </a:themeElements>
+  <a:objectDefaults>
+    <a:lnDef>
+      <a:spPr/>
+      <a:bodyPr/>
+      <a:lstStyle/>
+      <a:style>
+        <a:lnRef idx="2">
+          <a:schemeClr val="accent1"/>
+        </a:lnRef>
+        <a:fillRef idx="0">
+          <a:schemeClr val="accent1"/>
+        </a:fillRef>
+        <a:effectRef idx="1">
+          <a:schemeClr val="accent1"/>
+        </a:effectRef>
+        <a:fontRef idx="minor">
+          <a:schemeClr val="tx1"/>
+        </a:fontRef>
+      </a:style>
+    </a:lnDef>
+  </a:objectDefaults>
+  <a:extraClrSchemeLst/>
+  <a:extLst>
+    <a:ext uri="{05A4C25C-085E-4340-85A3-A5531E510DB2}">
+      <thm15:themeFamily xmlns:thm15="http://schemas.microsoft.com/office/thememl/2012/main" name="Office Theme" id="{2E142A2C-CD16-42D6-873A-C26D2A0506FA}" vid="{1BDDFF52-6CD6-40A5-AB3C-68EB2F1E4D0A}"/>
+    </a:ext>
+  </a:extLst>
+</a:theme>
 </file>
</xml_diff>

<commit_message>
docs: manage public source mirror explicitly
</commit_message>
<xml_diff>
--- a/docs/source/TP Prompt Ingénierie.pptx
+++ b/docs/source/TP Prompt Ingénierie.pptx
@@ -4,22 +4,19 @@
   <p:sldMasterIdLst>
     <p:sldMasterId id="2147483648" r:id="rId1"/>
   </p:sldMasterIdLst>
-  <p:notesMasterIdLst>
-    <p:notesMasterId r:id="rId12"/>
-  </p:notesMasterIdLst>
   <p:sldIdLst>
-    <p:sldId id="256" r:id="rId2"/>
-    <p:sldId id="257" r:id="rId3"/>
-    <p:sldId id="258" r:id="rId4"/>
-    <p:sldId id="259" r:id="rId5"/>
-    <p:sldId id="260" r:id="rId6"/>
-    <p:sldId id="261" r:id="rId7"/>
-    <p:sldId id="262" r:id="rId8"/>
-    <p:sldId id="263" r:id="rId9"/>
-    <p:sldId id="264" r:id="rId10"/>
-    <p:sldId id="265" r:id="rId11"/>
+    <p:sldId id="256" r:id="rId7"/>
+    <p:sldId id="257" r:id="rId8"/>
+    <p:sldId id="258" r:id="rId9"/>
+    <p:sldId id="259" r:id="rId10"/>
+    <p:sldId id="260" r:id="rId11"/>
+    <p:sldId id="261" r:id="rId12"/>
+    <p:sldId id="262" r:id="rId13"/>
+    <p:sldId id="263" r:id="rId14"/>
+    <p:sldId id="264" r:id="rId15"/>
+    <p:sldId id="265" r:id="rId16"/>
   </p:sldIdLst>
-  <p:sldSz cx="12192000" cy="6858000"/>
+  <p:sldSz cx="12191695" cy="6858000" type="screen4x3"/>
   <p:notesSz cx="6858000" cy="9144000"/>
   <p:defaultTextStyle>
     <a:defPPr>
@@ -116,457 +113,7 @@
       </a:defRPr>
     </a:lvl9pPr>
   </p:defaultTextStyle>
-  <p:extLst>
-    <p:ext uri="{EFAFB233-063F-42B5-8137-9DF3F51BA10A}">
-      <p15:sldGuideLst xmlns:p15="http://schemas.microsoft.com/office/powerpoint/2012/main">
-        <p15:guide id="1" orient="horz" pos="2160">
-          <p15:clr>
-            <a:srgbClr val="A4A3A4"/>
-          </p15:clr>
-        </p15:guide>
-        <p15:guide id="2" pos="2880">
-          <p15:clr>
-            <a:srgbClr val="A4A3A4"/>
-          </p15:clr>
-        </p15:guide>
-      </p15:sldGuideLst>
-    </p:ext>
-  </p:extLst>
 </p:presentation>
-</file>
-
-<file path=ppt/notesMasters/notesMaster1.xml><?xml version="1.0" encoding="utf-8"?>
-<p:notesMaster xmlns:a="http://schemas.openxmlformats.org/drawingml/2006/main" xmlns:r="http://schemas.openxmlformats.org/officeDocument/2006/relationships" xmlns:p="http://schemas.openxmlformats.org/presentationml/2006/main">
-  <p:cSld>
-    <p:bg>
-      <p:bgRef idx="1001">
-        <a:schemeClr val="bg1"/>
-      </p:bgRef>
-    </p:bg>
-    <p:spTree>
-      <p:nvGrpSpPr>
-        <p:cNvPr id="1" name=""/>
-        <p:cNvGrpSpPr/>
-        <p:nvPr/>
-      </p:nvGrpSpPr>
-      <p:grpSpPr>
-        <a:xfrm>
-          <a:off x="0" y="0"/>
-          <a:ext cx="0" cy="0"/>
-          <a:chOff x="0" y="0"/>
-          <a:chExt cx="0" cy="0"/>
-        </a:xfrm>
-      </p:grpSpPr>
-      <p:sp>
-        <p:nvSpPr>
-          <p:cNvPr id="2" name="Header Placeholder 1"/>
-          <p:cNvSpPr>
-            <a:spLocks noGrp="1"/>
-          </p:cNvSpPr>
-          <p:nvPr>
-            <p:ph type="hdr" sz="quarter"/>
-          </p:nvPr>
-        </p:nvSpPr>
-        <p:spPr>
-          <a:xfrm>
-            <a:off x="0" y="0"/>
-            <a:ext cx="2971800" cy="458788"/>
-          </a:xfrm>
-          <a:prstGeom prst="rect">
-            <a:avLst/>
-          </a:prstGeom>
-        </p:spPr>
-        <p:txBody>
-          <a:bodyPr vert="horz" lIns="91440" tIns="45720" rIns="91440" bIns="45720" rtlCol="0"/>
-          <a:lstStyle>
-            <a:lvl1pPr algn="l">
-              <a:defRPr sz="1200"/>
-            </a:lvl1pPr>
-          </a:lstStyle>
-          <a:p>
-            <a:endParaRPr lang="fr-FR"/>
-          </a:p>
-        </p:txBody>
-      </p:sp>
-      <p:sp>
-        <p:nvSpPr>
-          <p:cNvPr id="3" name="Date Placeholder 2"/>
-          <p:cNvSpPr>
-            <a:spLocks noGrp="1"/>
-          </p:cNvSpPr>
-          <p:nvPr>
-            <p:ph type="dt" idx="1"/>
-          </p:nvPr>
-        </p:nvSpPr>
-        <p:spPr>
-          <a:xfrm>
-            <a:off x="3884613" y="0"/>
-            <a:ext cx="2971800" cy="458788"/>
-          </a:xfrm>
-          <a:prstGeom prst="rect">
-            <a:avLst/>
-          </a:prstGeom>
-        </p:spPr>
-        <p:txBody>
-          <a:bodyPr vert="horz" lIns="91440" tIns="45720" rIns="91440" bIns="45720" rtlCol="0"/>
-          <a:lstStyle>
-            <a:lvl1pPr algn="r">
-              <a:defRPr sz="1200"/>
-            </a:lvl1pPr>
-          </a:lstStyle>
-          <a:p>
-            <a:fld id="{26361D52-3F77-7740-AEA3-A94937B14596}" type="datetimeFigureOut">
-              <a:rPr lang="fr-FR" smtClean="0"/>
-              <a:t>13/04/2026</a:t>
-            </a:fld>
-            <a:endParaRPr lang="fr-FR"/>
-          </a:p>
-        </p:txBody>
-      </p:sp>
-      <p:sp>
-        <p:nvSpPr>
-          <p:cNvPr id="4" name="Slide Image Placeholder 3"/>
-          <p:cNvSpPr>
-            <a:spLocks noGrp="1" noRot="1" noChangeAspect="1"/>
-          </p:cNvSpPr>
-          <p:nvPr>
-            <p:ph type="sldImg" idx="2"/>
-          </p:nvPr>
-        </p:nvSpPr>
-        <p:spPr>
-          <a:xfrm>
-            <a:off x="685800" y="1143000"/>
-            <a:ext cx="5486400" cy="3086100"/>
-          </a:xfrm>
-          <a:prstGeom prst="rect">
-            <a:avLst/>
-          </a:prstGeom>
-          <a:noFill/>
-          <a:ln w="12700">
-            <a:solidFill>
-              <a:prstClr val="black"/>
-            </a:solidFill>
-          </a:ln>
-        </p:spPr>
-        <p:txBody>
-          <a:bodyPr vert="horz" lIns="91440" tIns="45720" rIns="91440" bIns="45720" rtlCol="0" anchor="ctr"/>
-          <a:lstStyle/>
-          <a:p>
-            <a:endParaRPr lang="fr-FR"/>
-          </a:p>
-        </p:txBody>
-      </p:sp>
-      <p:sp>
-        <p:nvSpPr>
-          <p:cNvPr id="5" name="Notes Placeholder 4"/>
-          <p:cNvSpPr>
-            <a:spLocks noGrp="1"/>
-          </p:cNvSpPr>
-          <p:nvPr>
-            <p:ph type="body" sz="quarter" idx="3"/>
-          </p:nvPr>
-        </p:nvSpPr>
-        <p:spPr>
-          <a:xfrm>
-            <a:off x="685800" y="4400550"/>
-            <a:ext cx="5486400" cy="3600450"/>
-          </a:xfrm>
-          <a:prstGeom prst="rect">
-            <a:avLst/>
-          </a:prstGeom>
-        </p:spPr>
-        <p:txBody>
-          <a:bodyPr vert="horz" lIns="91440" tIns="45720" rIns="91440" bIns="45720" rtlCol="0"/>
-          <a:lstStyle/>
-          <a:p>
-            <a:pPr lvl="0"/>
-            <a:r>
-              <a:rPr lang="en-GB"/>
-              <a:t>Click to edit Master text styles</a:t>
-            </a:r>
-          </a:p>
-          <a:p>
-            <a:pPr lvl="1"/>
-            <a:r>
-              <a:rPr lang="en-GB"/>
-              <a:t>Second level</a:t>
-            </a:r>
-          </a:p>
-          <a:p>
-            <a:pPr lvl="2"/>
-            <a:r>
-              <a:rPr lang="en-GB"/>
-              <a:t>Third level</a:t>
-            </a:r>
-          </a:p>
-          <a:p>
-            <a:pPr lvl="3"/>
-            <a:r>
-              <a:rPr lang="en-GB"/>
-              <a:t>Fourth level</a:t>
-            </a:r>
-          </a:p>
-          <a:p>
-            <a:pPr lvl="4"/>
-            <a:r>
-              <a:rPr lang="en-GB"/>
-              <a:t>Fifth level</a:t>
-            </a:r>
-            <a:endParaRPr lang="fr-FR"/>
-          </a:p>
-        </p:txBody>
-      </p:sp>
-      <p:sp>
-        <p:nvSpPr>
-          <p:cNvPr id="6" name="Footer Placeholder 5"/>
-          <p:cNvSpPr>
-            <a:spLocks noGrp="1"/>
-          </p:cNvSpPr>
-          <p:nvPr>
-            <p:ph type="ftr" sz="quarter" idx="4"/>
-          </p:nvPr>
-        </p:nvSpPr>
-        <p:spPr>
-          <a:xfrm>
-            <a:off x="0" y="8685213"/>
-            <a:ext cx="2971800" cy="458787"/>
-          </a:xfrm>
-          <a:prstGeom prst="rect">
-            <a:avLst/>
-          </a:prstGeom>
-        </p:spPr>
-        <p:txBody>
-          <a:bodyPr vert="horz" lIns="91440" tIns="45720" rIns="91440" bIns="45720" rtlCol="0" anchor="b"/>
-          <a:lstStyle>
-            <a:lvl1pPr algn="l">
-              <a:defRPr sz="1200"/>
-            </a:lvl1pPr>
-          </a:lstStyle>
-          <a:p>
-            <a:endParaRPr lang="fr-FR"/>
-          </a:p>
-        </p:txBody>
-      </p:sp>
-      <p:sp>
-        <p:nvSpPr>
-          <p:cNvPr id="7" name="Slide Number Placeholder 6"/>
-          <p:cNvSpPr>
-            <a:spLocks noGrp="1"/>
-          </p:cNvSpPr>
-          <p:nvPr>
-            <p:ph type="sldNum" sz="quarter" idx="5"/>
-          </p:nvPr>
-        </p:nvSpPr>
-        <p:spPr>
-          <a:xfrm>
-            <a:off x="3884613" y="8685213"/>
-            <a:ext cx="2971800" cy="458787"/>
-          </a:xfrm>
-          <a:prstGeom prst="rect">
-            <a:avLst/>
-          </a:prstGeom>
-        </p:spPr>
-        <p:txBody>
-          <a:bodyPr vert="horz" lIns="91440" tIns="45720" rIns="91440" bIns="45720" rtlCol="0" anchor="b"/>
-          <a:lstStyle>
-            <a:lvl1pPr algn="r">
-              <a:defRPr sz="1200"/>
-            </a:lvl1pPr>
-          </a:lstStyle>
-          <a:p>
-            <a:fld id="{5A08E842-F3E3-C74A-9F46-D5E8BD4FC3EA}" type="slidenum">
-              <a:rPr lang="fr-FR" smtClean="0"/>
-              <a:t>‹#›</a:t>
-            </a:fld>
-            <a:endParaRPr lang="fr-FR"/>
-          </a:p>
-        </p:txBody>
-      </p:sp>
-    </p:spTree>
-    <p:extLst>
-      <p:ext uri="{BB962C8B-B14F-4D97-AF65-F5344CB8AC3E}">
-        <p14:creationId xmlns:p14="http://schemas.microsoft.com/office/powerpoint/2010/main" val="3248415340"/>
-      </p:ext>
-    </p:extLst>
-  </p:cSld>
-  <p:clrMap bg1="lt1" tx1="dk1" bg2="lt2" tx2="dk2" accent1="accent1" accent2="accent2" accent3="accent3" accent4="accent4" accent5="accent5" accent6="accent6" hlink="hlink" folHlink="folHlink"/>
-  <p:notesStyle>
-    <a:lvl1pPr marL="0" algn="l" defTabSz="914400" rtl="0" eaLnBrk="1" latinLnBrk="0" hangingPunct="1">
-      <a:defRPr sz="1200" kern="1200">
-        <a:solidFill>
-          <a:schemeClr val="tx1"/>
-        </a:solidFill>
-        <a:latin typeface="+mn-lt"/>
-        <a:ea typeface="+mn-ea"/>
-        <a:cs typeface="+mn-cs"/>
-      </a:defRPr>
-    </a:lvl1pPr>
-    <a:lvl2pPr marL="457200" algn="l" defTabSz="914400" rtl="0" eaLnBrk="1" latinLnBrk="0" hangingPunct="1">
-      <a:defRPr sz="1200" kern="1200">
-        <a:solidFill>
-          <a:schemeClr val="tx1"/>
-        </a:solidFill>
-        <a:latin typeface="+mn-lt"/>
-        <a:ea typeface="+mn-ea"/>
-        <a:cs typeface="+mn-cs"/>
-      </a:defRPr>
-    </a:lvl2pPr>
-    <a:lvl3pPr marL="914400" algn="l" defTabSz="914400" rtl="0" eaLnBrk="1" latinLnBrk="0" hangingPunct="1">
-      <a:defRPr sz="1200" kern="1200">
-        <a:solidFill>
-          <a:schemeClr val="tx1"/>
-        </a:solidFill>
-        <a:latin typeface="+mn-lt"/>
-        <a:ea typeface="+mn-ea"/>
-        <a:cs typeface="+mn-cs"/>
-      </a:defRPr>
-    </a:lvl3pPr>
-    <a:lvl4pPr marL="1371600" algn="l" defTabSz="914400" rtl="0" eaLnBrk="1" latinLnBrk="0" hangingPunct="1">
-      <a:defRPr sz="1200" kern="1200">
-        <a:solidFill>
-          <a:schemeClr val="tx1"/>
-        </a:solidFill>
-        <a:latin typeface="+mn-lt"/>
-        <a:ea typeface="+mn-ea"/>
-        <a:cs typeface="+mn-cs"/>
-      </a:defRPr>
-    </a:lvl4pPr>
-    <a:lvl5pPr marL="1828800" algn="l" defTabSz="914400" rtl="0" eaLnBrk="1" latinLnBrk="0" hangingPunct="1">
-      <a:defRPr sz="1200" kern="1200">
-        <a:solidFill>
-          <a:schemeClr val="tx1"/>
-        </a:solidFill>
-        <a:latin typeface="+mn-lt"/>
-        <a:ea typeface="+mn-ea"/>
-        <a:cs typeface="+mn-cs"/>
-      </a:defRPr>
-    </a:lvl5pPr>
-    <a:lvl6pPr marL="2286000" algn="l" defTabSz="914400" rtl="0" eaLnBrk="1" latinLnBrk="0" hangingPunct="1">
-      <a:defRPr sz="1200" kern="1200">
-        <a:solidFill>
-          <a:schemeClr val="tx1"/>
-        </a:solidFill>
-        <a:latin typeface="+mn-lt"/>
-        <a:ea typeface="+mn-ea"/>
-        <a:cs typeface="+mn-cs"/>
-      </a:defRPr>
-    </a:lvl6pPr>
-    <a:lvl7pPr marL="2743200" algn="l" defTabSz="914400" rtl="0" eaLnBrk="1" latinLnBrk="0" hangingPunct="1">
-      <a:defRPr sz="1200" kern="1200">
-        <a:solidFill>
-          <a:schemeClr val="tx1"/>
-        </a:solidFill>
-        <a:latin typeface="+mn-lt"/>
-        <a:ea typeface="+mn-ea"/>
-        <a:cs typeface="+mn-cs"/>
-      </a:defRPr>
-    </a:lvl7pPr>
-    <a:lvl8pPr marL="3200400" algn="l" defTabSz="914400" rtl="0" eaLnBrk="1" latinLnBrk="0" hangingPunct="1">
-      <a:defRPr sz="1200" kern="1200">
-        <a:solidFill>
-          <a:schemeClr val="tx1"/>
-        </a:solidFill>
-        <a:latin typeface="+mn-lt"/>
-        <a:ea typeface="+mn-ea"/>
-        <a:cs typeface="+mn-cs"/>
-      </a:defRPr>
-    </a:lvl8pPr>
-    <a:lvl9pPr marL="3657600" algn="l" defTabSz="914400" rtl="0" eaLnBrk="1" latinLnBrk="0" hangingPunct="1">
-      <a:defRPr sz="1200" kern="1200">
-        <a:solidFill>
-          <a:schemeClr val="tx1"/>
-        </a:solidFill>
-        <a:latin typeface="+mn-lt"/>
-        <a:ea typeface="+mn-ea"/>
-        <a:cs typeface="+mn-cs"/>
-      </a:defRPr>
-    </a:lvl9pPr>
-  </p:notesStyle>
-</p:notesMaster>
-</file>
-
-<file path=ppt/notesSlides/notesSlide1.xml><?xml version="1.0" encoding="utf-8"?>
-<p:notes xmlns:a="http://schemas.openxmlformats.org/drawingml/2006/main" xmlns:r="http://schemas.openxmlformats.org/officeDocument/2006/relationships" xmlns:p="http://schemas.openxmlformats.org/presentationml/2006/main">
-  <p:cSld>
-    <p:spTree>
-      <p:nvGrpSpPr>
-        <p:cNvPr id="1" name=""/>
-        <p:cNvGrpSpPr/>
-        <p:nvPr/>
-      </p:nvGrpSpPr>
-      <p:grpSpPr>
-        <a:xfrm>
-          <a:off x="0" y="0"/>
-          <a:ext cx="0" cy="0"/>
-          <a:chOff x="0" y="0"/>
-          <a:chExt cx="0" cy="0"/>
-        </a:xfrm>
-      </p:grpSpPr>
-      <p:sp>
-        <p:nvSpPr>
-          <p:cNvPr id="2" name="Slide Image Placeholder 1"/>
-          <p:cNvSpPr>
-            <a:spLocks noGrp="1" noRot="1" noChangeAspect="1"/>
-          </p:cNvSpPr>
-          <p:nvPr>
-            <p:ph type="sldImg"/>
-          </p:nvPr>
-        </p:nvSpPr>
-        <p:spPr/>
-      </p:sp>
-      <p:sp>
-        <p:nvSpPr>
-          <p:cNvPr id="3" name="Notes Placeholder 2"/>
-          <p:cNvSpPr>
-            <a:spLocks noGrp="1"/>
-          </p:cNvSpPr>
-          <p:nvPr>
-            <p:ph type="body" idx="1"/>
-          </p:nvPr>
-        </p:nvSpPr>
-        <p:spPr/>
-        <p:txBody>
-          <a:bodyPr/>
-          <a:lstStyle/>
-          <a:p>
-            <a:endParaRPr lang="fr-FR" dirty="0"/>
-          </a:p>
-        </p:txBody>
-      </p:sp>
-      <p:sp>
-        <p:nvSpPr>
-          <p:cNvPr id="4" name="Slide Number Placeholder 3"/>
-          <p:cNvSpPr>
-            <a:spLocks noGrp="1"/>
-          </p:cNvSpPr>
-          <p:nvPr>
-            <p:ph type="sldNum" sz="quarter" idx="5"/>
-          </p:nvPr>
-        </p:nvSpPr>
-        <p:spPr/>
-        <p:txBody>
-          <a:bodyPr/>
-          <a:lstStyle/>
-          <a:p>
-            <a:fld id="{5A08E842-F3E3-C74A-9F46-D5E8BD4FC3EA}" type="slidenum">
-              <a:rPr lang="fr-FR" smtClean="0"/>
-              <a:t>6</a:t>
-            </a:fld>
-            <a:endParaRPr lang="fr-FR"/>
-          </a:p>
-        </p:txBody>
-      </p:sp>
-    </p:spTree>
-    <p:extLst>
-      <p:ext uri="{BB962C8B-B14F-4D97-AF65-F5344CB8AC3E}">
-        <p14:creationId xmlns:p14="http://schemas.microsoft.com/office/powerpoint/2010/main" val="1836134409"/>
-      </p:ext>
-    </p:extLst>
-  </p:cSld>
-  <p:clrMapOvr>
-    <a:masterClrMapping/>
-  </p:clrMapOvr>
-</p:notes>
 </file>
 
 <file path=ppt/slideLayouts/slideLayout1.xml><?xml version="1.0" encoding="utf-8"?>
@@ -607,9 +154,10 @@
           <a:lstStyle/>
           <a:p>
             <a:r>
-              <a:rPr lang="en-US"/>
+              <a:rPr lang="en-US" smtClean="0"/>
               <a:t>Click to edit Master title style</a:t>
             </a:r>
+            <a:endParaRPr lang="en-US"/>
           </a:p>
         </p:txBody>
       </p:sp>
@@ -725,9 +273,10 @@
           </a:lstStyle>
           <a:p>
             <a:r>
-              <a:rPr lang="en-US"/>
+              <a:rPr lang="en-US" smtClean="0"/>
               <a:t>Click to edit Master subtitle style</a:t>
             </a:r>
+            <a:endParaRPr lang="en-US"/>
           </a:p>
         </p:txBody>
       </p:sp>
@@ -748,7 +297,7 @@
           <a:p>
             <a:fld id="{5BCAD085-E8A6-8845-BD4E-CB4CCA059FC4}" type="datetimeFigureOut">
               <a:rPr lang="en-US" smtClean="0"/>
-              <a:t>4/13/26</a:t>
+              <a:t>1/27/13</a:t>
             </a:fld>
             <a:endParaRPr lang="en-US"/>
           </a:p>
@@ -842,9 +391,10 @@
           <a:lstStyle/>
           <a:p>
             <a:r>
-              <a:rPr lang="en-US"/>
+              <a:rPr lang="en-US" smtClean="0"/>
               <a:t>Click to edit Master title style</a:t>
             </a:r>
+            <a:endParaRPr lang="en-US"/>
           </a:p>
         </p:txBody>
       </p:sp>
@@ -865,37 +415,38 @@
           <a:p>
             <a:pPr lvl="0"/>
             <a:r>
-              <a:rPr lang="en-US"/>
+              <a:rPr lang="en-US" smtClean="0"/>
               <a:t>Click to edit Master text styles</a:t>
             </a:r>
           </a:p>
           <a:p>
             <a:pPr lvl="1"/>
             <a:r>
-              <a:rPr lang="en-US"/>
+              <a:rPr lang="en-US" smtClean="0"/>
               <a:t>Second level</a:t>
             </a:r>
           </a:p>
           <a:p>
             <a:pPr lvl="2"/>
             <a:r>
-              <a:rPr lang="en-US"/>
+              <a:rPr lang="en-US" smtClean="0"/>
               <a:t>Third level</a:t>
             </a:r>
           </a:p>
           <a:p>
             <a:pPr lvl="3"/>
             <a:r>
-              <a:rPr lang="en-US"/>
+              <a:rPr lang="en-US" smtClean="0"/>
               <a:t>Fourth level</a:t>
             </a:r>
           </a:p>
           <a:p>
             <a:pPr lvl="4"/>
             <a:r>
-              <a:rPr lang="en-US"/>
+              <a:rPr lang="en-US" smtClean="0"/>
               <a:t>Fifth level</a:t>
             </a:r>
+            <a:endParaRPr lang="en-US"/>
           </a:p>
         </p:txBody>
       </p:sp>
@@ -916,7 +467,7 @@
           <a:p>
             <a:fld id="{5BCAD085-E8A6-8845-BD4E-CB4CCA059FC4}" type="datetimeFigureOut">
               <a:rPr lang="en-US" smtClean="0"/>
-              <a:t>4/13/26</a:t>
+              <a:t>1/27/13</a:t>
             </a:fld>
             <a:endParaRPr lang="en-US"/>
           </a:p>
@@ -1015,9 +566,10 @@
           <a:lstStyle/>
           <a:p>
             <a:r>
-              <a:rPr lang="en-US"/>
+              <a:rPr lang="en-US" smtClean="0"/>
               <a:t>Click to edit Master title style</a:t>
             </a:r>
+            <a:endParaRPr lang="en-US"/>
           </a:p>
         </p:txBody>
       </p:sp>
@@ -1043,37 +595,38 @@
           <a:p>
             <a:pPr lvl="0"/>
             <a:r>
-              <a:rPr lang="en-US"/>
+              <a:rPr lang="en-US" smtClean="0"/>
               <a:t>Click to edit Master text styles</a:t>
             </a:r>
           </a:p>
           <a:p>
             <a:pPr lvl="1"/>
             <a:r>
-              <a:rPr lang="en-US"/>
+              <a:rPr lang="en-US" smtClean="0"/>
               <a:t>Second level</a:t>
             </a:r>
           </a:p>
           <a:p>
             <a:pPr lvl="2"/>
             <a:r>
-              <a:rPr lang="en-US"/>
+              <a:rPr lang="en-US" smtClean="0"/>
               <a:t>Third level</a:t>
             </a:r>
           </a:p>
           <a:p>
             <a:pPr lvl="3"/>
             <a:r>
-              <a:rPr lang="en-US"/>
+              <a:rPr lang="en-US" smtClean="0"/>
               <a:t>Fourth level</a:t>
             </a:r>
           </a:p>
           <a:p>
             <a:pPr lvl="4"/>
             <a:r>
-              <a:rPr lang="en-US"/>
+              <a:rPr lang="en-US" smtClean="0"/>
               <a:t>Fifth level</a:t>
             </a:r>
+            <a:endParaRPr lang="en-US"/>
           </a:p>
         </p:txBody>
       </p:sp>
@@ -1094,7 +647,7 @@
           <a:p>
             <a:fld id="{5BCAD085-E8A6-8845-BD4E-CB4CCA059FC4}" type="datetimeFigureOut">
               <a:rPr lang="en-US" smtClean="0"/>
-              <a:t>4/13/26</a:t>
+              <a:t>1/27/13</a:t>
             </a:fld>
             <a:endParaRPr lang="en-US"/>
           </a:p>
@@ -1188,9 +741,10 @@
           <a:lstStyle/>
           <a:p>
             <a:r>
-              <a:rPr lang="en-US"/>
+              <a:rPr lang="en-US" smtClean="0"/>
               <a:t>Click to edit Master title style</a:t>
             </a:r>
+            <a:endParaRPr lang="en-US"/>
           </a:p>
         </p:txBody>
       </p:sp>
@@ -1211,37 +765,38 @@
           <a:p>
             <a:pPr lvl="0"/>
             <a:r>
-              <a:rPr lang="en-US"/>
+              <a:rPr lang="en-US" smtClean="0"/>
               <a:t>Click to edit Master text styles</a:t>
             </a:r>
           </a:p>
           <a:p>
             <a:pPr lvl="1"/>
             <a:r>
-              <a:rPr lang="en-US"/>
+              <a:rPr lang="en-US" smtClean="0"/>
               <a:t>Second level</a:t>
             </a:r>
           </a:p>
           <a:p>
             <a:pPr lvl="2"/>
             <a:r>
-              <a:rPr lang="en-US"/>
+              <a:rPr lang="en-US" smtClean="0"/>
               <a:t>Third level</a:t>
             </a:r>
           </a:p>
           <a:p>
             <a:pPr lvl="3"/>
             <a:r>
-              <a:rPr lang="en-US"/>
+              <a:rPr lang="en-US" smtClean="0"/>
               <a:t>Fourth level</a:t>
             </a:r>
           </a:p>
           <a:p>
             <a:pPr lvl="4"/>
             <a:r>
-              <a:rPr lang="en-US"/>
+              <a:rPr lang="en-US" smtClean="0"/>
               <a:t>Fifth level</a:t>
             </a:r>
+            <a:endParaRPr lang="en-US"/>
           </a:p>
         </p:txBody>
       </p:sp>
@@ -1262,7 +817,7 @@
           <a:p>
             <a:fld id="{5BCAD085-E8A6-8845-BD4E-CB4CCA059FC4}" type="datetimeFigureOut">
               <a:rPr lang="en-US" smtClean="0"/>
-              <a:t>4/13/26</a:t>
+              <a:t>1/27/13</a:t>
             </a:fld>
             <a:endParaRPr lang="en-US"/>
           </a:p>
@@ -1365,9 +920,10 @@
           </a:lstStyle>
           <a:p>
             <a:r>
-              <a:rPr lang="en-US"/>
+              <a:rPr lang="en-US" smtClean="0"/>
               <a:t>Click to edit Master title style</a:t>
             </a:r>
+            <a:endParaRPr lang="en-US"/>
           </a:p>
         </p:txBody>
       </p:sp>
@@ -1484,7 +1040,7 @@
           <a:p>
             <a:pPr lvl="0"/>
             <a:r>
-              <a:rPr lang="en-US"/>
+              <a:rPr lang="en-US" smtClean="0"/>
               <a:t>Click to edit Master text styles</a:t>
             </a:r>
           </a:p>
@@ -1507,7 +1063,7 @@
           <a:p>
             <a:fld id="{5BCAD085-E8A6-8845-BD4E-CB4CCA059FC4}" type="datetimeFigureOut">
               <a:rPr lang="en-US" smtClean="0"/>
-              <a:t>4/13/26</a:t>
+              <a:t>1/27/13</a:t>
             </a:fld>
             <a:endParaRPr lang="en-US"/>
           </a:p>
@@ -1601,9 +1157,10 @@
           <a:lstStyle/>
           <a:p>
             <a:r>
-              <a:rPr lang="en-US"/>
+              <a:rPr lang="en-US" smtClean="0"/>
               <a:t>Click to edit Master title style</a:t>
             </a:r>
+            <a:endParaRPr lang="en-US"/>
           </a:p>
         </p:txBody>
       </p:sp>
@@ -1657,37 +1214,38 @@
           <a:p>
             <a:pPr lvl="0"/>
             <a:r>
-              <a:rPr lang="en-US"/>
+              <a:rPr lang="en-US" smtClean="0"/>
               <a:t>Click to edit Master text styles</a:t>
             </a:r>
           </a:p>
           <a:p>
             <a:pPr lvl="1"/>
             <a:r>
-              <a:rPr lang="en-US"/>
+              <a:rPr lang="en-US" smtClean="0"/>
               <a:t>Second level</a:t>
             </a:r>
           </a:p>
           <a:p>
             <a:pPr lvl="2"/>
             <a:r>
-              <a:rPr lang="en-US"/>
+              <a:rPr lang="en-US" smtClean="0"/>
               <a:t>Third level</a:t>
             </a:r>
           </a:p>
           <a:p>
             <a:pPr lvl="3"/>
             <a:r>
-              <a:rPr lang="en-US"/>
+              <a:rPr lang="en-US" smtClean="0"/>
               <a:t>Fourth level</a:t>
             </a:r>
           </a:p>
           <a:p>
             <a:pPr lvl="4"/>
             <a:r>
-              <a:rPr lang="en-US"/>
+              <a:rPr lang="en-US" smtClean="0"/>
               <a:t>Fifth level</a:t>
             </a:r>
+            <a:endParaRPr lang="en-US"/>
           </a:p>
         </p:txBody>
       </p:sp>
@@ -1741,37 +1299,38 @@
           <a:p>
             <a:pPr lvl="0"/>
             <a:r>
-              <a:rPr lang="en-US"/>
+              <a:rPr lang="en-US" smtClean="0"/>
               <a:t>Click to edit Master text styles</a:t>
             </a:r>
           </a:p>
           <a:p>
             <a:pPr lvl="1"/>
             <a:r>
-              <a:rPr lang="en-US"/>
+              <a:rPr lang="en-US" smtClean="0"/>
               <a:t>Second level</a:t>
             </a:r>
           </a:p>
           <a:p>
             <a:pPr lvl="2"/>
             <a:r>
-              <a:rPr lang="en-US"/>
+              <a:rPr lang="en-US" smtClean="0"/>
               <a:t>Third level</a:t>
             </a:r>
           </a:p>
           <a:p>
             <a:pPr lvl="3"/>
             <a:r>
-              <a:rPr lang="en-US"/>
+              <a:rPr lang="en-US" smtClean="0"/>
               <a:t>Fourth level</a:t>
             </a:r>
           </a:p>
           <a:p>
             <a:pPr lvl="4"/>
             <a:r>
-              <a:rPr lang="en-US"/>
+              <a:rPr lang="en-US" smtClean="0"/>
               <a:t>Fifth level</a:t>
             </a:r>
+            <a:endParaRPr lang="en-US"/>
           </a:p>
         </p:txBody>
       </p:sp>
@@ -1792,7 +1351,7 @@
           <a:p>
             <a:fld id="{5BCAD085-E8A6-8845-BD4E-CB4CCA059FC4}" type="datetimeFigureOut">
               <a:rPr lang="en-US" smtClean="0"/>
-              <a:t>4/13/26</a:t>
+              <a:t>1/27/13</a:t>
             </a:fld>
             <a:endParaRPr lang="en-US"/>
           </a:p>
@@ -1890,9 +1449,10 @@
           </a:lstStyle>
           <a:p>
             <a:r>
-              <a:rPr lang="en-US"/>
+              <a:rPr lang="en-US" smtClean="0"/>
               <a:t>Click to edit Master title style</a:t>
             </a:r>
+            <a:endParaRPr lang="en-US"/>
           </a:p>
         </p:txBody>
       </p:sp>
@@ -1955,7 +1515,7 @@
           <a:p>
             <a:pPr lvl="0"/>
             <a:r>
-              <a:rPr lang="en-US"/>
+              <a:rPr lang="en-US" smtClean="0"/>
               <a:t>Click to edit Master text styles</a:t>
             </a:r>
           </a:p>
@@ -2011,37 +1571,38 @@
           <a:p>
             <a:pPr lvl="0"/>
             <a:r>
-              <a:rPr lang="en-US"/>
+              <a:rPr lang="en-US" smtClean="0"/>
               <a:t>Click to edit Master text styles</a:t>
             </a:r>
           </a:p>
           <a:p>
             <a:pPr lvl="1"/>
             <a:r>
-              <a:rPr lang="en-US"/>
+              <a:rPr lang="en-US" smtClean="0"/>
               <a:t>Second level</a:t>
             </a:r>
           </a:p>
           <a:p>
             <a:pPr lvl="2"/>
             <a:r>
-              <a:rPr lang="en-US"/>
+              <a:rPr lang="en-US" smtClean="0"/>
               <a:t>Third level</a:t>
             </a:r>
           </a:p>
           <a:p>
             <a:pPr lvl="3"/>
             <a:r>
-              <a:rPr lang="en-US"/>
+              <a:rPr lang="en-US" smtClean="0"/>
               <a:t>Fourth level</a:t>
             </a:r>
           </a:p>
           <a:p>
             <a:pPr lvl="4"/>
             <a:r>
-              <a:rPr lang="en-US"/>
+              <a:rPr lang="en-US" smtClean="0"/>
               <a:t>Fifth level</a:t>
             </a:r>
+            <a:endParaRPr lang="en-US"/>
           </a:p>
         </p:txBody>
       </p:sp>
@@ -2104,7 +1665,7 @@
           <a:p>
             <a:pPr lvl="0"/>
             <a:r>
-              <a:rPr lang="en-US"/>
+              <a:rPr lang="en-US" smtClean="0"/>
               <a:t>Click to edit Master text styles</a:t>
             </a:r>
           </a:p>
@@ -2160,37 +1721,38 @@
           <a:p>
             <a:pPr lvl="0"/>
             <a:r>
-              <a:rPr lang="en-US"/>
+              <a:rPr lang="en-US" smtClean="0"/>
               <a:t>Click to edit Master text styles</a:t>
             </a:r>
           </a:p>
           <a:p>
             <a:pPr lvl="1"/>
             <a:r>
-              <a:rPr lang="en-US"/>
+              <a:rPr lang="en-US" smtClean="0"/>
               <a:t>Second level</a:t>
             </a:r>
           </a:p>
           <a:p>
             <a:pPr lvl="2"/>
             <a:r>
-              <a:rPr lang="en-US"/>
+              <a:rPr lang="en-US" smtClean="0"/>
               <a:t>Third level</a:t>
             </a:r>
           </a:p>
           <a:p>
             <a:pPr lvl="3"/>
             <a:r>
-              <a:rPr lang="en-US"/>
+              <a:rPr lang="en-US" smtClean="0"/>
               <a:t>Fourth level</a:t>
             </a:r>
           </a:p>
           <a:p>
             <a:pPr lvl="4"/>
             <a:r>
-              <a:rPr lang="en-US"/>
+              <a:rPr lang="en-US" smtClean="0"/>
               <a:t>Fifth level</a:t>
             </a:r>
+            <a:endParaRPr lang="en-US"/>
           </a:p>
         </p:txBody>
       </p:sp>
@@ -2211,7 +1773,7 @@
           <a:p>
             <a:fld id="{5BCAD085-E8A6-8845-BD4E-CB4CCA059FC4}" type="datetimeFigureOut">
               <a:rPr lang="en-US" smtClean="0"/>
-              <a:t>4/13/26</a:t>
+              <a:t>1/27/13</a:t>
             </a:fld>
             <a:endParaRPr lang="en-US"/>
           </a:p>
@@ -2305,9 +1867,10 @@
           <a:lstStyle/>
           <a:p>
             <a:r>
-              <a:rPr lang="en-US"/>
+              <a:rPr lang="en-US" smtClean="0"/>
               <a:t>Click to edit Master title style</a:t>
             </a:r>
+            <a:endParaRPr lang="en-US"/>
           </a:p>
         </p:txBody>
       </p:sp>
@@ -2328,7 +1891,7 @@
           <a:p>
             <a:fld id="{5BCAD085-E8A6-8845-BD4E-CB4CCA059FC4}" type="datetimeFigureOut">
               <a:rPr lang="en-US" smtClean="0"/>
-              <a:t>4/13/26</a:t>
+              <a:t>1/27/13</a:t>
             </a:fld>
             <a:endParaRPr lang="en-US"/>
           </a:p>
@@ -2423,7 +1986,7 @@
           <a:p>
             <a:fld id="{5BCAD085-E8A6-8845-BD4E-CB4CCA059FC4}" type="datetimeFigureOut">
               <a:rPr lang="en-US" smtClean="0"/>
-              <a:t>4/13/26</a:t>
+              <a:t>1/27/13</a:t>
             </a:fld>
             <a:endParaRPr lang="en-US"/>
           </a:p>
@@ -2526,9 +2089,10 @@
           </a:lstStyle>
           <a:p>
             <a:r>
-              <a:rPr lang="en-US"/>
+              <a:rPr lang="en-US" smtClean="0"/>
               <a:t>Click to edit Master title style</a:t>
             </a:r>
+            <a:endParaRPr lang="en-US"/>
           </a:p>
         </p:txBody>
       </p:sp>
@@ -2582,37 +2146,38 @@
           <a:p>
             <a:pPr lvl="0"/>
             <a:r>
-              <a:rPr lang="en-US"/>
+              <a:rPr lang="en-US" smtClean="0"/>
               <a:t>Click to edit Master text styles</a:t>
             </a:r>
           </a:p>
           <a:p>
             <a:pPr lvl="1"/>
             <a:r>
-              <a:rPr lang="en-US"/>
+              <a:rPr lang="en-US" smtClean="0"/>
               <a:t>Second level</a:t>
             </a:r>
           </a:p>
           <a:p>
             <a:pPr lvl="2"/>
             <a:r>
-              <a:rPr lang="en-US"/>
+              <a:rPr lang="en-US" smtClean="0"/>
               <a:t>Third level</a:t>
             </a:r>
           </a:p>
           <a:p>
             <a:pPr lvl="3"/>
             <a:r>
-              <a:rPr lang="en-US"/>
+              <a:rPr lang="en-US" smtClean="0"/>
               <a:t>Fourth level</a:t>
             </a:r>
           </a:p>
           <a:p>
             <a:pPr lvl="4"/>
             <a:r>
-              <a:rPr lang="en-US"/>
+              <a:rPr lang="en-US" smtClean="0"/>
               <a:t>Fifth level</a:t>
             </a:r>
+            <a:endParaRPr lang="en-US"/>
           </a:p>
         </p:txBody>
       </p:sp>
@@ -2675,7 +2240,7 @@
           <a:p>
             <a:pPr lvl="0"/>
             <a:r>
-              <a:rPr lang="en-US"/>
+              <a:rPr lang="en-US" smtClean="0"/>
               <a:t>Click to edit Master text styles</a:t>
             </a:r>
           </a:p>
@@ -2698,7 +2263,7 @@
           <a:p>
             <a:fld id="{5BCAD085-E8A6-8845-BD4E-CB4CCA059FC4}" type="datetimeFigureOut">
               <a:rPr lang="en-US" smtClean="0"/>
-              <a:t>4/13/26</a:t>
+              <a:t>1/27/13</a:t>
             </a:fld>
             <a:endParaRPr lang="en-US"/>
           </a:p>
@@ -2801,9 +2366,10 @@
           </a:lstStyle>
           <a:p>
             <a:r>
-              <a:rPr lang="en-US"/>
+              <a:rPr lang="en-US" smtClean="0"/>
               <a:t>Click to edit Master title style</a:t>
             </a:r>
+            <a:endParaRPr lang="en-US"/>
           </a:p>
         </p:txBody>
       </p:sp>
@@ -2927,7 +2493,7 @@
           <a:p>
             <a:pPr lvl="0"/>
             <a:r>
-              <a:rPr lang="en-US"/>
+              <a:rPr lang="en-US" smtClean="0"/>
               <a:t>Click to edit Master text styles</a:t>
             </a:r>
           </a:p>
@@ -2950,7 +2516,7 @@
           <a:p>
             <a:fld id="{5BCAD085-E8A6-8845-BD4E-CB4CCA059FC4}" type="datetimeFigureOut">
               <a:rPr lang="en-US" smtClean="0"/>
-              <a:t>4/13/26</a:t>
+              <a:t>1/27/13</a:t>
             </a:fld>
             <a:endParaRPr lang="en-US"/>
           </a:p>
@@ -3059,9 +2625,10 @@
           <a:lstStyle/>
           <a:p>
             <a:r>
-              <a:rPr lang="en-US"/>
+              <a:rPr lang="en-US" smtClean="0"/>
               <a:t>Click to edit Master title style</a:t>
             </a:r>
+            <a:endParaRPr lang="en-US"/>
           </a:p>
         </p:txBody>
       </p:sp>
@@ -3092,37 +2659,38 @@
           <a:p>
             <a:pPr lvl="0"/>
             <a:r>
-              <a:rPr lang="en-US"/>
+              <a:rPr lang="en-US" smtClean="0"/>
               <a:t>Click to edit Master text styles</a:t>
             </a:r>
           </a:p>
           <a:p>
             <a:pPr lvl="1"/>
             <a:r>
-              <a:rPr lang="en-US"/>
+              <a:rPr lang="en-US" smtClean="0"/>
               <a:t>Second level</a:t>
             </a:r>
           </a:p>
           <a:p>
             <a:pPr lvl="2"/>
             <a:r>
-              <a:rPr lang="en-US"/>
+              <a:rPr lang="en-US" smtClean="0"/>
               <a:t>Third level</a:t>
             </a:r>
           </a:p>
           <a:p>
             <a:pPr lvl="3"/>
             <a:r>
-              <a:rPr lang="en-US"/>
+              <a:rPr lang="en-US" smtClean="0"/>
               <a:t>Fourth level</a:t>
             </a:r>
           </a:p>
           <a:p>
             <a:pPr lvl="4"/>
             <a:r>
-              <a:rPr lang="en-US"/>
+              <a:rPr lang="en-US" smtClean="0"/>
               <a:t>Fifth level</a:t>
             </a:r>
+            <a:endParaRPr lang="en-US"/>
           </a:p>
         </p:txBody>
       </p:sp>
@@ -3161,7 +2729,7 @@
           <a:p>
             <a:fld id="{5BCAD085-E8A6-8845-BD4E-CB4CCA059FC4}" type="datetimeFigureOut">
               <a:rPr lang="en-US" smtClean="0"/>
-              <a:t>4/13/26</a:t>
+              <a:t>1/27/13</a:t>
             </a:fld>
             <a:endParaRPr lang="en-US"/>
           </a:p>
@@ -3520,7 +3088,7 @@
 </file>
 
 <file path=ppt/slides/slide1.xml><?xml version="1.0" encoding="utf-8"?>
-<p:sld xmlns:a="http://schemas.openxmlformats.org/drawingml/2006/main" xmlns:r="http://schemas.openxmlformats.org/officeDocument/2006/relationships" xmlns:p="http://schemas.openxmlformats.org/presentationml/2006/main">
+<p:sld xmlns:a="http://schemas.openxmlformats.org/drawingml/2006/main" xmlns:p="http://schemas.openxmlformats.org/presentationml/2006/main" xmlns:r="http://schemas.openxmlformats.org/officeDocument/2006/relationships">
   <p:cSld>
     <p:bg>
       <p:bgPr>
@@ -3536,14 +3104,7 @@
         <p:cNvGrpSpPr/>
         <p:nvPr/>
       </p:nvGrpSpPr>
-      <p:grpSpPr>
-        <a:xfrm>
-          <a:off x="0" y="0"/>
-          <a:ext cx="0" cy="0"/>
-          <a:chOff x="0" y="0"/>
-          <a:chExt cx="0" cy="0"/>
-        </a:xfrm>
-      </p:grpSpPr>
+      <p:grpSpPr/>
       <p:sp>
         <p:nvSpPr>
           <p:cNvPr id="2" name="TextBox 1"/>
@@ -3609,7 +3170,7 @@
                 </a:solidFill>
                 <a:latin typeface="Aptos"/>
               </a:rPr>
-              <a:t>Le prompt cadre le système d'exécution : modèle, boucle agentique et runtime.</a:t>
+              <a:t>Il cadre un coding harness : modèle, agent loop et runtime supports.</a:t>
             </a:r>
           </a:p>
         </p:txBody>
@@ -3654,7 +3215,6 @@
           <a:lstStyle/>
           <a:p>
             <a:pPr algn="ctr"/>
-            <a:endParaRPr/>
           </a:p>
         </p:txBody>
       </p:sp>
@@ -3666,8 +3226,8 @@
         </p:nvSpPr>
         <p:spPr>
           <a:xfrm>
-            <a:off x="3822191" y="1828800"/>
-            <a:ext cx="4663440" cy="420624"/>
+            <a:off x="4279392" y="1847088"/>
+            <a:ext cx="3657600" cy="402336"/>
           </a:xfrm>
           <a:prstGeom prst="rect">
             <a:avLst/>
@@ -3682,13 +3242,13 @@
           <a:p>
             <a:pPr algn="ctr"/>
             <a:r>
-              <a:rPr sz="1900" b="1">
+              <a:rPr sz="2300" b="1">
                 <a:solidFill>
                   <a:srgbClr val="17222D"/>
                 </a:solidFill>
                 <a:latin typeface="Aptos"/>
               </a:rPr>
-              <a:t>Système cadré par le prompt</a:t>
+              <a:t>Coding harness</a:t>
             </a:r>
           </a:p>
         </p:txBody>
@@ -3702,7 +3262,7 @@
         <p:spPr>
           <a:xfrm>
             <a:off x="640080" y="2267712"/>
-            <a:ext cx="2596896" cy="2944368"/>
+            <a:ext cx="2560320" cy="2999232"/>
           </a:xfrm>
           <a:prstGeom prst="roundRect">
             <a:avLst/>
@@ -3735,7 +3295,6 @@
           <a:lstStyle/>
           <a:p>
             <a:pPr algn="ctr"/>
-            <a:endParaRPr/>
           </a:p>
         </p:txBody>
       </p:sp>
@@ -3747,8 +3306,8 @@
         </p:nvSpPr>
         <p:spPr>
           <a:xfrm>
-            <a:off x="3675887" y="2267712"/>
-            <a:ext cx="4480560" cy="2944368"/>
+            <a:off x="3730752" y="2267712"/>
+            <a:ext cx="4315968" cy="2999232"/>
           </a:xfrm>
           <a:prstGeom prst="roundRect">
             <a:avLst/>
@@ -3781,7 +3340,6 @@
           <a:lstStyle/>
           <a:p>
             <a:pPr algn="ctr"/>
-            <a:endParaRPr/>
           </a:p>
         </p:txBody>
       </p:sp>
@@ -3793,8 +3351,8 @@
         </p:nvSpPr>
         <p:spPr>
           <a:xfrm>
-            <a:off x="8485632" y="2267712"/>
-            <a:ext cx="3127248" cy="2944368"/>
+            <a:off x="8577072" y="2267712"/>
+            <a:ext cx="2971800" cy="2999232"/>
           </a:xfrm>
           <a:prstGeom prst="roundRect">
             <a:avLst/>
@@ -3827,7 +3385,6 @@
           <a:lstStyle/>
           <a:p>
             <a:pPr algn="ctr"/>
-            <a:endParaRPr/>
           </a:p>
         </p:txBody>
       </p:sp>
@@ -3839,8 +3396,8 @@
         </p:nvSpPr>
         <p:spPr>
           <a:xfrm>
-            <a:off x="886968" y="2523744"/>
-            <a:ext cx="2103120" cy="292608"/>
+            <a:off x="886968" y="2542032"/>
+            <a:ext cx="2057400" cy="292608"/>
           </a:xfrm>
           <a:prstGeom prst="rect">
             <a:avLst/>
@@ -3855,13 +3412,13 @@
           <a:p>
             <a:pPr algn="ctr"/>
             <a:r>
-              <a:rPr sz="2100" b="0">
+              <a:rPr sz="2200" b="0">
                 <a:solidFill>
                   <a:srgbClr val="17222D"/>
                 </a:solidFill>
                 <a:latin typeface="Aptos"/>
               </a:rPr>
-              <a:t>Couche modèle</a:t>
+              <a:t>Model family</a:t>
             </a:r>
           </a:p>
         </p:txBody>
@@ -3874,8 +3431,8 @@
         </p:nvSpPr>
         <p:spPr>
           <a:xfrm>
-            <a:off x="1005840" y="3054096"/>
-            <a:ext cx="1847088" cy="877824"/>
+            <a:off x="1024128" y="3163824"/>
+            <a:ext cx="1810512" cy="859536"/>
           </a:xfrm>
           <a:prstGeom prst="roundRect">
             <a:avLst/>
@@ -3908,7 +3465,6 @@
           <a:lstStyle/>
           <a:p>
             <a:pPr algn="ctr"/>
-            <a:endParaRPr/>
           </a:p>
         </p:txBody>
       </p:sp>
@@ -3920,8 +3476,8 @@
         </p:nvSpPr>
         <p:spPr>
           <a:xfrm>
-            <a:off x="1115568" y="3319272"/>
-            <a:ext cx="1627632" cy="310896"/>
+            <a:off x="1170432" y="3456432"/>
+            <a:ext cx="1517904" cy="219456"/>
           </a:xfrm>
           <a:prstGeom prst="rect">
             <a:avLst/>
@@ -3936,13 +3492,13 @@
           <a:p>
             <a:pPr algn="ctr"/>
             <a:r>
-              <a:rPr sz="1900" b="0">
+              <a:rPr sz="2100" b="0">
                 <a:solidFill>
                   <a:srgbClr val="17222D"/>
                 </a:solidFill>
                 <a:latin typeface="Aptos"/>
               </a:rPr>
-              <a:t>LLM de base</a:t>
+              <a:t>Base LLM</a:t>
             </a:r>
           </a:p>
         </p:txBody>
@@ -3955,8 +3511,8 @@
         </p:nvSpPr>
         <p:spPr>
           <a:xfrm rot="5400000">
-            <a:off x="1773936" y="3968496"/>
-            <a:ext cx="292608" cy="292608"/>
+            <a:off x="1764792" y="4078224"/>
+            <a:ext cx="310896" cy="310896"/>
           </a:xfrm>
           <a:prstGeom prst="chevron">
             <a:avLst/>
@@ -3987,7 +3543,6 @@
           <a:lstStyle/>
           <a:p>
             <a:pPr algn="ctr"/>
-            <a:endParaRPr/>
           </a:p>
         </p:txBody>
       </p:sp>
@@ -3999,8 +3554,8 @@
         </p:nvSpPr>
         <p:spPr>
           <a:xfrm>
-            <a:off x="1005840" y="4315968"/>
-            <a:ext cx="1847088" cy="877824"/>
+            <a:off x="1024128" y="4462272"/>
+            <a:ext cx="1810512" cy="859536"/>
           </a:xfrm>
           <a:prstGeom prst="roundRect">
             <a:avLst/>
@@ -4033,7 +3588,6 @@
           <a:lstStyle/>
           <a:p>
             <a:pPr algn="ctr"/>
-            <a:endParaRPr/>
           </a:p>
         </p:txBody>
       </p:sp>
@@ -4045,8 +3599,8 @@
         </p:nvSpPr>
         <p:spPr>
           <a:xfrm>
-            <a:off x="1115568" y="4461854"/>
-            <a:ext cx="1627632" cy="384048"/>
+            <a:off x="1170432" y="4681728"/>
+            <a:ext cx="1517904" cy="384048"/>
           </a:xfrm>
           <a:prstGeom prst="rect">
             <a:avLst/>
@@ -4061,14 +3615,14 @@
           <a:p>
             <a:pPr algn="ctr"/>
             <a:r>
-              <a:rPr sz="1900" b="0" dirty="0">
+              <a:rPr sz="2000" b="0">
                 <a:solidFill>
                   <a:srgbClr val="17222D"/>
                 </a:solidFill>
                 <a:latin typeface="Aptos"/>
               </a:rPr>
-              <a:t>LLM
-reasoning</a:t>
+              <a:t>Reasoning
+model</a:t>
             </a:r>
           </a:p>
         </p:txBody>
@@ -4081,7 +3635,7 @@
         </p:nvSpPr>
         <p:spPr>
           <a:xfrm>
-            <a:off x="4700016" y="2523744"/>
+            <a:off x="4663440" y="2542032"/>
             <a:ext cx="2487168" cy="292608"/>
           </a:xfrm>
           <a:prstGeom prst="rect">
@@ -4097,13 +3651,13 @@
           <a:p>
             <a:pPr algn="ctr"/>
             <a:r>
-              <a:rPr sz="2100" b="0">
+              <a:rPr sz="2200" b="0">
                 <a:solidFill>
                   <a:srgbClr val="17222D"/>
                 </a:solidFill>
                 <a:latin typeface="Aptos"/>
               </a:rPr>
-              <a:t>Boucle agentique</a:t>
+              <a:t>Agent loop</a:t>
             </a:r>
           </a:p>
         </p:txBody>
@@ -4116,8 +3670,8 @@
         </p:nvSpPr>
         <p:spPr>
           <a:xfrm>
-            <a:off x="4187952" y="3401568"/>
-            <a:ext cx="1463040" cy="566928"/>
+            <a:off x="4169663" y="3511296"/>
+            <a:ext cx="1353312" cy="566928"/>
           </a:xfrm>
           <a:prstGeom prst="roundRect">
             <a:avLst/>
@@ -4150,7 +3704,6 @@
           <a:lstStyle/>
           <a:p>
             <a:pPr algn="ctr"/>
-            <a:endParaRPr/>
           </a:p>
         </p:txBody>
       </p:sp>
@@ -4162,8 +3715,8 @@
         </p:nvSpPr>
         <p:spPr>
           <a:xfrm>
-            <a:off x="4187952" y="3547872"/>
-            <a:ext cx="1463040" cy="201168"/>
+            <a:off x="4169663" y="3666744"/>
+            <a:ext cx="1353312" cy="182880"/>
           </a:xfrm>
           <a:prstGeom prst="rect">
             <a:avLst/>
@@ -4178,13 +3731,13 @@
           <a:p>
             <a:pPr algn="ctr"/>
             <a:r>
-              <a:rPr sz="1800" b="0">
+              <a:rPr sz="1900" b="0">
                 <a:solidFill>
                   <a:srgbClr val="17222D"/>
                 </a:solidFill>
                 <a:latin typeface="Aptos"/>
               </a:rPr>
-              <a:t>Inspecte</a:t>
+              <a:t>Inspect</a:t>
             </a:r>
           </a:p>
         </p:txBody>
@@ -4197,8 +3750,8 @@
         </p:nvSpPr>
         <p:spPr>
           <a:xfrm>
-            <a:off x="6144768" y="3401568"/>
-            <a:ext cx="1463040" cy="566928"/>
+            <a:off x="6016752" y="3511296"/>
+            <a:ext cx="1353312" cy="566928"/>
           </a:xfrm>
           <a:prstGeom prst="roundRect">
             <a:avLst/>
@@ -4231,7 +3784,6 @@
           <a:lstStyle/>
           <a:p>
             <a:pPr algn="ctr"/>
-            <a:endParaRPr/>
           </a:p>
         </p:txBody>
       </p:sp>
@@ -4243,8 +3795,8 @@
         </p:nvSpPr>
         <p:spPr>
           <a:xfrm>
-            <a:off x="6144768" y="3547872"/>
-            <a:ext cx="1463040" cy="201168"/>
+            <a:off x="6016752" y="3666744"/>
+            <a:ext cx="1353312" cy="182880"/>
           </a:xfrm>
           <a:prstGeom prst="rect">
             <a:avLst/>
@@ -4259,13 +3811,13 @@
           <a:p>
             <a:pPr algn="ctr"/>
             <a:r>
-              <a:rPr sz="1800" b="0">
+              <a:rPr sz="1900" b="0">
                 <a:solidFill>
                   <a:srgbClr val="17222D"/>
                 </a:solidFill>
                 <a:latin typeface="Aptos"/>
               </a:rPr>
-              <a:t>Choisit</a:t>
+              <a:t>Choose</a:t>
             </a:r>
           </a:p>
         </p:txBody>
@@ -4278,8 +3830,8 @@
         </p:nvSpPr>
         <p:spPr>
           <a:xfrm>
-            <a:off x="4187952" y="4498848"/>
-            <a:ext cx="1463040" cy="566928"/>
+            <a:off x="4169663" y="4590288"/>
+            <a:ext cx="1353312" cy="566928"/>
           </a:xfrm>
           <a:prstGeom prst="roundRect">
             <a:avLst/>
@@ -4312,7 +3864,6 @@
           <a:lstStyle/>
           <a:p>
             <a:pPr algn="ctr"/>
-            <a:endParaRPr/>
           </a:p>
         </p:txBody>
       </p:sp>
@@ -4324,8 +3875,8 @@
         </p:nvSpPr>
         <p:spPr>
           <a:xfrm>
-            <a:off x="4187952" y="4645152"/>
-            <a:ext cx="1463040" cy="201168"/>
+            <a:off x="4169663" y="4745736"/>
+            <a:ext cx="1353312" cy="182880"/>
           </a:xfrm>
           <a:prstGeom prst="rect">
             <a:avLst/>
@@ -4340,7 +3891,7 @@
           <a:p>
             <a:pPr algn="ctr"/>
             <a:r>
-              <a:rPr sz="1800" b="0">
+              <a:rPr sz="1900" b="0">
                 <a:solidFill>
                   <a:srgbClr val="17222D"/>
                 </a:solidFill>
@@ -4359,8 +3910,8 @@
         </p:nvSpPr>
         <p:spPr>
           <a:xfrm>
-            <a:off x="6144768" y="4498848"/>
-            <a:ext cx="1463040" cy="566928"/>
+            <a:off x="6016752" y="4590288"/>
+            <a:ext cx="1353312" cy="566928"/>
           </a:xfrm>
           <a:prstGeom prst="roundRect">
             <a:avLst/>
@@ -4393,7 +3944,6 @@
           <a:lstStyle/>
           <a:p>
             <a:pPr algn="ctr"/>
-            <a:endParaRPr/>
           </a:p>
         </p:txBody>
       </p:sp>
@@ -4405,8 +3955,8 @@
         </p:nvSpPr>
         <p:spPr>
           <a:xfrm>
-            <a:off x="6144768" y="4645152"/>
-            <a:ext cx="1463040" cy="201168"/>
+            <a:off x="6016752" y="4745736"/>
+            <a:ext cx="1353312" cy="182880"/>
           </a:xfrm>
           <a:prstGeom prst="rect">
             <a:avLst/>
@@ -4421,13 +3971,13 @@
           <a:p>
             <a:pPr algn="ctr"/>
             <a:r>
-              <a:rPr sz="1800" b="0">
+              <a:rPr sz="1900" b="0">
                 <a:solidFill>
                   <a:srgbClr val="17222D"/>
                 </a:solidFill>
                 <a:latin typeface="Aptos"/>
               </a:rPr>
-              <a:t>Agit</a:t>
+              <a:t>Act</a:t>
             </a:r>
           </a:p>
         </p:txBody>
@@ -4440,8 +3990,8 @@
         </p:nvSpPr>
         <p:spPr>
           <a:xfrm>
-            <a:off x="5742432" y="3657600"/>
-            <a:ext cx="201168" cy="128016"/>
+            <a:off x="5541264" y="3712463"/>
+            <a:ext cx="256032" cy="164592"/>
           </a:xfrm>
           <a:prstGeom prst="chevron">
             <a:avLst/>
@@ -4472,7 +4022,6 @@
           <a:lstStyle/>
           <a:p>
             <a:pPr algn="ctr"/>
-            <a:endParaRPr/>
           </a:p>
         </p:txBody>
       </p:sp>
@@ -4484,8 +4033,8 @@
         </p:nvSpPr>
         <p:spPr>
           <a:xfrm rot="5400000">
-            <a:off x="6803136" y="3977639"/>
-            <a:ext cx="128016" cy="201168"/>
+            <a:off x="6547104" y="4096512"/>
+            <a:ext cx="164592" cy="256032"/>
           </a:xfrm>
           <a:prstGeom prst="chevron">
             <a:avLst/>
@@ -4516,7 +4065,6 @@
           <a:lstStyle/>
           <a:p>
             <a:pPr algn="ctr"/>
-            <a:endParaRPr/>
           </a:p>
         </p:txBody>
       </p:sp>
@@ -4528,8 +4076,8 @@
         </p:nvSpPr>
         <p:spPr>
           <a:xfrm rot="10800000">
-            <a:off x="5742432" y="4718304"/>
-            <a:ext cx="201168" cy="128016"/>
+            <a:off x="5541264" y="4828032"/>
+            <a:ext cx="256032" cy="164592"/>
           </a:xfrm>
           <a:prstGeom prst="chevron">
             <a:avLst/>
@@ -4560,7 +4108,6 @@
           <a:lstStyle/>
           <a:p>
             <a:pPr algn="ctr"/>
-            <a:endParaRPr/>
           </a:p>
         </p:txBody>
       </p:sp>
@@ -4572,8 +4119,8 @@
         </p:nvSpPr>
         <p:spPr>
           <a:xfrm rot="16200000">
-            <a:off x="4956048" y="3977639"/>
-            <a:ext cx="128016" cy="201168"/>
+            <a:off x="4718304" y="4078224"/>
+            <a:ext cx="164592" cy="256032"/>
           </a:xfrm>
           <a:prstGeom prst="chevron">
             <a:avLst/>
@@ -4604,7 +4151,6 @@
           <a:lstStyle/>
           <a:p>
             <a:pPr algn="ctr"/>
-            <a:endParaRPr/>
           </a:p>
         </p:txBody>
       </p:sp>
@@ -4616,8 +4162,8 @@
         </p:nvSpPr>
         <p:spPr>
           <a:xfrm>
-            <a:off x="8650224" y="2505456"/>
-            <a:ext cx="2761488" cy="292608"/>
+            <a:off x="8961120" y="2542032"/>
+            <a:ext cx="2176272" cy="292608"/>
           </a:xfrm>
           <a:prstGeom prst="rect">
             <a:avLst/>
@@ -4632,13 +4178,13 @@
           <a:p>
             <a:pPr algn="ctr"/>
             <a:r>
-              <a:rPr sz="2000" b="0">
+              <a:rPr sz="2100" b="0">
                 <a:solidFill>
                   <a:srgbClr val="17222D"/>
                 </a:solidFill>
                 <a:latin typeface="Aptos"/>
               </a:rPr>
-              <a:t>Cadre d'exécution</a:t>
+              <a:t>Runtime supports</a:t>
             </a:r>
           </a:p>
         </p:txBody>
@@ -4651,8 +4197,8 @@
         </p:nvSpPr>
         <p:spPr>
           <a:xfrm>
-            <a:off x="8741664" y="3200400"/>
-            <a:ext cx="1316736" cy="475488"/>
+            <a:off x="8851392" y="3474720"/>
+            <a:ext cx="1133856" cy="493776"/>
           </a:xfrm>
           <a:prstGeom prst="roundRect">
             <a:avLst/>
@@ -4685,7 +4231,6 @@
           <a:lstStyle/>
           <a:p>
             <a:pPr algn="ctr"/>
-            <a:endParaRPr/>
           </a:p>
         </p:txBody>
       </p:sp>
@@ -4697,8 +4242,8 @@
         </p:nvSpPr>
         <p:spPr>
           <a:xfrm>
-            <a:off x="8741664" y="3282696"/>
-            <a:ext cx="1316736" cy="237744"/>
+            <a:off x="8851392" y="3602736"/>
+            <a:ext cx="1133856" cy="182880"/>
           </a:xfrm>
           <a:prstGeom prst="rect">
             <a:avLst/>
@@ -4713,14 +4258,13 @@
           <a:p>
             <a:pPr algn="ctr"/>
             <a:r>
-              <a:rPr sz="1200" b="0">
+              <a:rPr sz="1500" b="0">
                 <a:solidFill>
                   <a:srgbClr val="17222D"/>
                 </a:solidFill>
                 <a:latin typeface="Aptos"/>
               </a:rPr>
-              <a:t>Contexte
-repo</a:t>
+              <a:t>Repo context</a:t>
             </a:r>
           </a:p>
         </p:txBody>
@@ -4733,8 +4277,8 @@
         </p:nvSpPr>
         <p:spPr>
           <a:xfrm>
-            <a:off x="10168128" y="3200400"/>
-            <a:ext cx="1316736" cy="475488"/>
+            <a:off x="10213848" y="3474720"/>
+            <a:ext cx="1133856" cy="493776"/>
           </a:xfrm>
           <a:prstGeom prst="roundRect">
             <a:avLst/>
@@ -4767,7 +4311,6 @@
           <a:lstStyle/>
           <a:p>
             <a:pPr algn="ctr"/>
-            <a:endParaRPr/>
           </a:p>
         </p:txBody>
       </p:sp>
@@ -4779,8 +4322,8 @@
         </p:nvSpPr>
         <p:spPr>
           <a:xfrm>
-            <a:off x="10168128" y="3282696"/>
-            <a:ext cx="1316736" cy="237744"/>
+            <a:off x="10213848" y="3602736"/>
+            <a:ext cx="1133856" cy="182880"/>
           </a:xfrm>
           <a:prstGeom prst="rect">
             <a:avLst/>
@@ -4795,13 +4338,13 @@
           <a:p>
             <a:pPr algn="ctr"/>
             <a:r>
-              <a:rPr sz="1200" b="0">
+              <a:rPr sz="1500" b="0">
                 <a:solidFill>
                   <a:srgbClr val="17222D"/>
                 </a:solidFill>
                 <a:latin typeface="Aptos"/>
               </a:rPr>
-              <a:t>Outils</a:t>
+              <a:t>Tools</a:t>
             </a:r>
           </a:p>
         </p:txBody>
@@ -4814,8 +4357,8 @@
         </p:nvSpPr>
         <p:spPr>
           <a:xfrm>
-            <a:off x="8741664" y="3886200"/>
-            <a:ext cx="1316736" cy="475488"/>
+            <a:off x="8851392" y="4261104"/>
+            <a:ext cx="1133856" cy="493776"/>
           </a:xfrm>
           <a:prstGeom prst="roundRect">
             <a:avLst/>
@@ -4848,7 +4391,6 @@
           <a:lstStyle/>
           <a:p>
             <a:pPr algn="ctr"/>
-            <a:endParaRPr/>
           </a:p>
         </p:txBody>
       </p:sp>
@@ -4860,8 +4402,8 @@
         </p:nvSpPr>
         <p:spPr>
           <a:xfrm>
-            <a:off x="8741664" y="3968496"/>
-            <a:ext cx="1316736" cy="237744"/>
+            <a:off x="8851392" y="4389120"/>
+            <a:ext cx="1133856" cy="182880"/>
           </a:xfrm>
           <a:prstGeom prst="rect">
             <a:avLst/>
@@ -4876,7 +4418,7 @@
           <a:p>
             <a:pPr algn="ctr"/>
             <a:r>
-              <a:rPr sz="1200" b="0">
+              <a:rPr sz="1500" b="0">
                 <a:solidFill>
                   <a:srgbClr val="17222D"/>
                 </a:solidFill>
@@ -4895,8 +4437,8 @@
         </p:nvSpPr>
         <p:spPr>
           <a:xfrm>
-            <a:off x="10168128" y="3886200"/>
-            <a:ext cx="1316736" cy="475488"/>
+            <a:off x="10213848" y="4261104"/>
+            <a:ext cx="1133856" cy="493776"/>
           </a:xfrm>
           <a:prstGeom prst="roundRect">
             <a:avLst/>
@@ -4929,7 +4471,6 @@
           <a:lstStyle/>
           <a:p>
             <a:pPr algn="ctr"/>
-            <a:endParaRPr/>
           </a:p>
         </p:txBody>
       </p:sp>
@@ -4941,8 +4482,8 @@
         </p:nvSpPr>
         <p:spPr>
           <a:xfrm>
-            <a:off x="10168128" y="3968496"/>
-            <a:ext cx="1316736" cy="237744"/>
+            <a:off x="10213848" y="4389120"/>
+            <a:ext cx="1133856" cy="182880"/>
           </a:xfrm>
           <a:prstGeom prst="rect">
             <a:avLst/>
@@ -4957,13 +4498,13 @@
           <a:p>
             <a:pPr algn="ctr"/>
             <a:r>
-              <a:rPr sz="1200" b="0">
+              <a:rPr sz="1500" b="0">
                 <a:solidFill>
                   <a:srgbClr val="17222D"/>
                 </a:solidFill>
                 <a:latin typeface="Aptos"/>
               </a:rPr>
-              <a:t>Mémoire</a:t>
+              <a:t>Memory</a:t>
             </a:r>
           </a:p>
         </p:txBody>
@@ -4976,8 +4517,8 @@
         </p:nvSpPr>
         <p:spPr>
           <a:xfrm>
-            <a:off x="8741664" y="4572000"/>
-            <a:ext cx="1316736" cy="475488"/>
+            <a:off x="8851392" y="5047488"/>
+            <a:ext cx="1133856" cy="493776"/>
           </a:xfrm>
           <a:prstGeom prst="roundRect">
             <a:avLst/>
@@ -5010,7 +4551,6 @@
           <a:lstStyle/>
           <a:p>
             <a:pPr algn="ctr"/>
-            <a:endParaRPr/>
           </a:p>
         </p:txBody>
       </p:sp>
@@ -5022,8 +4562,8 @@
         </p:nvSpPr>
         <p:spPr>
           <a:xfrm>
-            <a:off x="8741664" y="4654296"/>
-            <a:ext cx="1316736" cy="237744"/>
+            <a:off x="8851392" y="5175504"/>
+            <a:ext cx="1133856" cy="182880"/>
           </a:xfrm>
           <a:prstGeom prst="rect">
             <a:avLst/>
@@ -5038,7 +4578,7 @@
           <a:p>
             <a:pPr algn="ctr"/>
             <a:r>
-              <a:rPr sz="1200" b="0">
+              <a:rPr sz="1500" b="0">
                 <a:solidFill>
                   <a:srgbClr val="17222D"/>
                 </a:solidFill>
@@ -5057,8 +4597,8 @@
         </p:nvSpPr>
         <p:spPr>
           <a:xfrm>
-            <a:off x="10168128" y="4572000"/>
-            <a:ext cx="1316736" cy="475488"/>
+            <a:off x="10213848" y="5047488"/>
+            <a:ext cx="1133856" cy="493776"/>
           </a:xfrm>
           <a:prstGeom prst="roundRect">
             <a:avLst/>
@@ -5091,7 +4631,6 @@
           <a:lstStyle/>
           <a:p>
             <a:pPr algn="ctr"/>
-            <a:endParaRPr/>
           </a:p>
         </p:txBody>
       </p:sp>
@@ -5103,8 +4642,8 @@
         </p:nvSpPr>
         <p:spPr>
           <a:xfrm>
-            <a:off x="10168128" y="4654296"/>
-            <a:ext cx="1316736" cy="237744"/>
+            <a:off x="10213848" y="5175504"/>
+            <a:ext cx="1133856" cy="182880"/>
           </a:xfrm>
           <a:prstGeom prst="rect">
             <a:avLst/>
@@ -5119,13 +4658,13 @@
           <a:p>
             <a:pPr algn="ctr"/>
             <a:r>
-              <a:rPr sz="1200" b="0">
+              <a:rPr sz="1500" b="0">
                 <a:solidFill>
                   <a:srgbClr val="17222D"/>
                 </a:solidFill>
                 <a:latin typeface="Aptos"/>
               </a:rPr>
-              <a:t>Exécution</a:t>
+              <a:t>Execution</a:t>
             </a:r>
           </a:p>
         </p:txBody>
@@ -5138,8 +4677,8 @@
         </p:nvSpPr>
         <p:spPr>
           <a:xfrm>
-            <a:off x="3346704" y="3803904"/>
-            <a:ext cx="219456" cy="201168"/>
+            <a:off x="3255264" y="3767328"/>
+            <a:ext cx="310896" cy="256032"/>
           </a:xfrm>
           <a:prstGeom prst="chevron">
             <a:avLst/>
@@ -5170,7 +4709,6 @@
           <a:lstStyle/>
           <a:p>
             <a:pPr algn="ctr"/>
-            <a:endParaRPr/>
           </a:p>
         </p:txBody>
       </p:sp>
@@ -5182,8 +4720,8 @@
         </p:nvSpPr>
         <p:spPr>
           <a:xfrm>
-            <a:off x="8211312" y="3803904"/>
-            <a:ext cx="219456" cy="201168"/>
+            <a:off x="8174736" y="3767328"/>
+            <a:ext cx="310896" cy="256032"/>
           </a:xfrm>
           <a:prstGeom prst="chevron">
             <a:avLst/>
@@ -5214,66 +4752,19 @@
           <a:lstStyle/>
           <a:p>
             <a:pPr algn="ctr"/>
-            <a:endParaRPr/>
-          </a:p>
-        </p:txBody>
-      </p:sp>
-      <p:sp>
-        <p:nvSpPr>
-          <p:cNvPr id="43" name="Rounded Rectangle 42"/>
-          <p:cNvSpPr/>
-          <p:nvPr/>
-        </p:nvSpPr>
-        <p:spPr>
-          <a:xfrm>
-            <a:off x="987552" y="5522976"/>
-            <a:ext cx="10149840" cy="640080"/>
-          </a:xfrm>
-          <a:prstGeom prst="roundRect">
-            <a:avLst/>
-          </a:prstGeom>
-          <a:solidFill>
-            <a:srgbClr val="F4ECE0"/>
-          </a:solidFill>
-          <a:ln w="15240">
-            <a:solidFill>
-              <a:srgbClr val="F4ECE0"/>
-            </a:solidFill>
-          </a:ln>
-        </p:spPr>
-        <p:style>
-          <a:lnRef idx="1">
-            <a:schemeClr val="accent1"/>
-          </a:lnRef>
-          <a:fillRef idx="3">
-            <a:schemeClr val="accent1"/>
-          </a:fillRef>
-          <a:effectRef idx="2">
-            <a:schemeClr val="accent1"/>
-          </a:effectRef>
-          <a:fontRef idx="minor">
-            <a:schemeClr val="lt1"/>
-          </a:fontRef>
-        </p:style>
-        <p:txBody>
-          <a:bodyPr rtlCol="0" anchor="ctr"/>
-          <a:lstStyle/>
-          <a:p>
-            <a:pPr algn="ctr"/>
-            <a:endParaRPr/>
-          </a:p>
-        </p:txBody>
-      </p:sp>
-      <p:sp>
-        <p:nvSpPr>
-          <p:cNvPr id="44" name="TextBox 43"/>
+          </a:p>
+        </p:txBody>
+      </p:sp>
+      <p:sp>
+        <p:nvSpPr>
+          <p:cNvPr id="43" name="TextBox 42"/>
           <p:cNvSpPr txBox="1"/>
           <p:nvPr/>
         </p:nvSpPr>
         <p:spPr>
           <a:xfrm>
-            <a:off x="1225296" y="5696712"/>
-            <a:ext cx="9692640" cy="256032"/>
+            <a:off x="914400" y="5669280"/>
+            <a:ext cx="10332720" cy="219456"/>
           </a:xfrm>
           <a:prstGeom prst="rect">
             <a:avLst/>
@@ -5288,13 +4779,13 @@
           <a:p>
             <a:pPr algn="ctr"/>
             <a:r>
-              <a:rPr sz="1600" b="1">
+              <a:rPr sz="1700" b="1">
                 <a:solidFill>
                   <a:srgbClr val="BF5A24"/>
                 </a:solidFill>
                 <a:latin typeface="Aptos"/>
               </a:rPr>
-              <a:t>Le Prompt Engineering cadre la boucle, les outils et le bon niveau de contexte.</a:t>
+              <a:t>Le Prompt Engineering sert ici à cadrer la boucle, les outils, les règles et le bon niveau de contexte.</a:t>
             </a:r>
           </a:p>
         </p:txBody>
@@ -5308,7 +4799,7 @@
 </file>
 
 <file path=ppt/slides/slide10.xml><?xml version="1.0" encoding="utf-8"?>
-<p:sld xmlns:a="http://schemas.openxmlformats.org/drawingml/2006/main" xmlns:r="http://schemas.openxmlformats.org/officeDocument/2006/relationships" xmlns:p="http://schemas.openxmlformats.org/presentationml/2006/main">
+<p:sld xmlns:a="http://schemas.openxmlformats.org/drawingml/2006/main" xmlns:p="http://schemas.openxmlformats.org/presentationml/2006/main" xmlns:r="http://schemas.openxmlformats.org/officeDocument/2006/relationships">
   <p:cSld>
     <p:bg>
       <p:bgPr>
@@ -5324,14 +4815,7 @@
         <p:cNvGrpSpPr/>
         <p:nvPr/>
       </p:nvGrpSpPr>
-      <p:grpSpPr>
-        <a:xfrm>
-          <a:off x="0" y="0"/>
-          <a:ext cx="0" cy="0"/>
-          <a:chOff x="0" y="0"/>
-          <a:chExt cx="0" cy="0"/>
-        </a:xfrm>
-      </p:grpSpPr>
+      <p:grpSpPr/>
       <p:sp>
         <p:nvSpPr>
           <p:cNvPr id="2" name="TextBox 1"/>
@@ -5407,7 +4891,6 @@
           <a:lstStyle/>
           <a:p>
             <a:pPr algn="ctr"/>
-            <a:endParaRPr/>
           </a:p>
         </p:txBody>
       </p:sp>
@@ -5453,7 +4936,6 @@
           <a:lstStyle/>
           <a:p>
             <a:pPr algn="ctr"/>
-            <a:endParaRPr/>
           </a:p>
         </p:txBody>
       </p:sp>
@@ -5535,7 +5017,6 @@
           <a:lstStyle/>
           <a:p>
             <a:pPr algn="ctr"/>
-            <a:endParaRPr/>
           </a:p>
         </p:txBody>
       </p:sp>
@@ -5652,7 +5133,6 @@
           <a:lstStyle/>
           <a:p>
             <a:pPr algn="ctr"/>
-            <a:endParaRPr/>
           </a:p>
         </p:txBody>
       </p:sp>
@@ -5769,7 +5249,6 @@
           <a:lstStyle/>
           <a:p>
             <a:pPr algn="ctr"/>
-            <a:endParaRPr/>
           </a:p>
         </p:txBody>
       </p:sp>
@@ -5853,7 +5332,7 @@
 </file>
 
 <file path=ppt/slides/slide2.xml><?xml version="1.0" encoding="utf-8"?>
-<p:sld xmlns:a="http://schemas.openxmlformats.org/drawingml/2006/main" xmlns:r="http://schemas.openxmlformats.org/officeDocument/2006/relationships" xmlns:p="http://schemas.openxmlformats.org/presentationml/2006/main">
+<p:sld xmlns:a="http://schemas.openxmlformats.org/drawingml/2006/main" xmlns:p="http://schemas.openxmlformats.org/presentationml/2006/main" xmlns:r="http://schemas.openxmlformats.org/officeDocument/2006/relationships">
   <p:cSld>
     <p:bg>
       <p:bgPr>
@@ -5869,14 +5348,7 @@
         <p:cNvGrpSpPr/>
         <p:nvPr/>
       </p:nvGrpSpPr>
-      <p:grpSpPr>
-        <a:xfrm>
-          <a:off x="0" y="0"/>
-          <a:ext cx="0" cy="0"/>
-          <a:chOff x="0" y="0"/>
-          <a:chExt cx="0" cy="0"/>
-        </a:xfrm>
-      </p:grpSpPr>
+      <p:grpSpPr/>
       <p:sp>
         <p:nvSpPr>
           <p:cNvPr id="2" name="TextBox 1"/>
@@ -5987,7 +5459,6 @@
           <a:lstStyle/>
           <a:p>
             <a:pPr algn="ctr"/>
-            <a:endParaRPr/>
           </a:p>
         </p:txBody>
       </p:sp>
@@ -6033,7 +5504,6 @@
           <a:lstStyle/>
           <a:p>
             <a:pPr algn="ctr"/>
-            <a:endParaRPr/>
           </a:p>
         </p:txBody>
       </p:sp>
@@ -6079,7 +5549,6 @@
           <a:lstStyle/>
           <a:p>
             <a:pPr algn="ctr"/>
-            <a:endParaRPr/>
           </a:p>
         </p:txBody>
       </p:sp>
@@ -6142,40 +5611,13 @@
           <a:p>
             <a:pPr algn="ctr"/>
             <a:r>
-              <a:rPr sz="1900" b="1" dirty="0" err="1">
+              <a:rPr sz="1900" b="1">
                 <a:solidFill>
                   <a:srgbClr val="17222D"/>
                 </a:solidFill>
                 <a:latin typeface="Aptos"/>
               </a:rPr>
-              <a:t>produit</a:t>
-            </a:r>
-            <a:r>
-              <a:rPr sz="1900" b="1" dirty="0">
-                <a:solidFill>
-                  <a:srgbClr val="17222D"/>
-                </a:solidFill>
-                <a:latin typeface="Aptos"/>
-              </a:rPr>
-              <a:t> </a:t>
-            </a:r>
-            <a:r>
-              <a:rPr sz="1900" b="1" dirty="0" err="1">
-                <a:solidFill>
-                  <a:srgbClr val="17222D"/>
-                </a:solidFill>
-                <a:latin typeface="Aptos"/>
-              </a:rPr>
-              <a:t>texte</a:t>
-            </a:r>
-            <a:r>
-              <a:rPr sz="1900" b="1" dirty="0">
-                <a:solidFill>
-                  <a:srgbClr val="17222D"/>
-                </a:solidFill>
-                <a:latin typeface="Aptos"/>
-              </a:rPr>
-              <a:t>,
+              <a:t>produit texte,
 code, plan,
 résumé</a:t>
             </a:r>
@@ -6224,7 +5666,6 @@
           <a:lstStyle/>
           <a:p>
             <a:pPr algn="ctr"/>
-            <a:endParaRPr/>
           </a:p>
         </p:txBody>
       </p:sp>
@@ -6270,7 +5711,6 @@
           <a:lstStyle/>
           <a:p>
             <a:pPr algn="ctr"/>
-            <a:endParaRPr/>
           </a:p>
         </p:txBody>
       </p:sp>
@@ -6388,7 +5828,6 @@
           <a:lstStyle/>
           <a:p>
             <a:pPr algn="ctr"/>
-            <a:endParaRPr/>
           </a:p>
         </p:txBody>
       </p:sp>
@@ -6434,7 +5873,6 @@
           <a:lstStyle/>
           <a:p>
             <a:pPr algn="ctr"/>
-            <a:endParaRPr/>
           </a:p>
         </p:txBody>
       </p:sp>
@@ -6552,7 +5990,6 @@
           <a:lstStyle/>
           <a:p>
             <a:pPr algn="ctr"/>
-            <a:endParaRPr/>
           </a:p>
         </p:txBody>
       </p:sp>
@@ -6598,7 +6035,6 @@
           <a:lstStyle/>
           <a:p>
             <a:pPr algn="ctr"/>
-            <a:endParaRPr/>
           </a:p>
         </p:txBody>
       </p:sp>
@@ -6682,8 +6118,8 @@
         </p:nvSpPr>
         <p:spPr>
           <a:xfrm>
-            <a:off x="3310128" y="3072384"/>
-            <a:ext cx="274320" cy="256032"/>
+            <a:off x="3017520" y="2999232"/>
+            <a:ext cx="438912" cy="365760"/>
           </a:xfrm>
           <a:prstGeom prst="chevron">
             <a:avLst/>
@@ -6714,7 +6150,6 @@
           <a:lstStyle/>
           <a:p>
             <a:pPr algn="ctr"/>
-            <a:endParaRPr/>
           </a:p>
         </p:txBody>
       </p:sp>
@@ -6726,8 +6161,8 @@
         </p:nvSpPr>
         <p:spPr>
           <a:xfrm>
-            <a:off x="6163056" y="3072384"/>
-            <a:ext cx="274320" cy="256032"/>
+            <a:off x="5870448" y="2999232"/>
+            <a:ext cx="438912" cy="365760"/>
           </a:xfrm>
           <a:prstGeom prst="chevron">
             <a:avLst/>
@@ -6758,7 +6193,6 @@
           <a:lstStyle/>
           <a:p>
             <a:pPr algn="ctr"/>
-            <a:endParaRPr/>
           </a:p>
         </p:txBody>
       </p:sp>
@@ -6770,8 +6204,8 @@
         </p:nvSpPr>
         <p:spPr>
           <a:xfrm>
-            <a:off x="9015984" y="3072384"/>
-            <a:ext cx="274320" cy="256032"/>
+            <a:off x="8723376" y="2999232"/>
+            <a:ext cx="438912" cy="365760"/>
           </a:xfrm>
           <a:prstGeom prst="chevron">
             <a:avLst/>
@@ -6802,7 +6236,6 @@
           <a:lstStyle/>
           <a:p>
             <a:pPr algn="ctr"/>
-            <a:endParaRPr/>
           </a:p>
         </p:txBody>
       </p:sp>
@@ -6814,8 +6247,8 @@
         </p:nvSpPr>
         <p:spPr>
           <a:xfrm>
-            <a:off x="896112" y="4535424"/>
-            <a:ext cx="4800600" cy="987552"/>
+            <a:off x="896112" y="4572000"/>
+            <a:ext cx="4800600" cy="841248"/>
           </a:xfrm>
           <a:prstGeom prst="roundRect">
             <a:avLst/>
@@ -6848,7 +6281,6 @@
           <a:lstStyle/>
           <a:p>
             <a:pPr algn="ctr"/>
-            <a:endParaRPr/>
           </a:p>
         </p:txBody>
       </p:sp>
@@ -6860,7 +6292,7 @@
         </p:nvSpPr>
         <p:spPr>
           <a:xfrm>
-            <a:off x="1078992" y="4690872"/>
+            <a:off x="1078992" y="4736592"/>
             <a:ext cx="4443984" cy="182880"/>
           </a:xfrm>
           <a:prstGeom prst="rect">
@@ -6895,8 +6327,8 @@
         </p:nvSpPr>
         <p:spPr>
           <a:xfrm>
-            <a:off x="1078992" y="4946904"/>
-            <a:ext cx="4443984" cy="420624"/>
+            <a:off x="1078992" y="4974336"/>
+            <a:ext cx="4443984" cy="292608"/>
           </a:xfrm>
           <a:prstGeom prst="rect">
             <a:avLst/>
@@ -6911,7 +6343,7 @@
           <a:p>
             <a:pPr algn="ctr"/>
             <a:r>
-              <a:rPr sz="1700" b="1">
+              <a:rPr sz="1900" b="1">
                 <a:solidFill>
                   <a:srgbClr val="215472"/>
                 </a:solidFill>
@@ -6930,8 +6362,8 @@
         </p:nvSpPr>
         <p:spPr>
           <a:xfrm>
-            <a:off x="5989320" y="4535424"/>
-            <a:ext cx="5285232" cy="987552"/>
+            <a:off x="5989320" y="4572000"/>
+            <a:ext cx="5285232" cy="841248"/>
           </a:xfrm>
           <a:prstGeom prst="roundRect">
             <a:avLst/>
@@ -6964,7 +6396,6 @@
           <a:lstStyle/>
           <a:p>
             <a:pPr algn="ctr"/>
-            <a:endParaRPr/>
           </a:p>
         </p:txBody>
       </p:sp>
@@ -6976,7 +6407,7 @@
         </p:nvSpPr>
         <p:spPr>
           <a:xfrm>
-            <a:off x="6199632" y="4690872"/>
+            <a:off x="6199632" y="4736592"/>
             <a:ext cx="4864608" cy="182880"/>
           </a:xfrm>
           <a:prstGeom prst="rect">
@@ -7011,8 +6442,8 @@
         </p:nvSpPr>
         <p:spPr>
           <a:xfrm>
-            <a:off x="6199632" y="4946904"/>
-            <a:ext cx="4864608" cy="420624"/>
+            <a:off x="6199632" y="4974336"/>
+            <a:ext cx="4864608" cy="292608"/>
           </a:xfrm>
           <a:prstGeom prst="rect">
             <a:avLst/>
@@ -7027,7 +6458,7 @@
           <a:p>
             <a:pPr algn="ctr"/>
             <a:r>
-              <a:rPr sz="1700" b="1">
+              <a:rPr sz="1900" b="1">
                 <a:solidFill>
                   <a:srgbClr val="215472"/>
                 </a:solidFill>
@@ -7047,7 +6478,7 @@
 </file>
 
 <file path=ppt/slides/slide3.xml><?xml version="1.0" encoding="utf-8"?>
-<p:sld xmlns:a="http://schemas.openxmlformats.org/drawingml/2006/main" xmlns:r="http://schemas.openxmlformats.org/officeDocument/2006/relationships" xmlns:p="http://schemas.openxmlformats.org/presentationml/2006/main">
+<p:sld xmlns:a="http://schemas.openxmlformats.org/drawingml/2006/main" xmlns:p="http://schemas.openxmlformats.org/presentationml/2006/main" xmlns:r="http://schemas.openxmlformats.org/officeDocument/2006/relationships">
   <p:cSld>
     <p:bg>
       <p:bgPr>
@@ -7063,14 +6494,7 @@
         <p:cNvGrpSpPr/>
         <p:nvPr/>
       </p:nvGrpSpPr>
-      <p:grpSpPr>
-        <a:xfrm>
-          <a:off x="0" y="0"/>
-          <a:ext cx="0" cy="0"/>
-          <a:chOff x="0" y="0"/>
-          <a:chExt cx="0" cy="0"/>
-        </a:xfrm>
-      </p:grpSpPr>
+      <p:grpSpPr/>
       <p:sp>
         <p:nvSpPr>
           <p:cNvPr id="2" name="TextBox 1"/>
@@ -7181,7 +6605,6 @@
           <a:lstStyle/>
           <a:p>
             <a:pPr algn="ctr"/>
-            <a:endParaRPr/>
           </a:p>
         </p:txBody>
       </p:sp>
@@ -7193,8 +6616,143 @@
         </p:nvSpPr>
         <p:spPr>
           <a:xfrm>
-            <a:off x="822960" y="1901952"/>
-            <a:ext cx="2926080" cy="2468880"/>
+            <a:off x="713232" y="2907792"/>
+            <a:ext cx="3063240" cy="1389888"/>
+          </a:xfrm>
+          <a:prstGeom prst="roundRect">
+            <a:avLst/>
+          </a:prstGeom>
+          <a:solidFill>
+            <a:srgbClr val="F4F0EB"/>
+          </a:solidFill>
+          <a:ln w="15240">
+            <a:solidFill>
+              <a:srgbClr val="F4F0EB"/>
+            </a:solidFill>
+          </a:ln>
+        </p:spPr>
+        <p:style>
+          <a:lnRef idx="1">
+            <a:schemeClr val="accent1"/>
+          </a:lnRef>
+          <a:fillRef idx="3">
+            <a:schemeClr val="accent1"/>
+          </a:fillRef>
+          <a:effectRef idx="2">
+            <a:schemeClr val="accent1"/>
+          </a:effectRef>
+          <a:fontRef idx="minor">
+            <a:schemeClr val="lt1"/>
+          </a:fontRef>
+        </p:style>
+        <p:txBody>
+          <a:bodyPr rtlCol="0" anchor="ctr"/>
+          <a:lstStyle/>
+          <a:p>
+            <a:pPr algn="ctr"/>
+          </a:p>
+        </p:txBody>
+      </p:sp>
+      <p:sp>
+        <p:nvSpPr>
+          <p:cNvPr id="6" name="Rounded Rectangle 5"/>
+          <p:cNvSpPr/>
+          <p:nvPr/>
+        </p:nvSpPr>
+        <p:spPr>
+          <a:xfrm>
+            <a:off x="3703320" y="2359152"/>
+            <a:ext cx="3246120" cy="1938528"/>
+          </a:xfrm>
+          <a:prstGeom prst="roundRect">
+            <a:avLst/>
+          </a:prstGeom>
+          <a:solidFill>
+            <a:srgbClr val="F2EBE3"/>
+          </a:solidFill>
+          <a:ln w="15240">
+            <a:solidFill>
+              <a:srgbClr val="F2EBE3"/>
+            </a:solidFill>
+          </a:ln>
+        </p:spPr>
+        <p:style>
+          <a:lnRef idx="1">
+            <a:schemeClr val="accent1"/>
+          </a:lnRef>
+          <a:fillRef idx="3">
+            <a:schemeClr val="accent1"/>
+          </a:fillRef>
+          <a:effectRef idx="2">
+            <a:schemeClr val="accent1"/>
+          </a:effectRef>
+          <a:fontRef idx="minor">
+            <a:schemeClr val="lt1"/>
+          </a:fontRef>
+        </p:style>
+        <p:txBody>
+          <a:bodyPr rtlCol="0" anchor="ctr"/>
+          <a:lstStyle/>
+          <a:p>
+            <a:pPr algn="ctr"/>
+          </a:p>
+        </p:txBody>
+      </p:sp>
+      <p:sp>
+        <p:nvSpPr>
+          <p:cNvPr id="7" name="Rounded Rectangle 6"/>
+          <p:cNvSpPr/>
+          <p:nvPr/>
+        </p:nvSpPr>
+        <p:spPr>
+          <a:xfrm>
+            <a:off x="6931152" y="1810512"/>
+            <a:ext cx="3675887" cy="2487168"/>
+          </a:xfrm>
+          <a:prstGeom prst="roundRect">
+            <a:avLst/>
+          </a:prstGeom>
+          <a:solidFill>
+            <a:srgbClr val="EFE3D6"/>
+          </a:solidFill>
+          <a:ln w="15240">
+            <a:solidFill>
+              <a:srgbClr val="EFE3D6"/>
+            </a:solidFill>
+          </a:ln>
+        </p:spPr>
+        <p:style>
+          <a:lnRef idx="1">
+            <a:schemeClr val="accent1"/>
+          </a:lnRef>
+          <a:fillRef idx="3">
+            <a:schemeClr val="accent1"/>
+          </a:fillRef>
+          <a:effectRef idx="2">
+            <a:schemeClr val="accent1"/>
+          </a:effectRef>
+          <a:fontRef idx="minor">
+            <a:schemeClr val="lt1"/>
+          </a:fontRef>
+        </p:style>
+        <p:txBody>
+          <a:bodyPr rtlCol="0" anchor="ctr"/>
+          <a:lstStyle/>
+          <a:p>
+            <a:pPr algn="ctr"/>
+          </a:p>
+        </p:txBody>
+      </p:sp>
+      <p:sp>
+        <p:nvSpPr>
+          <p:cNvPr id="8" name="Rounded Rectangle 7"/>
+          <p:cNvSpPr/>
+          <p:nvPr/>
+        </p:nvSpPr>
+        <p:spPr>
+          <a:xfrm>
+            <a:off x="868680" y="2139696"/>
+            <a:ext cx="2697480" cy="1993392"/>
           </a:xfrm>
           <a:prstGeom prst="roundRect">
             <a:avLst/>
@@ -7227,19 +6785,18 @@
           <a:lstStyle/>
           <a:p>
             <a:pPr algn="ctr"/>
-            <a:endParaRPr/>
-          </a:p>
-        </p:txBody>
-      </p:sp>
-      <p:sp>
-        <p:nvSpPr>
-          <p:cNvPr id="6" name="Rounded Rectangle 5"/>
+          </a:p>
+        </p:txBody>
+      </p:sp>
+      <p:sp>
+        <p:nvSpPr>
+          <p:cNvPr id="9" name="Rounded Rectangle 8"/>
           <p:cNvSpPr/>
           <p:nvPr/>
         </p:nvSpPr>
         <p:spPr>
           <a:xfrm>
-            <a:off x="1042416" y="2066544"/>
+            <a:off x="1088136" y="2304288"/>
             <a:ext cx="1078992" cy="310896"/>
           </a:xfrm>
           <a:prstGeom prst="roundRect">
@@ -7273,19 +6830,18 @@
           <a:lstStyle/>
           <a:p>
             <a:pPr algn="ctr"/>
-            <a:endParaRPr/>
-          </a:p>
-        </p:txBody>
-      </p:sp>
-      <p:sp>
-        <p:nvSpPr>
-          <p:cNvPr id="7" name="TextBox 6"/>
+          </a:p>
+        </p:txBody>
+      </p:sp>
+      <p:sp>
+        <p:nvSpPr>
+          <p:cNvPr id="10" name="TextBox 9"/>
           <p:cNvSpPr txBox="1"/>
           <p:nvPr/>
         </p:nvSpPr>
         <p:spPr>
           <a:xfrm>
-            <a:off x="1042416" y="2093976"/>
+            <a:off x="1088136" y="2331720"/>
             <a:ext cx="1078992" cy="310896"/>
           </a:xfrm>
           <a:prstGeom prst="rect">
@@ -7314,14 +6870,14 @@
       </p:sp>
       <p:sp>
         <p:nvSpPr>
-          <p:cNvPr id="8" name="TextBox 7"/>
+          <p:cNvPr id="11" name="TextBox 10"/>
           <p:cNvSpPr txBox="1"/>
           <p:nvPr/>
         </p:nvSpPr>
         <p:spPr>
           <a:xfrm>
-            <a:off x="1042416" y="2468880"/>
-            <a:ext cx="2487168" cy="365760"/>
+            <a:off x="1088136" y="2706624"/>
+            <a:ext cx="2258568" cy="310896"/>
           </a:xfrm>
           <a:prstGeom prst="rect">
             <a:avLst/>
@@ -7336,7 +6892,7 @@
           <a:p>
             <a:pPr algn="ctr"/>
             <a:r>
-              <a:rPr sz="2200" b="1">
+              <a:rPr sz="2400" b="1">
                 <a:solidFill>
                   <a:srgbClr val="215472"/>
                 </a:solidFill>
@@ -7349,14 +6905,14 @@
       </p:sp>
       <p:sp>
         <p:nvSpPr>
-          <p:cNvPr id="9" name="TextBox 8"/>
+          <p:cNvPr id="12" name="TextBox 11"/>
           <p:cNvSpPr txBox="1"/>
           <p:nvPr/>
         </p:nvSpPr>
         <p:spPr>
           <a:xfrm>
-            <a:off x="1042416" y="2889504"/>
-            <a:ext cx="2487168" cy="219456"/>
+            <a:off x="1088136" y="3072384"/>
+            <a:ext cx="2258568" cy="219456"/>
           </a:xfrm>
           <a:prstGeom prst="rect">
             <a:avLst/>
@@ -7371,7 +6927,7 @@
           <a:p>
             <a:pPr algn="ctr"/>
             <a:r>
-              <a:rPr sz="1500" b="1">
+              <a:rPr sz="1600" b="1">
                 <a:solidFill>
                   <a:srgbClr val="BF5A24"/>
                 </a:solidFill>
@@ -7384,14 +6940,14 @@
       </p:sp>
       <p:sp>
         <p:nvSpPr>
-          <p:cNvPr id="10" name="TextBox 9"/>
+          <p:cNvPr id="13" name="TextBox 12"/>
           <p:cNvSpPr txBox="1"/>
           <p:nvPr/>
         </p:nvSpPr>
         <p:spPr>
           <a:xfrm>
-            <a:off x="1133856" y="3291840"/>
-            <a:ext cx="2304288" cy="475488"/>
+            <a:off x="1124712" y="3438144"/>
+            <a:ext cx="2185416" cy="658368"/>
           </a:xfrm>
           <a:prstGeom prst="rect">
             <a:avLst/>
@@ -7406,61 +6962,28 @@
           <a:p>
             <a:pPr algn="ctr"/>
             <a:r>
-              <a:rPr sz="1400" b="0" dirty="0">
+              <a:rPr sz="1700" b="0">
                 <a:solidFill>
                   <a:srgbClr val="5E656B"/>
                 </a:solidFill>
                 <a:latin typeface="Aptos"/>
               </a:rPr>
-              <a:t>• copier-</a:t>
-            </a:r>
-            <a:r>
-              <a:rPr sz="1400" b="0" dirty="0" err="1">
-                <a:solidFill>
-                  <a:srgbClr val="5E656B"/>
-                </a:solidFill>
-                <a:latin typeface="Aptos"/>
-              </a:rPr>
-              <a:t>coller</a:t>
-            </a:r>
-            <a:r>
-              <a:rPr sz="1400" b="0" dirty="0">
-                <a:solidFill>
-                  <a:srgbClr val="5E656B"/>
-                </a:solidFill>
-                <a:latin typeface="Aptos"/>
-              </a:rPr>
-              <a:t>
-• tests </a:t>
-            </a:r>
-            <a:r>
-              <a:rPr sz="1400" b="0" dirty="0" err="1">
-                <a:solidFill>
-                  <a:srgbClr val="5E656B"/>
-                </a:solidFill>
-                <a:latin typeface="Aptos"/>
-              </a:rPr>
-              <a:t>manuels</a:t>
-            </a:r>
-            <a:endParaRPr sz="1400" b="0" dirty="0">
-              <a:solidFill>
-                <a:srgbClr val="5E656B"/>
-              </a:solidFill>
-              <a:latin typeface="Aptos"/>
-            </a:endParaRPr>
-          </a:p>
-        </p:txBody>
-      </p:sp>
-      <p:sp>
-        <p:nvSpPr>
-          <p:cNvPr id="11" name="Rounded Rectangle 10"/>
+              <a:t>• copier-coller
+• tests à la main</a:t>
+            </a:r>
+          </a:p>
+        </p:txBody>
+      </p:sp>
+      <p:sp>
+        <p:nvSpPr>
+          <p:cNvPr id="14" name="Rounded Rectangle 13"/>
           <p:cNvSpPr/>
           <p:nvPr/>
         </p:nvSpPr>
         <p:spPr>
           <a:xfrm>
-            <a:off x="1554480" y="3877056"/>
-            <a:ext cx="1463040" cy="310896"/>
+            <a:off x="1440180" y="3639312"/>
+            <a:ext cx="1554480" cy="347472"/>
           </a:xfrm>
           <a:prstGeom prst="roundRect">
             <a:avLst/>
@@ -7493,20 +7016,19 @@
           <a:lstStyle/>
           <a:p>
             <a:pPr algn="ctr"/>
-            <a:endParaRPr/>
-          </a:p>
-        </p:txBody>
-      </p:sp>
-      <p:sp>
-        <p:nvSpPr>
-          <p:cNvPr id="12" name="TextBox 11"/>
+          </a:p>
+        </p:txBody>
+      </p:sp>
+      <p:sp>
+        <p:nvSpPr>
+          <p:cNvPr id="15" name="TextBox 14"/>
           <p:cNvSpPr txBox="1"/>
           <p:nvPr/>
         </p:nvSpPr>
         <p:spPr>
           <a:xfrm>
-            <a:off x="1554480" y="3904488"/>
-            <a:ext cx="1463040" cy="310896"/>
+            <a:off x="1440180" y="3666744"/>
+            <a:ext cx="1554480" cy="347472"/>
           </a:xfrm>
           <a:prstGeom prst="rect">
             <a:avLst/>
@@ -7521,7 +7043,7 @@
           <a:p>
             <a:pPr algn="ctr"/>
             <a:r>
-              <a:rPr sz="1000" b="1">
+              <a:rPr sz="1100" b="1">
                 <a:solidFill>
                   <a:srgbClr val="BF5A24"/>
                 </a:solidFill>
@@ -7534,14 +7056,14 @@
       </p:sp>
       <p:sp>
         <p:nvSpPr>
-          <p:cNvPr id="13" name="Rounded Rectangle 12"/>
+          <p:cNvPr id="16" name="Rounded Rectangle 15"/>
           <p:cNvSpPr/>
           <p:nvPr/>
         </p:nvSpPr>
         <p:spPr>
           <a:xfrm>
-            <a:off x="4005072" y="1901952"/>
-            <a:ext cx="2926080" cy="2468880"/>
+            <a:off x="3913632" y="1792224"/>
+            <a:ext cx="2834640" cy="2340864"/>
           </a:xfrm>
           <a:prstGeom prst="roundRect">
             <a:avLst/>
@@ -7574,19 +7096,18 @@
           <a:lstStyle/>
           <a:p>
             <a:pPr algn="ctr"/>
-            <a:endParaRPr/>
-          </a:p>
-        </p:txBody>
-      </p:sp>
-      <p:sp>
-        <p:nvSpPr>
-          <p:cNvPr id="14" name="Rounded Rectangle 13"/>
+          </a:p>
+        </p:txBody>
+      </p:sp>
+      <p:sp>
+        <p:nvSpPr>
+          <p:cNvPr id="17" name="Rounded Rectangle 16"/>
           <p:cNvSpPr/>
           <p:nvPr/>
         </p:nvSpPr>
         <p:spPr>
           <a:xfrm>
-            <a:off x="4224528" y="2066544"/>
+            <a:off x="4133088" y="1956816"/>
             <a:ext cx="1078992" cy="310896"/>
           </a:xfrm>
           <a:prstGeom prst="roundRect">
@@ -7620,19 +7141,18 @@
           <a:lstStyle/>
           <a:p>
             <a:pPr algn="ctr"/>
-            <a:endParaRPr/>
-          </a:p>
-        </p:txBody>
-      </p:sp>
-      <p:sp>
-        <p:nvSpPr>
-          <p:cNvPr id="15" name="TextBox 14"/>
+          </a:p>
+        </p:txBody>
+      </p:sp>
+      <p:sp>
+        <p:nvSpPr>
+          <p:cNvPr id="18" name="TextBox 17"/>
           <p:cNvSpPr txBox="1"/>
           <p:nvPr/>
         </p:nvSpPr>
         <p:spPr>
           <a:xfrm>
-            <a:off x="4224528" y="2093976"/>
+            <a:off x="4133088" y="1984248"/>
             <a:ext cx="1078992" cy="310896"/>
           </a:xfrm>
           <a:prstGeom prst="rect">
@@ -7661,14 +7181,14 @@
       </p:sp>
       <p:sp>
         <p:nvSpPr>
-          <p:cNvPr id="16" name="TextBox 15"/>
+          <p:cNvPr id="19" name="TextBox 18"/>
           <p:cNvSpPr txBox="1"/>
           <p:nvPr/>
         </p:nvSpPr>
         <p:spPr>
           <a:xfrm>
-            <a:off x="4224528" y="2468880"/>
-            <a:ext cx="2487168" cy="365760"/>
+            <a:off x="4133088" y="2359152"/>
+            <a:ext cx="2395728" cy="310896"/>
           </a:xfrm>
           <a:prstGeom prst="rect">
             <a:avLst/>
@@ -7683,7 +7203,7 @@
           <a:p>
             <a:pPr algn="ctr"/>
             <a:r>
-              <a:rPr sz="2200" b="1">
+              <a:rPr sz="2400" b="1">
                 <a:solidFill>
                   <a:srgbClr val="215472"/>
                 </a:solidFill>
@@ -7696,14 +7216,14 @@
       </p:sp>
       <p:sp>
         <p:nvSpPr>
-          <p:cNvPr id="17" name="TextBox 16"/>
+          <p:cNvPr id="20" name="TextBox 19"/>
           <p:cNvSpPr txBox="1"/>
           <p:nvPr/>
         </p:nvSpPr>
         <p:spPr>
           <a:xfrm>
-            <a:off x="4224528" y="2889504"/>
-            <a:ext cx="2487168" cy="219456"/>
+            <a:off x="4133088" y="2724912"/>
+            <a:ext cx="2395728" cy="219456"/>
           </a:xfrm>
           <a:prstGeom prst="rect">
             <a:avLst/>
@@ -7718,7 +7238,7 @@
           <a:p>
             <a:pPr algn="ctr"/>
             <a:r>
-              <a:rPr sz="1500" b="1">
+              <a:rPr sz="1600" b="1">
                 <a:solidFill>
                   <a:srgbClr val="BF5A24"/>
                 </a:solidFill>
@@ -7731,14 +7251,14 @@
       </p:sp>
       <p:sp>
         <p:nvSpPr>
-          <p:cNvPr id="18" name="TextBox 17"/>
+          <p:cNvPr id="21" name="TextBox 20"/>
           <p:cNvSpPr txBox="1"/>
           <p:nvPr/>
         </p:nvSpPr>
         <p:spPr>
           <a:xfrm>
-            <a:off x="4315968" y="3291840"/>
-            <a:ext cx="2304288" cy="475488"/>
+            <a:off x="4169664" y="3090672"/>
+            <a:ext cx="2322576" cy="658368"/>
           </a:xfrm>
           <a:prstGeom prst="rect">
             <a:avLst/>
@@ -7753,7 +7273,7 @@
           <a:p>
             <a:pPr algn="ctr"/>
             <a:r>
-              <a:rPr sz="1400" b="0">
+              <a:rPr sz="1700" b="0">
                 <a:solidFill>
                   <a:srgbClr val="5E656B"/>
                 </a:solidFill>
@@ -7767,14 +7287,14 @@
       </p:sp>
       <p:sp>
         <p:nvSpPr>
-          <p:cNvPr id="19" name="Rounded Rectangle 18"/>
+          <p:cNvPr id="22" name="Rounded Rectangle 21"/>
           <p:cNvSpPr/>
           <p:nvPr/>
         </p:nvSpPr>
         <p:spPr>
           <a:xfrm>
-            <a:off x="4736592" y="3877056"/>
-            <a:ext cx="1463040" cy="310896"/>
+            <a:off x="4553712" y="3639312"/>
+            <a:ext cx="1554480" cy="347472"/>
           </a:xfrm>
           <a:prstGeom prst="roundRect">
             <a:avLst/>
@@ -7807,20 +7327,19 @@
           <a:lstStyle/>
           <a:p>
             <a:pPr algn="ctr"/>
-            <a:endParaRPr/>
-          </a:p>
-        </p:txBody>
-      </p:sp>
-      <p:sp>
-        <p:nvSpPr>
-          <p:cNvPr id="20" name="TextBox 19"/>
+          </a:p>
+        </p:txBody>
+      </p:sp>
+      <p:sp>
+        <p:nvSpPr>
+          <p:cNvPr id="23" name="TextBox 22"/>
           <p:cNvSpPr txBox="1"/>
           <p:nvPr/>
         </p:nvSpPr>
         <p:spPr>
           <a:xfrm>
-            <a:off x="4736592" y="3904488"/>
-            <a:ext cx="1463040" cy="310896"/>
+            <a:off x="4553712" y="3666744"/>
+            <a:ext cx="1554480" cy="347472"/>
           </a:xfrm>
           <a:prstGeom prst="rect">
             <a:avLst/>
@@ -7835,7 +7354,7 @@
           <a:p>
             <a:pPr algn="ctr"/>
             <a:r>
-              <a:rPr sz="1000" b="1">
+              <a:rPr sz="1100" b="1">
                 <a:solidFill>
                   <a:srgbClr val="BF5A24"/>
                 </a:solidFill>
@@ -7848,14 +7367,14 @@
       </p:sp>
       <p:sp>
         <p:nvSpPr>
-          <p:cNvPr id="21" name="Rounded Rectangle 20"/>
+          <p:cNvPr id="24" name="Rounded Rectangle 23"/>
           <p:cNvSpPr/>
           <p:nvPr/>
         </p:nvSpPr>
         <p:spPr>
           <a:xfrm>
-            <a:off x="7187184" y="1901952"/>
-            <a:ext cx="3291840" cy="2468880"/>
+            <a:off x="7269480" y="1389888"/>
+            <a:ext cx="3246120" cy="2743200"/>
           </a:xfrm>
           <a:prstGeom prst="roundRect">
             <a:avLst/>
@@ -7888,19 +7407,18 @@
           <a:lstStyle/>
           <a:p>
             <a:pPr algn="ctr"/>
-            <a:endParaRPr/>
-          </a:p>
-        </p:txBody>
-      </p:sp>
-      <p:sp>
-        <p:nvSpPr>
-          <p:cNvPr id="22" name="Rounded Rectangle 21"/>
+          </a:p>
+        </p:txBody>
+      </p:sp>
+      <p:sp>
+        <p:nvSpPr>
+          <p:cNvPr id="25" name="Rounded Rectangle 24"/>
           <p:cNvSpPr/>
           <p:nvPr/>
         </p:nvSpPr>
         <p:spPr>
           <a:xfrm>
-            <a:off x="7406640" y="2066544"/>
+            <a:off x="7488936" y="1554480"/>
             <a:ext cx="1078992" cy="310896"/>
           </a:xfrm>
           <a:prstGeom prst="roundRect">
@@ -7934,19 +7452,18 @@
           <a:lstStyle/>
           <a:p>
             <a:pPr algn="ctr"/>
-            <a:endParaRPr/>
-          </a:p>
-        </p:txBody>
-      </p:sp>
-      <p:sp>
-        <p:nvSpPr>
-          <p:cNvPr id="23" name="TextBox 22"/>
+          </a:p>
+        </p:txBody>
+      </p:sp>
+      <p:sp>
+        <p:nvSpPr>
+          <p:cNvPr id="26" name="TextBox 25"/>
           <p:cNvSpPr txBox="1"/>
           <p:nvPr/>
         </p:nvSpPr>
         <p:spPr>
           <a:xfrm>
-            <a:off x="7406640" y="2093976"/>
+            <a:off x="7488936" y="1581912"/>
             <a:ext cx="1078992" cy="310896"/>
           </a:xfrm>
           <a:prstGeom prst="rect">
@@ -7975,14 +7492,14 @@
       </p:sp>
       <p:sp>
         <p:nvSpPr>
-          <p:cNvPr id="24" name="TextBox 23"/>
+          <p:cNvPr id="27" name="TextBox 26"/>
           <p:cNvSpPr txBox="1"/>
           <p:nvPr/>
         </p:nvSpPr>
         <p:spPr>
           <a:xfrm>
-            <a:off x="7406640" y="2468880"/>
-            <a:ext cx="2852928" cy="365760"/>
+            <a:off x="7488936" y="1956816"/>
+            <a:ext cx="2807208" cy="310896"/>
           </a:xfrm>
           <a:prstGeom prst="rect">
             <a:avLst/>
@@ -7997,7 +7514,7 @@
           <a:p>
             <a:pPr algn="ctr"/>
             <a:r>
-              <a:rPr sz="1900" b="1">
+              <a:rPr sz="2400" b="1">
                 <a:solidFill>
                   <a:srgbClr val="215472"/>
                 </a:solidFill>
@@ -8010,14 +7527,14 @@
       </p:sp>
       <p:sp>
         <p:nvSpPr>
-          <p:cNvPr id="25" name="TextBox 24"/>
+          <p:cNvPr id="28" name="TextBox 27"/>
           <p:cNvSpPr txBox="1"/>
           <p:nvPr/>
         </p:nvSpPr>
         <p:spPr>
           <a:xfrm>
-            <a:off x="7406640" y="2889504"/>
-            <a:ext cx="2852928" cy="219456"/>
+            <a:off x="7488936" y="2322576"/>
+            <a:ext cx="2807208" cy="219456"/>
           </a:xfrm>
           <a:prstGeom prst="rect">
             <a:avLst/>
@@ -8032,7 +7549,7 @@
           <a:p>
             <a:pPr algn="ctr"/>
             <a:r>
-              <a:rPr sz="1500" b="1">
+              <a:rPr sz="1600" b="1">
                 <a:solidFill>
                   <a:srgbClr val="BF5A24"/>
                 </a:solidFill>
@@ -8045,14 +7562,14 @@
       </p:sp>
       <p:sp>
         <p:nvSpPr>
-          <p:cNvPr id="26" name="TextBox 25"/>
+          <p:cNvPr id="29" name="TextBox 28"/>
           <p:cNvSpPr txBox="1"/>
           <p:nvPr/>
         </p:nvSpPr>
         <p:spPr>
           <a:xfrm>
-            <a:off x="7498080" y="3291840"/>
-            <a:ext cx="2670048" cy="475488"/>
+            <a:off x="7525512" y="2688336"/>
+            <a:ext cx="2734056" cy="658368"/>
           </a:xfrm>
           <a:prstGeom prst="rect">
             <a:avLst/>
@@ -8067,7 +7584,7 @@
           <a:p>
             <a:pPr algn="ctr"/>
             <a:r>
-              <a:rPr sz="1400" b="0">
+              <a:rPr sz="1700" b="0">
                 <a:solidFill>
                   <a:srgbClr val="5E656B"/>
                 </a:solidFill>
@@ -8081,14 +7598,14 @@
       </p:sp>
       <p:sp>
         <p:nvSpPr>
-          <p:cNvPr id="27" name="Rounded Rectangle 26"/>
+          <p:cNvPr id="30" name="Rounded Rectangle 29"/>
           <p:cNvSpPr/>
           <p:nvPr/>
         </p:nvSpPr>
         <p:spPr>
           <a:xfrm>
-            <a:off x="8101584" y="3877056"/>
-            <a:ext cx="1463040" cy="310896"/>
+            <a:off x="8115300" y="3639312"/>
+            <a:ext cx="1554480" cy="347472"/>
           </a:xfrm>
           <a:prstGeom prst="roundRect">
             <a:avLst/>
@@ -8121,20 +7638,19 @@
           <a:lstStyle/>
           <a:p>
             <a:pPr algn="ctr"/>
-            <a:endParaRPr/>
-          </a:p>
-        </p:txBody>
-      </p:sp>
-      <p:sp>
-        <p:nvSpPr>
-          <p:cNvPr id="28" name="TextBox 27"/>
+          </a:p>
+        </p:txBody>
+      </p:sp>
+      <p:sp>
+        <p:nvSpPr>
+          <p:cNvPr id="31" name="TextBox 30"/>
           <p:cNvSpPr txBox="1"/>
           <p:nvPr/>
         </p:nvSpPr>
         <p:spPr>
           <a:xfrm>
-            <a:off x="8101584" y="3904488"/>
-            <a:ext cx="1463040" cy="310896"/>
+            <a:off x="8115300" y="3666744"/>
+            <a:ext cx="1554480" cy="347472"/>
           </a:xfrm>
           <a:prstGeom prst="rect">
             <a:avLst/>
@@ -8149,7 +7665,7 @@
           <a:p>
             <a:pPr algn="ctr"/>
             <a:r>
-              <a:rPr sz="1000" b="1">
+              <a:rPr sz="1100" b="1">
                 <a:solidFill>
                   <a:srgbClr val="BF5A24"/>
                 </a:solidFill>
@@ -8162,13 +7678,13 @@
       </p:sp>
       <p:sp>
         <p:nvSpPr>
-          <p:cNvPr id="29" name="Chevron 28"/>
+          <p:cNvPr id="32" name="Chevron 31"/>
           <p:cNvSpPr/>
           <p:nvPr/>
         </p:nvSpPr>
         <p:spPr>
           <a:xfrm>
-            <a:off x="1371600" y="4736592"/>
+            <a:off x="1371600" y="4663440"/>
             <a:ext cx="9052560" cy="384048"/>
           </a:xfrm>
           <a:prstGeom prst="chevron">
@@ -8200,20 +7716,19 @@
           <a:lstStyle/>
           <a:p>
             <a:pPr algn="ctr"/>
-            <a:endParaRPr/>
-          </a:p>
-        </p:txBody>
-      </p:sp>
-      <p:sp>
-        <p:nvSpPr>
-          <p:cNvPr id="30" name="TextBox 29"/>
+          </a:p>
+        </p:txBody>
+      </p:sp>
+      <p:sp>
+        <p:nvSpPr>
+          <p:cNvPr id="33" name="TextBox 32"/>
           <p:cNvSpPr txBox="1"/>
           <p:nvPr/>
         </p:nvSpPr>
         <p:spPr>
           <a:xfrm>
-            <a:off x="1417320" y="5157216"/>
-            <a:ext cx="8961120" cy="438912"/>
+            <a:off x="1417320" y="5102352"/>
+            <a:ext cx="8961120" cy="347472"/>
           </a:xfrm>
           <a:prstGeom prst="rect">
             <a:avLst/>
@@ -8228,7 +7743,7 @@
           <a:p>
             <a:pPr algn="ctr"/>
             <a:r>
-              <a:rPr sz="2000" b="1">
+              <a:rPr sz="2100" b="1">
                 <a:solidFill>
                   <a:srgbClr val="BF5A24"/>
                 </a:solidFill>
@@ -8248,7 +7763,7 @@
 </file>
 
 <file path=ppt/slides/slide4.xml><?xml version="1.0" encoding="utf-8"?>
-<p:sld xmlns:a="http://schemas.openxmlformats.org/drawingml/2006/main" xmlns:r="http://schemas.openxmlformats.org/officeDocument/2006/relationships" xmlns:p="http://schemas.openxmlformats.org/presentationml/2006/main">
+<p:sld xmlns:a="http://schemas.openxmlformats.org/drawingml/2006/main" xmlns:p="http://schemas.openxmlformats.org/presentationml/2006/main" xmlns:r="http://schemas.openxmlformats.org/officeDocument/2006/relationships">
   <p:cSld>
     <p:bg>
       <p:bgPr>
@@ -8264,14 +7779,7 @@
         <p:cNvGrpSpPr/>
         <p:nvPr/>
       </p:nvGrpSpPr>
-      <p:grpSpPr>
-        <a:xfrm>
-          <a:off x="0" y="0"/>
-          <a:ext cx="0" cy="0"/>
-          <a:chOff x="0" y="0"/>
-          <a:chExt cx="0" cy="0"/>
-        </a:xfrm>
-      </p:grpSpPr>
+      <p:grpSpPr/>
       <p:sp>
         <p:nvSpPr>
           <p:cNvPr id="2" name="TextBox 1"/>
@@ -8382,7 +7890,6 @@
           <a:lstStyle/>
           <a:p>
             <a:pPr algn="ctr"/>
-            <a:endParaRPr/>
           </a:p>
         </p:txBody>
       </p:sp>
@@ -8428,7 +7935,6 @@
           <a:lstStyle/>
           <a:p>
             <a:pPr algn="ctr"/>
-            <a:endParaRPr/>
           </a:p>
         </p:txBody>
       </p:sp>
@@ -8545,7 +8051,6 @@
           <a:lstStyle/>
           <a:p>
             <a:pPr algn="ctr"/>
-            <a:endParaRPr/>
           </a:p>
         </p:txBody>
       </p:sp>
@@ -8614,9 +8119,8 @@
                 </a:solidFill>
                 <a:latin typeface="Aptos"/>
               </a:rPr>
-              <a:t>prompt
-AGENTS.md
-skills du repo</a:t>
+              <a:t>prompt + AGENTS.md
++ skills du repo</a:t>
             </a:r>
           </a:p>
         </p:txBody>
@@ -8663,7 +8167,6 @@
           <a:lstStyle/>
           <a:p>
             <a:pPr algn="ctr"/>
-            <a:endParaRPr/>
           </a:p>
         </p:txBody>
       </p:sp>
@@ -8778,7 +8281,6 @@
           <a:lstStyle/>
           <a:p>
             <a:pPr algn="ctr"/>
-            <a:endParaRPr/>
           </a:p>
         </p:txBody>
       </p:sp>
@@ -8822,7 +8324,6 @@
           <a:lstStyle/>
           <a:p>
             <a:pPr algn="ctr"/>
-            <a:endParaRPr/>
           </a:p>
         </p:txBody>
       </p:sp>
@@ -8834,8 +8335,8 @@
         </p:nvSpPr>
         <p:spPr>
           <a:xfrm>
-            <a:off x="914400" y="4608576"/>
-            <a:ext cx="10058400" cy="768096"/>
+            <a:off x="914400" y="4709160"/>
+            <a:ext cx="10058400" cy="658368"/>
           </a:xfrm>
           <a:prstGeom prst="roundRect">
             <a:avLst/>
@@ -8868,7 +8369,6 @@
           <a:lstStyle/>
           <a:p>
             <a:pPr algn="ctr"/>
-            <a:endParaRPr/>
           </a:p>
         </p:txBody>
       </p:sp>
@@ -8880,8 +8380,8 @@
         </p:nvSpPr>
         <p:spPr>
           <a:xfrm>
-            <a:off x="1143000" y="4791456"/>
-            <a:ext cx="9601200" cy="310896"/>
+            <a:off x="1143000" y="4919472"/>
+            <a:ext cx="9601200" cy="219456"/>
           </a:xfrm>
           <a:prstGeom prst="rect">
             <a:avLst/>
@@ -8896,7 +8396,7 @@
           <a:p>
             <a:pPr algn="ctr"/>
             <a:r>
-              <a:rPr sz="1700" b="1">
+              <a:rPr sz="1800" b="1">
                 <a:solidFill>
                   <a:srgbClr val="BF5A24"/>
                 </a:solidFill>
@@ -8915,8 +8415,8 @@
         </p:nvSpPr>
         <p:spPr>
           <a:xfrm>
-            <a:off x="914400" y="5486400"/>
-            <a:ext cx="10058400" cy="676656"/>
+            <a:off x="914400" y="5504688"/>
+            <a:ext cx="10058400" cy="713232"/>
           </a:xfrm>
           <a:prstGeom prst="roundRect">
             <a:avLst/>
@@ -8949,7 +8449,6 @@
           <a:lstStyle/>
           <a:p>
             <a:pPr algn="ctr"/>
-            <a:endParaRPr/>
           </a:p>
         </p:txBody>
       </p:sp>
@@ -8962,7 +8461,7 @@
         <p:spPr>
           <a:xfrm>
             <a:off x="1188720" y="5650992"/>
-            <a:ext cx="9509760" cy="256032"/>
+            <a:ext cx="9509760" cy="274320"/>
           </a:xfrm>
           <a:prstGeom prst="rect">
             <a:avLst/>
@@ -8977,7 +8476,7 @@
           <a:p>
             <a:pPr algn="ctr"/>
             <a:r>
-              <a:rPr sz="1500" b="1">
+              <a:rPr sz="1600" b="1">
                 <a:solidFill>
                   <a:srgbClr val="215472"/>
                 </a:solidFill>
@@ -8997,7 +8496,7 @@
 </file>
 
 <file path=ppt/slides/slide5.xml><?xml version="1.0" encoding="utf-8"?>
-<p:sld xmlns:a="http://schemas.openxmlformats.org/drawingml/2006/main" xmlns:r="http://schemas.openxmlformats.org/officeDocument/2006/relationships" xmlns:p="http://schemas.openxmlformats.org/presentationml/2006/main">
+<p:sld xmlns:a="http://schemas.openxmlformats.org/drawingml/2006/main" xmlns:p="http://schemas.openxmlformats.org/presentationml/2006/main" xmlns:r="http://schemas.openxmlformats.org/officeDocument/2006/relationships">
   <p:cSld>
     <p:bg>
       <p:bgPr>
@@ -9013,14 +8512,7 @@
         <p:cNvGrpSpPr/>
         <p:nvPr/>
       </p:nvGrpSpPr>
-      <p:grpSpPr>
-        <a:xfrm>
-          <a:off x="0" y="0"/>
-          <a:ext cx="0" cy="0"/>
-          <a:chOff x="0" y="0"/>
-          <a:chExt cx="0" cy="0"/>
-        </a:xfrm>
-      </p:grpSpPr>
+      <p:grpSpPr/>
       <p:sp>
         <p:nvSpPr>
           <p:cNvPr id="2" name="TextBox 1"/>
@@ -9131,7 +8623,6 @@
           <a:lstStyle/>
           <a:p>
             <a:pPr algn="ctr"/>
-            <a:endParaRPr/>
           </a:p>
         </p:txBody>
       </p:sp>
@@ -9143,8 +8634,8 @@
         </p:nvSpPr>
         <p:spPr>
           <a:xfrm>
-            <a:off x="786384" y="2359152"/>
-            <a:ext cx="2267712" cy="1170432"/>
+            <a:off x="841248" y="2331720"/>
+            <a:ext cx="2057400" cy="1188720"/>
           </a:xfrm>
           <a:prstGeom prst="roundRect">
             <a:avLst/>
@@ -9177,7 +8668,6 @@
           <a:lstStyle/>
           <a:p>
             <a:pPr algn="ctr"/>
-            <a:endParaRPr/>
           </a:p>
         </p:txBody>
       </p:sp>
@@ -9189,7 +8679,7 @@
         </p:nvSpPr>
         <p:spPr>
           <a:xfrm>
-            <a:off x="1700784" y="1993392"/>
+            <a:off x="1591056" y="1993392"/>
             <a:ext cx="566928" cy="329184"/>
           </a:xfrm>
           <a:prstGeom prst="roundRect">
@@ -9223,7 +8713,6 @@
           <a:lstStyle/>
           <a:p>
             <a:pPr algn="ctr"/>
-            <a:endParaRPr/>
           </a:p>
         </p:txBody>
       </p:sp>
@@ -9235,7 +8724,7 @@
         </p:nvSpPr>
         <p:spPr>
           <a:xfrm>
-            <a:off x="1700784" y="2020824"/>
+            <a:off x="1591056" y="2020824"/>
             <a:ext cx="566928" cy="329184"/>
           </a:xfrm>
           <a:prstGeom prst="rect">
@@ -9270,8 +8759,8 @@
         </p:nvSpPr>
         <p:spPr>
           <a:xfrm>
-            <a:off x="932688" y="2788920"/>
-            <a:ext cx="2066543" cy="310896"/>
+            <a:off x="950976" y="2743200"/>
+            <a:ext cx="1828800" cy="219456"/>
           </a:xfrm>
           <a:prstGeom prst="rect">
             <a:avLst/>
@@ -9286,13 +8775,13 @@
           <a:p>
             <a:pPr algn="ctr"/>
             <a:r>
-              <a:rPr sz="1700" b="1">
+              <a:rPr sz="1800" b="1">
                 <a:solidFill>
                   <a:srgbClr val="1A1F24"/>
                 </a:solidFill>
                 <a:latin typeface="Aptos"/>
               </a:rPr>
-              <a:t>métadonnées repo</a:t>
+              <a:t>métadonnées</a:t>
             </a:r>
           </a:p>
         </p:txBody>
@@ -9305,8 +8794,8 @@
         </p:nvSpPr>
         <p:spPr>
           <a:xfrm>
-            <a:off x="3227832" y="2852928"/>
-            <a:ext cx="274320" cy="201168"/>
+            <a:off x="2743200" y="2743200"/>
+            <a:ext cx="347472" cy="256032"/>
           </a:xfrm>
           <a:prstGeom prst="chevron">
             <a:avLst/>
@@ -9337,7 +8826,6 @@
           <a:lstStyle/>
           <a:p>
             <a:pPr algn="ctr"/>
-            <a:endParaRPr/>
           </a:p>
         </p:txBody>
       </p:sp>
@@ -9349,8 +8837,8 @@
         </p:nvSpPr>
         <p:spPr>
           <a:xfrm>
-            <a:off x="3575303" y="2359152"/>
-            <a:ext cx="2267712" cy="1170432"/>
+            <a:off x="3493008" y="2331720"/>
+            <a:ext cx="2057400" cy="1188720"/>
           </a:xfrm>
           <a:prstGeom prst="roundRect">
             <a:avLst/>
@@ -9383,7 +8871,6 @@
           <a:lstStyle/>
           <a:p>
             <a:pPr algn="ctr"/>
-            <a:endParaRPr/>
           </a:p>
         </p:txBody>
       </p:sp>
@@ -9395,7 +8882,7 @@
         </p:nvSpPr>
         <p:spPr>
           <a:xfrm>
-            <a:off x="4489703" y="1993392"/>
+            <a:off x="4242816" y="1993392"/>
             <a:ext cx="566928" cy="329184"/>
           </a:xfrm>
           <a:prstGeom prst="roundRect">
@@ -9429,7 +8916,6 @@
           <a:lstStyle/>
           <a:p>
             <a:pPr algn="ctr"/>
-            <a:endParaRPr/>
           </a:p>
         </p:txBody>
       </p:sp>
@@ -9441,7 +8927,7 @@
         </p:nvSpPr>
         <p:spPr>
           <a:xfrm>
-            <a:off x="4489703" y="2020824"/>
+            <a:off x="4242816" y="2020824"/>
             <a:ext cx="566928" cy="329184"/>
           </a:xfrm>
           <a:prstGeom prst="rect">
@@ -9476,8 +8962,8 @@
         </p:nvSpPr>
         <p:spPr>
           <a:xfrm>
-            <a:off x="3721607" y="2788920"/>
-            <a:ext cx="2066543" cy="310896"/>
+            <a:off x="3602736" y="2743200"/>
+            <a:ext cx="1828800" cy="219456"/>
           </a:xfrm>
           <a:prstGeom prst="rect">
             <a:avLst/>
@@ -9492,7 +8978,7 @@
           <a:p>
             <a:pPr algn="ctr"/>
             <a:r>
-              <a:rPr sz="1700" b="1">
+              <a:rPr sz="1800" b="1">
                 <a:solidFill>
                   <a:srgbClr val="1A1F24"/>
                 </a:solidFill>
@@ -9511,8 +8997,8 @@
         </p:nvSpPr>
         <p:spPr>
           <a:xfrm>
-            <a:off x="6016752" y="2852928"/>
-            <a:ext cx="274320" cy="201168"/>
+            <a:off x="5394960" y="2743200"/>
+            <a:ext cx="347472" cy="256032"/>
           </a:xfrm>
           <a:prstGeom prst="chevron">
             <a:avLst/>
@@ -9543,7 +9029,6 @@
           <a:lstStyle/>
           <a:p>
             <a:pPr algn="ctr"/>
-            <a:endParaRPr/>
           </a:p>
         </p:txBody>
       </p:sp>
@@ -9555,8 +9040,8 @@
         </p:nvSpPr>
         <p:spPr>
           <a:xfrm>
-            <a:off x="6364224" y="2359152"/>
-            <a:ext cx="2267712" cy="1170432"/>
+            <a:off x="6144768" y="2331720"/>
+            <a:ext cx="2057400" cy="1188720"/>
           </a:xfrm>
           <a:prstGeom prst="roundRect">
             <a:avLst/>
@@ -9589,7 +9074,6 @@
           <a:lstStyle/>
           <a:p>
             <a:pPr algn="ctr"/>
-            <a:endParaRPr/>
           </a:p>
         </p:txBody>
       </p:sp>
@@ -9601,7 +9085,7 @@
         </p:nvSpPr>
         <p:spPr>
           <a:xfrm>
-            <a:off x="7278624" y="1993392"/>
+            <a:off x="6894576" y="1993392"/>
             <a:ext cx="566928" cy="329184"/>
           </a:xfrm>
           <a:prstGeom prst="roundRect">
@@ -9635,7 +9119,6 @@
           <a:lstStyle/>
           <a:p>
             <a:pPr algn="ctr"/>
-            <a:endParaRPr/>
           </a:p>
         </p:txBody>
       </p:sp>
@@ -9647,7 +9130,7 @@
         </p:nvSpPr>
         <p:spPr>
           <a:xfrm>
-            <a:off x="7278624" y="2020824"/>
+            <a:off x="6894576" y="2020824"/>
             <a:ext cx="566928" cy="329184"/>
           </a:xfrm>
           <a:prstGeom prst="rect">
@@ -9682,8 +9165,8 @@
         </p:nvSpPr>
         <p:spPr>
           <a:xfrm>
-            <a:off x="6510528" y="2788920"/>
-            <a:ext cx="2066543" cy="310896"/>
+            <a:off x="6254496" y="2743200"/>
+            <a:ext cx="1828800" cy="219456"/>
           </a:xfrm>
           <a:prstGeom prst="rect">
             <a:avLst/>
@@ -9698,7 +9181,7 @@
           <a:p>
             <a:pPr algn="ctr"/>
             <a:r>
-              <a:rPr sz="1700" b="1">
+              <a:rPr sz="1800" b="1">
                 <a:solidFill>
                   <a:srgbClr val="1A1F24"/>
                 </a:solidFill>
@@ -9717,8 +9200,8 @@
         </p:nvSpPr>
         <p:spPr>
           <a:xfrm>
-            <a:off x="8805672" y="2852928"/>
-            <a:ext cx="274320" cy="201168"/>
+            <a:off x="8046720" y="2743200"/>
+            <a:ext cx="347472" cy="256032"/>
           </a:xfrm>
           <a:prstGeom prst="chevron">
             <a:avLst/>
@@ -9749,7 +9232,6 @@
           <a:lstStyle/>
           <a:p>
             <a:pPr algn="ctr"/>
-            <a:endParaRPr/>
           </a:p>
         </p:txBody>
       </p:sp>
@@ -9761,8 +9243,8 @@
         </p:nvSpPr>
         <p:spPr>
           <a:xfrm>
-            <a:off x="9153143" y="2359152"/>
-            <a:ext cx="2267712" cy="1170432"/>
+            <a:off x="8796528" y="2331720"/>
+            <a:ext cx="2057400" cy="1188720"/>
           </a:xfrm>
           <a:prstGeom prst="roundRect">
             <a:avLst/>
@@ -9795,7 +9277,6 @@
           <a:lstStyle/>
           <a:p>
             <a:pPr algn="ctr"/>
-            <a:endParaRPr/>
           </a:p>
         </p:txBody>
       </p:sp>
@@ -9807,7 +9288,7 @@
         </p:nvSpPr>
         <p:spPr>
           <a:xfrm>
-            <a:off x="10067543" y="1993392"/>
+            <a:off x="9546336" y="1993392"/>
             <a:ext cx="566928" cy="329184"/>
           </a:xfrm>
           <a:prstGeom prst="roundRect">
@@ -9841,7 +9322,6 @@
           <a:lstStyle/>
           <a:p>
             <a:pPr algn="ctr"/>
-            <a:endParaRPr/>
           </a:p>
         </p:txBody>
       </p:sp>
@@ -9853,7 +9333,7 @@
         </p:nvSpPr>
         <p:spPr>
           <a:xfrm>
-            <a:off x="10067543" y="2020824"/>
+            <a:off x="9546336" y="2020824"/>
             <a:ext cx="566928" cy="329184"/>
           </a:xfrm>
           <a:prstGeom prst="rect">
@@ -9888,8 +9368,8 @@
         </p:nvSpPr>
         <p:spPr>
           <a:xfrm>
-            <a:off x="9299447" y="2788920"/>
-            <a:ext cx="2066543" cy="310896"/>
+            <a:off x="8906256" y="2743200"/>
+            <a:ext cx="1828800" cy="219456"/>
           </a:xfrm>
           <a:prstGeom prst="rect">
             <a:avLst/>
@@ -9904,7 +9384,7 @@
           <a:p>
             <a:pPr algn="ctr"/>
             <a:r>
-              <a:rPr sz="1700" b="1">
+              <a:rPr sz="1800" b="1">
                 <a:solidFill>
                   <a:srgbClr val="1A1F24"/>
                 </a:solidFill>
@@ -9923,8 +9403,8 @@
         </p:nvSpPr>
         <p:spPr>
           <a:xfrm>
-            <a:off x="1051560" y="4590288"/>
-            <a:ext cx="10012680" cy="749808"/>
+            <a:off x="1097280" y="4572000"/>
+            <a:ext cx="9875520" cy="786384"/>
           </a:xfrm>
           <a:prstGeom prst="roundRect">
             <a:avLst/>
@@ -9957,7 +9437,6 @@
           <a:lstStyle/>
           <a:p>
             <a:pPr algn="ctr"/>
-            <a:endParaRPr/>
           </a:p>
         </p:txBody>
       </p:sp>
@@ -9969,8 +9448,8 @@
         </p:nvSpPr>
         <p:spPr>
           <a:xfrm>
-            <a:off x="1298448" y="4800600"/>
-            <a:ext cx="9509760" cy="310896"/>
+            <a:off x="1325880" y="4818888"/>
+            <a:ext cx="9326880" cy="219456"/>
           </a:xfrm>
           <a:prstGeom prst="rect">
             <a:avLst/>
@@ -9985,7 +9464,7 @@
           <a:p>
             <a:pPr algn="ctr"/>
             <a:r>
-              <a:rPr sz="1800" b="1">
+              <a:rPr sz="1900" b="1">
                 <a:solidFill>
                   <a:srgbClr val="BF5A24"/>
                 </a:solidFill>
@@ -10005,7 +9484,7 @@
 </file>
 
 <file path=ppt/slides/slide6.xml><?xml version="1.0" encoding="utf-8"?>
-<p:sld xmlns:a="http://schemas.openxmlformats.org/drawingml/2006/main" xmlns:r="http://schemas.openxmlformats.org/officeDocument/2006/relationships" xmlns:p="http://schemas.openxmlformats.org/presentationml/2006/main">
+<p:sld xmlns:a="http://schemas.openxmlformats.org/drawingml/2006/main" xmlns:p="http://schemas.openxmlformats.org/presentationml/2006/main" xmlns:r="http://schemas.openxmlformats.org/officeDocument/2006/relationships">
   <p:cSld>
     <p:bg>
       <p:bgPr>
@@ -10021,14 +9500,7 @@
         <p:cNvGrpSpPr/>
         <p:nvPr/>
       </p:nvGrpSpPr>
-      <p:grpSpPr>
-        <a:xfrm>
-          <a:off x="0" y="0"/>
-          <a:ext cx="0" cy="0"/>
-          <a:chOff x="0" y="0"/>
-          <a:chExt cx="0" cy="0"/>
-        </a:xfrm>
-      </p:grpSpPr>
+      <p:grpSpPr/>
       <p:sp>
         <p:nvSpPr>
           <p:cNvPr id="2" name="TextBox 1"/>
@@ -10139,7 +9611,6 @@
           <a:lstStyle/>
           <a:p>
             <a:pPr algn="ctr"/>
-            <a:endParaRPr/>
           </a:p>
         </p:txBody>
       </p:sp>
@@ -10185,7 +9656,6 @@
           <a:lstStyle/>
           <a:p>
             <a:pPr algn="ctr"/>
-            <a:endParaRPr/>
           </a:p>
         </p:txBody>
       </p:sp>
@@ -10232,8 +9702,8 @@
         </p:nvSpPr>
         <p:spPr>
           <a:xfrm>
-            <a:off x="1618488" y="2852927"/>
-            <a:ext cx="1463040" cy="482317"/>
+            <a:off x="1618488" y="2852928"/>
+            <a:ext cx="1463040" cy="365760"/>
           </a:xfrm>
           <a:prstGeom prst="roundRect">
             <a:avLst/>
@@ -10266,7 +9736,6 @@
           <a:lstStyle/>
           <a:p>
             <a:pPr algn="ctr"/>
-            <a:endParaRPr sz="3600"/>
           </a:p>
         </p:txBody>
       </p:sp>
@@ -10278,8 +9747,8 @@
         </p:nvSpPr>
         <p:spPr>
           <a:xfrm>
-            <a:off x="1618488" y="2827810"/>
-            <a:ext cx="1463040" cy="461665"/>
+            <a:off x="1618488" y="2880360"/>
+            <a:ext cx="1463040" cy="365760"/>
           </a:xfrm>
           <a:prstGeom prst="rect">
             <a:avLst/>
@@ -10294,7 +9763,7 @@
           <a:p>
             <a:pPr algn="ctr"/>
             <a:r>
-              <a:rPr sz="2400" b="1" dirty="0" err="1">
+              <a:rPr sz="1200" b="1">
                 <a:solidFill>
                   <a:srgbClr val="BF5A24"/>
                 </a:solidFill>
@@ -10302,12 +9771,6 @@
               </a:rPr>
               <a:t>exécute</a:t>
             </a:r>
-            <a:endParaRPr sz="2400" b="1" dirty="0">
-              <a:solidFill>
-                <a:srgbClr val="BF5A24"/>
-              </a:solidFill>
-              <a:latin typeface="Aptos"/>
-            </a:endParaRPr>
           </a:p>
         </p:txBody>
       </p:sp>
@@ -10335,67 +9798,16 @@
           <a:p>
             <a:pPr algn="ctr"/>
             <a:r>
-              <a:rPr sz="1800" b="0" dirty="0">
+              <a:rPr sz="1800" b="0">
                 <a:solidFill>
                   <a:srgbClr val="5E656B"/>
                 </a:solidFill>
                 <a:latin typeface="Aptos"/>
               </a:rPr>
-              <a:t>CLI </a:t>
-            </a:r>
-            <a:r>
-              <a:rPr sz="1800" b="0" dirty="0" err="1">
-                <a:solidFill>
-                  <a:srgbClr val="5E656B"/>
-                </a:solidFill>
-                <a:latin typeface="Aptos"/>
-              </a:rPr>
-              <a:t>déterministe</a:t>
-            </a:r>
-            <a:r>
-              <a:rPr sz="1800" b="0" dirty="0">
-                <a:solidFill>
-                  <a:srgbClr val="5E656B"/>
-                </a:solidFill>
-                <a:latin typeface="Aptos"/>
-              </a:rPr>
-              <a:t>
-</a:t>
-            </a:r>
-            <a:r>
-              <a:rPr sz="1800" b="0" dirty="0" err="1">
-                <a:solidFill>
-                  <a:srgbClr val="5E656B"/>
-                </a:solidFill>
-                <a:latin typeface="Aptos"/>
-              </a:rPr>
-              <a:t>run_eval.py</a:t>
-            </a:r>
-            <a:r>
-              <a:rPr sz="1800" b="0" dirty="0">
-                <a:solidFill>
-                  <a:srgbClr val="5E656B"/>
-                </a:solidFill>
-                <a:latin typeface="Aptos"/>
-              </a:rPr>
-              <a:t>
-</a:t>
-            </a:r>
-            <a:r>
-              <a:rPr sz="1800" b="0" dirty="0" err="1">
-                <a:solidFill>
-                  <a:srgbClr val="5E656B"/>
-                </a:solidFill>
-                <a:latin typeface="Aptos"/>
-              </a:rPr>
-              <a:t>collect_metrics.py</a:t>
-            </a:r>
-            <a:endParaRPr sz="1800" b="0" dirty="0">
-              <a:solidFill>
-                <a:srgbClr val="5E656B"/>
-              </a:solidFill>
-              <a:latin typeface="Aptos"/>
-            </a:endParaRPr>
+              <a:t>CLI déterministe
+run_eval.py
+collect_metrics.py</a:t>
+            </a:r>
           </a:p>
         </p:txBody>
       </p:sp>
@@ -10441,7 +9853,6 @@
           <a:lstStyle/>
           <a:p>
             <a:pPr algn="ctr"/>
-            <a:endParaRPr/>
           </a:p>
         </p:txBody>
       </p:sp>
@@ -10488,8 +9899,8 @@
         </p:nvSpPr>
         <p:spPr>
           <a:xfrm>
-            <a:off x="5303520" y="2852927"/>
-            <a:ext cx="1463040" cy="482317"/>
+            <a:off x="5303520" y="2852928"/>
+            <a:ext cx="1463040" cy="365760"/>
           </a:xfrm>
           <a:prstGeom prst="roundRect">
             <a:avLst/>
@@ -10522,7 +9933,6 @@
           <a:lstStyle/>
           <a:p>
             <a:pPr algn="ctr"/>
-            <a:endParaRPr sz="3600"/>
           </a:p>
         </p:txBody>
       </p:sp>
@@ -10535,7 +9945,7 @@
         <p:spPr>
           <a:xfrm>
             <a:off x="5303520" y="2880360"/>
-            <a:ext cx="1463040" cy="461665"/>
+            <a:ext cx="1463040" cy="365760"/>
           </a:xfrm>
           <a:prstGeom prst="rect">
             <a:avLst/>
@@ -10550,7 +9960,7 @@
           <a:p>
             <a:pPr algn="ctr"/>
             <a:r>
-              <a:rPr sz="2400" b="1">
+              <a:rPr sz="1200" b="1">
                 <a:solidFill>
                   <a:srgbClr val="BF5A24"/>
                 </a:solidFill>
@@ -10640,7 +10050,6 @@
           <a:lstStyle/>
           <a:p>
             <a:pPr algn="ctr"/>
-            <a:endParaRPr/>
           </a:p>
         </p:txBody>
       </p:sp>
@@ -10687,8 +10096,8 @@
         </p:nvSpPr>
         <p:spPr>
           <a:xfrm>
-            <a:off x="8988552" y="2852927"/>
-            <a:ext cx="1463040" cy="482317"/>
+            <a:off x="8988552" y="2852928"/>
+            <a:ext cx="1463040" cy="365760"/>
           </a:xfrm>
           <a:prstGeom prst="roundRect">
             <a:avLst/>
@@ -10721,7 +10130,6 @@
           <a:lstStyle/>
           <a:p>
             <a:pPr algn="ctr"/>
-            <a:endParaRPr sz="3600"/>
           </a:p>
         </p:txBody>
       </p:sp>
@@ -10734,7 +10142,7 @@
         <p:spPr>
           <a:xfrm>
             <a:off x="8988552" y="2880360"/>
-            <a:ext cx="1463040" cy="461665"/>
+            <a:ext cx="1463040" cy="365760"/>
           </a:xfrm>
           <a:prstGeom prst="rect">
             <a:avLst/>
@@ -10749,7 +10157,7 @@
           <a:p>
             <a:pPr algn="ctr"/>
             <a:r>
-              <a:rPr sz="2400" b="1">
+              <a:rPr sz="1200" b="1">
                 <a:solidFill>
                   <a:srgbClr val="BF5A24"/>
                 </a:solidFill>
@@ -10806,7 +10214,7 @@
 </file>
 
 <file path=ppt/slides/slide7.xml><?xml version="1.0" encoding="utf-8"?>
-<p:sld xmlns:a="http://schemas.openxmlformats.org/drawingml/2006/main" xmlns:r="http://schemas.openxmlformats.org/officeDocument/2006/relationships" xmlns:p="http://schemas.openxmlformats.org/presentationml/2006/main">
+<p:sld xmlns:a="http://schemas.openxmlformats.org/drawingml/2006/main" xmlns:p="http://schemas.openxmlformats.org/presentationml/2006/main" xmlns:r="http://schemas.openxmlformats.org/officeDocument/2006/relationships">
   <p:cSld>
     <p:bg>
       <p:bgPr>
@@ -10822,14 +10230,7 @@
         <p:cNvGrpSpPr/>
         <p:nvPr/>
       </p:nvGrpSpPr>
-      <p:grpSpPr>
-        <a:xfrm>
-          <a:off x="0" y="0"/>
-          <a:ext cx="0" cy="0"/>
-          <a:chOff x="0" y="0"/>
-          <a:chExt cx="0" cy="0"/>
-        </a:xfrm>
-      </p:grpSpPr>
+      <p:grpSpPr/>
       <p:sp>
         <p:nvSpPr>
           <p:cNvPr id="2" name="TextBox 1"/>
@@ -10940,7 +10341,6 @@
           <a:lstStyle/>
           <a:p>
             <a:pPr algn="ctr"/>
-            <a:endParaRPr/>
           </a:p>
         </p:txBody>
       </p:sp>
@@ -10986,7 +10386,6 @@
           <a:lstStyle/>
           <a:p>
             <a:pPr algn="ctr"/>
-            <a:endParaRPr/>
           </a:p>
         </p:txBody>
       </p:sp>
@@ -11032,7 +10431,6 @@
           <a:lstStyle/>
           <a:p>
             <a:pPr algn="ctr"/>
-            <a:endParaRPr/>
           </a:p>
         </p:txBody>
       </p:sp>
@@ -11045,7 +10443,7 @@
         <p:spPr>
           <a:xfrm>
             <a:off x="1188720" y="2359152"/>
-            <a:ext cx="1554480" cy="338554"/>
+            <a:ext cx="1554480" cy="384048"/>
           </a:xfrm>
           <a:prstGeom prst="rect">
             <a:avLst/>
@@ -11060,7 +10458,7 @@
           <a:p>
             <a:pPr algn="ctr"/>
             <a:r>
-              <a:rPr sz="1600" b="1" dirty="0">
+              <a:rPr sz="1200" b="1">
                 <a:solidFill>
                   <a:srgbClr val="BF5A24"/>
                 </a:solidFill>
@@ -11149,7 +10547,6 @@
           <a:lstStyle/>
           <a:p>
             <a:pPr algn="ctr"/>
-            <a:endParaRPr/>
           </a:p>
         </p:txBody>
       </p:sp>
@@ -11162,7 +10559,7 @@
         <p:spPr>
           <a:xfrm>
             <a:off x="6931152" y="2331720"/>
-            <a:ext cx="2843468" cy="384048"/>
+            <a:ext cx="2148840" cy="384048"/>
           </a:xfrm>
           <a:prstGeom prst="roundRect">
             <a:avLst/>
@@ -11195,7 +10592,6 @@
           <a:lstStyle/>
           <a:p>
             <a:pPr algn="ctr"/>
-            <a:endParaRPr/>
           </a:p>
         </p:txBody>
       </p:sp>
@@ -11207,8 +10603,8 @@
         </p:nvSpPr>
         <p:spPr>
           <a:xfrm>
-            <a:off x="6931151" y="2359152"/>
-            <a:ext cx="2843469" cy="338554"/>
+            <a:off x="6931152" y="2359152"/>
+            <a:ext cx="2148840" cy="384048"/>
           </a:xfrm>
           <a:prstGeom prst="rect">
             <a:avLst/>
@@ -11223,7 +10619,7 @@
           <a:p>
             <a:pPr algn="ctr"/>
             <a:r>
-              <a:rPr sz="1600" b="1" dirty="0">
+              <a:rPr sz="1200" b="1">
                 <a:solidFill>
                   <a:srgbClr val="BF5A24"/>
                 </a:solidFill>
@@ -11314,7 +10710,7 @@
 </file>
 
 <file path=ppt/slides/slide8.xml><?xml version="1.0" encoding="utf-8"?>
-<p:sld xmlns:a="http://schemas.openxmlformats.org/drawingml/2006/main" xmlns:r="http://schemas.openxmlformats.org/officeDocument/2006/relationships" xmlns:p="http://schemas.openxmlformats.org/presentationml/2006/main">
+<p:sld xmlns:a="http://schemas.openxmlformats.org/drawingml/2006/main" xmlns:p="http://schemas.openxmlformats.org/presentationml/2006/main" xmlns:r="http://schemas.openxmlformats.org/officeDocument/2006/relationships">
   <p:cSld>
     <p:bg>
       <p:bgPr>
@@ -11330,14 +10726,7 @@
         <p:cNvGrpSpPr/>
         <p:nvPr/>
       </p:nvGrpSpPr>
-      <p:grpSpPr>
-        <a:xfrm>
-          <a:off x="0" y="0"/>
-          <a:ext cx="0" cy="0"/>
-          <a:chOff x="0" y="0"/>
-          <a:chExt cx="0" cy="0"/>
-        </a:xfrm>
-      </p:grpSpPr>
+      <p:grpSpPr/>
       <p:sp>
         <p:nvSpPr>
           <p:cNvPr id="2" name="TextBox 1"/>
@@ -11448,7 +10837,6 @@
           <a:lstStyle/>
           <a:p>
             <a:pPr algn="ctr"/>
-            <a:endParaRPr/>
           </a:p>
         </p:txBody>
       </p:sp>
@@ -11461,7 +10849,7 @@
         <p:spPr>
           <a:xfrm>
             <a:off x="841248" y="1920240"/>
-            <a:ext cx="4709160" cy="2761488"/>
+            <a:ext cx="4709160" cy="3063240"/>
           </a:xfrm>
           <a:prstGeom prst="roundRect">
             <a:avLst/>
@@ -11494,7 +10882,6 @@
           <a:lstStyle/>
           <a:p>
             <a:pPr algn="ctr"/>
-            <a:endParaRPr/>
           </a:p>
         </p:txBody>
       </p:sp>
@@ -11576,8 +10963,8 @@
         </p:nvSpPr>
         <p:spPr>
           <a:xfrm>
-            <a:off x="1161288" y="3182112"/>
-            <a:ext cx="3840480" cy="1005840"/>
+            <a:off x="1161288" y="3246120"/>
+            <a:ext cx="3840480" cy="1097280"/>
           </a:xfrm>
           <a:prstGeom prst="rect">
             <a:avLst/>
@@ -11614,7 +11001,7 @@
         <p:spPr>
           <a:xfrm>
             <a:off x="6172200" y="1920240"/>
-            <a:ext cx="4709160" cy="2761488"/>
+            <a:ext cx="4709160" cy="3063240"/>
           </a:xfrm>
           <a:prstGeom prst="roundRect">
             <a:avLst/>
@@ -11647,7 +11034,6 @@
           <a:lstStyle/>
           <a:p>
             <a:pPr algn="ctr"/>
-            <a:endParaRPr/>
           </a:p>
         </p:txBody>
       </p:sp>
@@ -11729,8 +11115,8 @@
         </p:nvSpPr>
         <p:spPr>
           <a:xfrm>
-            <a:off x="6492240" y="3182112"/>
-            <a:ext cx="3840480" cy="1005840"/>
+            <a:off x="6492240" y="3246120"/>
+            <a:ext cx="3840480" cy="1097280"/>
           </a:xfrm>
           <a:prstGeom prst="rect">
             <a:avLst/>
@@ -11766,8 +11152,8 @@
         </p:nvSpPr>
         <p:spPr>
           <a:xfrm>
-            <a:off x="868680" y="4992624"/>
-            <a:ext cx="10469880" cy="694944"/>
+            <a:off x="1828800" y="4892040"/>
+            <a:ext cx="8549640" cy="658368"/>
           </a:xfrm>
           <a:prstGeom prst="roundRect">
             <a:avLst/>
@@ -11800,7 +11186,6 @@
           <a:lstStyle/>
           <a:p>
             <a:pPr algn="ctr"/>
-            <a:endParaRPr/>
           </a:p>
         </p:txBody>
       </p:sp>
@@ -11812,8 +11197,8 @@
         </p:nvSpPr>
         <p:spPr>
           <a:xfrm>
-            <a:off x="1078992" y="5230368"/>
-            <a:ext cx="10058400" cy="219456"/>
+            <a:off x="2011680" y="5120640"/>
+            <a:ext cx="8183879" cy="219456"/>
           </a:xfrm>
           <a:prstGeom prst="rect">
             <a:avLst/>
@@ -11828,7 +11213,7 @@
           <a:p>
             <a:pPr algn="ctr"/>
             <a:r>
-              <a:rPr sz="1600" b="1">
+              <a:rPr sz="2000" b="1">
                 <a:solidFill>
                   <a:srgbClr val="215472"/>
                 </a:solidFill>
@@ -11848,7 +11233,7 @@
 </file>
 
 <file path=ppt/slides/slide9.xml><?xml version="1.0" encoding="utf-8"?>
-<p:sld xmlns:a="http://schemas.openxmlformats.org/drawingml/2006/main" xmlns:r="http://schemas.openxmlformats.org/officeDocument/2006/relationships" xmlns:p="http://schemas.openxmlformats.org/presentationml/2006/main">
+<p:sld xmlns:a="http://schemas.openxmlformats.org/drawingml/2006/main" xmlns:p="http://schemas.openxmlformats.org/presentationml/2006/main" xmlns:r="http://schemas.openxmlformats.org/officeDocument/2006/relationships">
   <p:cSld>
     <p:bg>
       <p:bgPr>
@@ -11864,14 +11249,7 @@
         <p:cNvGrpSpPr/>
         <p:nvPr/>
       </p:nvGrpSpPr>
-      <p:grpSpPr>
-        <a:xfrm>
-          <a:off x="0" y="0"/>
-          <a:ext cx="0" cy="0"/>
-          <a:chOff x="0" y="0"/>
-          <a:chExt cx="0" cy="0"/>
-        </a:xfrm>
-      </p:grpSpPr>
+      <p:grpSpPr/>
       <p:sp>
         <p:nvSpPr>
           <p:cNvPr id="2" name="TextBox 1"/>
@@ -11982,7 +11360,6 @@
           <a:lstStyle/>
           <a:p>
             <a:pPr algn="ctr"/>
-            <a:endParaRPr/>
           </a:p>
         </p:txBody>
       </p:sp>
@@ -12028,7 +11405,6 @@
           <a:lstStyle/>
           <a:p>
             <a:pPr algn="ctr"/>
-            <a:endParaRPr/>
           </a:p>
         </p:txBody>
       </p:sp>
@@ -12074,7 +11450,6 @@
           <a:lstStyle/>
           <a:p>
             <a:pPr algn="ctr"/>
-            <a:endParaRPr/>
           </a:p>
         </p:txBody>
       </p:sp>
@@ -12262,7 +11637,6 @@
           <a:lstStyle/>
           <a:p>
             <a:pPr algn="ctr"/>
-            <a:endParaRPr/>
           </a:p>
         </p:txBody>
       </p:sp>
@@ -12592,319 +11966,4 @@
   </a:objectDefaults>
   <a:extraClrSchemeLst/>
 </a:theme>
-</file>
-
-<file path=ppt/theme/theme2.xml><?xml version="1.0" encoding="utf-8"?>
-<a:theme xmlns:a="http://schemas.openxmlformats.org/drawingml/2006/main" name="Office Theme">
-  <a:themeElements>
-    <a:clrScheme name="Office">
-      <a:dk1>
-        <a:sysClr val="windowText" lastClr="000000"/>
-      </a:dk1>
-      <a:lt1>
-        <a:sysClr val="window" lastClr="FFFFFF"/>
-      </a:lt1>
-      <a:dk2>
-        <a:srgbClr val="0E2841"/>
-      </a:dk2>
-      <a:lt2>
-        <a:srgbClr val="E8E8E8"/>
-      </a:lt2>
-      <a:accent1>
-        <a:srgbClr val="156082"/>
-      </a:accent1>
-      <a:accent2>
-        <a:srgbClr val="E97132"/>
-      </a:accent2>
-      <a:accent3>
-        <a:srgbClr val="196B24"/>
-      </a:accent3>
-      <a:accent4>
-        <a:srgbClr val="0F9ED5"/>
-      </a:accent4>
-      <a:accent5>
-        <a:srgbClr val="A02B93"/>
-      </a:accent5>
-      <a:accent6>
-        <a:srgbClr val="4EA72E"/>
-      </a:accent6>
-      <a:hlink>
-        <a:srgbClr val="467886"/>
-      </a:hlink>
-      <a:folHlink>
-        <a:srgbClr val="96607D"/>
-      </a:folHlink>
-    </a:clrScheme>
-    <a:fontScheme name="Office">
-      <a:majorFont>
-        <a:latin typeface="Aptos Display" panose="02110004020202020204"/>
-        <a:ea typeface=""/>
-        <a:cs typeface=""/>
-        <a:font script="Jpan" typeface="游ゴシック Light"/>
-        <a:font script="Hang" typeface="맑은 고딕"/>
-        <a:font script="Hans" typeface="等线 Light"/>
-        <a:font script="Hant" typeface="新細明體"/>
-        <a:font script="Arab" typeface="Times New Roman"/>
-        <a:font script="Hebr" typeface="Times New Roman"/>
-        <a:font script="Thai" typeface="Angsana New"/>
-        <a:font script="Ethi" typeface="Nyala"/>
-        <a:font script="Beng" typeface="Vrinda"/>
-        <a:font script="Gujr" typeface="Shruti"/>
-        <a:font script="Khmr" typeface="MoolBoran"/>
-        <a:font script="Knda" typeface="Tunga"/>
-        <a:font script="Guru" typeface="Raavi"/>
-        <a:font script="Cans" typeface="Euphemia"/>
-        <a:font script="Cher" typeface="Plantagenet Cherokee"/>
-        <a:font script="Yiii" typeface="Microsoft Yi Baiti"/>
-        <a:font script="Tibt" typeface="Microsoft Himalaya"/>
-        <a:font script="Thaa" typeface="MV Boli"/>
-        <a:font script="Deva" typeface="Mangal"/>
-        <a:font script="Telu" typeface="Gautami"/>
-        <a:font script="Taml" typeface="Latha"/>
-        <a:font script="Syrc" typeface="Estrangelo Edessa"/>
-        <a:font script="Orya" typeface="Kalinga"/>
-        <a:font script="Mlym" typeface="Kartika"/>
-        <a:font script="Laoo" typeface="DokChampa"/>
-        <a:font script="Sinh" typeface="Iskoola Pota"/>
-        <a:font script="Mong" typeface="Mongolian Baiti"/>
-        <a:font script="Viet" typeface="Times New Roman"/>
-        <a:font script="Uigh" typeface="Microsoft Uighur"/>
-        <a:font script="Geor" typeface="Sylfaen"/>
-        <a:font script="Armn" typeface="Arial"/>
-        <a:font script="Bugi" typeface="Leelawadee UI"/>
-        <a:font script="Bopo" typeface="Microsoft JhengHei"/>
-        <a:font script="Java" typeface="Javanese Text"/>
-        <a:font script="Lisu" typeface="Segoe UI"/>
-        <a:font script="Mymr" typeface="Myanmar Text"/>
-        <a:font script="Nkoo" typeface="Ebrima"/>
-        <a:font script="Olck" typeface="Nirmala UI"/>
-        <a:font script="Osma" typeface="Ebrima"/>
-        <a:font script="Phag" typeface="Phagspa"/>
-        <a:font script="Syrn" typeface="Estrangelo Edessa"/>
-        <a:font script="Syrj" typeface="Estrangelo Edessa"/>
-        <a:font script="Syre" typeface="Estrangelo Edessa"/>
-        <a:font script="Sora" typeface="Nirmala UI"/>
-        <a:font script="Tale" typeface="Microsoft Tai Le"/>
-        <a:font script="Talu" typeface="Microsoft New Tai Lue"/>
-        <a:font script="Tfng" typeface="Ebrima"/>
-      </a:majorFont>
-      <a:minorFont>
-        <a:latin typeface="Aptos" panose="02110004020202020204"/>
-        <a:ea typeface=""/>
-        <a:cs typeface=""/>
-        <a:font script="Jpan" typeface="游ゴシック"/>
-        <a:font script="Hang" typeface="맑은 고딕"/>
-        <a:font script="Hans" typeface="等线"/>
-        <a:font script="Hant" typeface="新細明體"/>
-        <a:font script="Arab" typeface="Arial"/>
-        <a:font script="Hebr" typeface="Arial"/>
-        <a:font script="Thai" typeface="Cordia New"/>
-        <a:font script="Ethi" typeface="Nyala"/>
-        <a:font script="Beng" typeface="Vrinda"/>
-        <a:font script="Gujr" typeface="Shruti"/>
-        <a:font script="Khmr" typeface="DaunPenh"/>
-        <a:font script="Knda" typeface="Tunga"/>
-        <a:font script="Guru" typeface="Raavi"/>
-        <a:font script="Cans" typeface="Euphemia"/>
-        <a:font script="Cher" typeface="Plantagenet Cherokee"/>
-        <a:font script="Yiii" typeface="Microsoft Yi Baiti"/>
-        <a:font script="Tibt" typeface="Microsoft Himalaya"/>
-        <a:font script="Thaa" typeface="MV Boli"/>
-        <a:font script="Deva" typeface="Mangal"/>
-        <a:font script="Telu" typeface="Gautami"/>
-        <a:font script="Taml" typeface="Latha"/>
-        <a:font script="Syrc" typeface="Estrangelo Edessa"/>
-        <a:font script="Orya" typeface="Kalinga"/>
-        <a:font script="Mlym" typeface="Kartika"/>
-        <a:font script="Laoo" typeface="DokChampa"/>
-        <a:font script="Sinh" typeface="Iskoola Pota"/>
-        <a:font script="Mong" typeface="Mongolian Baiti"/>
-        <a:font script="Viet" typeface="Arial"/>
-        <a:font script="Uigh" typeface="Microsoft Uighur"/>
-        <a:font script="Geor" typeface="Sylfaen"/>
-        <a:font script="Armn" typeface="Arial"/>
-        <a:font script="Bugi" typeface="Leelawadee UI"/>
-        <a:font script="Bopo" typeface="Microsoft JhengHei"/>
-        <a:font script="Java" typeface="Javanese Text"/>
-        <a:font script="Lisu" typeface="Segoe UI"/>
-        <a:font script="Mymr" typeface="Myanmar Text"/>
-        <a:font script="Nkoo" typeface="Ebrima"/>
-        <a:font script="Olck" typeface="Nirmala UI"/>
-        <a:font script="Osma" typeface="Ebrima"/>
-        <a:font script="Phag" typeface="Phagspa"/>
-        <a:font script="Syrn" typeface="Estrangelo Edessa"/>
-        <a:font script="Syrj" typeface="Estrangelo Edessa"/>
-        <a:font script="Syre" typeface="Estrangelo Edessa"/>
-        <a:font script="Sora" typeface="Nirmala UI"/>
-        <a:font script="Tale" typeface="Microsoft Tai Le"/>
-        <a:font script="Talu" typeface="Microsoft New Tai Lue"/>
-        <a:font script="Tfng" typeface="Ebrima"/>
-      </a:minorFont>
-    </a:fontScheme>
-    <a:fmtScheme name="Office">
-      <a:fillStyleLst>
-        <a:solidFill>
-          <a:schemeClr val="phClr"/>
-        </a:solidFill>
-        <a:gradFill rotWithShape="1">
-          <a:gsLst>
-            <a:gs pos="0">
-              <a:schemeClr val="phClr">
-                <a:lumMod val="110000"/>
-                <a:satMod val="105000"/>
-                <a:tint val="67000"/>
-              </a:schemeClr>
-            </a:gs>
-            <a:gs pos="50000">
-              <a:schemeClr val="phClr">
-                <a:lumMod val="105000"/>
-                <a:satMod val="103000"/>
-                <a:tint val="73000"/>
-              </a:schemeClr>
-            </a:gs>
-            <a:gs pos="100000">
-              <a:schemeClr val="phClr">
-                <a:lumMod val="105000"/>
-                <a:satMod val="109000"/>
-                <a:tint val="81000"/>
-              </a:schemeClr>
-            </a:gs>
-          </a:gsLst>
-          <a:lin ang="5400000" scaled="0"/>
-        </a:gradFill>
-        <a:gradFill rotWithShape="1">
-          <a:gsLst>
-            <a:gs pos="0">
-              <a:schemeClr val="phClr">
-                <a:satMod val="103000"/>
-                <a:lumMod val="102000"/>
-                <a:tint val="94000"/>
-              </a:schemeClr>
-            </a:gs>
-            <a:gs pos="50000">
-              <a:schemeClr val="phClr">
-                <a:satMod val="110000"/>
-                <a:lumMod val="100000"/>
-                <a:shade val="100000"/>
-              </a:schemeClr>
-            </a:gs>
-            <a:gs pos="100000">
-              <a:schemeClr val="phClr">
-                <a:lumMod val="99000"/>
-                <a:satMod val="120000"/>
-                <a:shade val="78000"/>
-              </a:schemeClr>
-            </a:gs>
-          </a:gsLst>
-          <a:lin ang="5400000" scaled="0"/>
-        </a:gradFill>
-      </a:fillStyleLst>
-      <a:lnStyleLst>
-        <a:ln w="12700" cap="flat" cmpd="sng" algn="ctr">
-          <a:solidFill>
-            <a:schemeClr val="phClr"/>
-          </a:solidFill>
-          <a:prstDash val="solid"/>
-          <a:miter lim="800000"/>
-        </a:ln>
-        <a:ln w="19050" cap="flat" cmpd="sng" algn="ctr">
-          <a:solidFill>
-            <a:schemeClr val="phClr"/>
-          </a:solidFill>
-          <a:prstDash val="solid"/>
-          <a:miter lim="800000"/>
-        </a:ln>
-        <a:ln w="25400" cap="flat" cmpd="sng" algn="ctr">
-          <a:solidFill>
-            <a:schemeClr val="phClr"/>
-          </a:solidFill>
-          <a:prstDash val="solid"/>
-          <a:miter lim="800000"/>
-        </a:ln>
-      </a:lnStyleLst>
-      <a:effectStyleLst>
-        <a:effectStyle>
-          <a:effectLst/>
-        </a:effectStyle>
-        <a:effectStyle>
-          <a:effectLst/>
-        </a:effectStyle>
-        <a:effectStyle>
-          <a:effectLst>
-            <a:outerShdw blurRad="57150" dist="19050" dir="5400000" algn="ctr" rotWithShape="0">
-              <a:srgbClr val="000000">
-                <a:alpha val="63000"/>
-              </a:srgbClr>
-            </a:outerShdw>
-          </a:effectLst>
-        </a:effectStyle>
-      </a:effectStyleLst>
-      <a:bgFillStyleLst>
-        <a:solidFill>
-          <a:schemeClr val="phClr"/>
-        </a:solidFill>
-        <a:solidFill>
-          <a:schemeClr val="phClr">
-            <a:tint val="95000"/>
-            <a:satMod val="170000"/>
-          </a:schemeClr>
-        </a:solidFill>
-        <a:gradFill rotWithShape="1">
-          <a:gsLst>
-            <a:gs pos="0">
-              <a:schemeClr val="phClr">
-                <a:tint val="93000"/>
-                <a:satMod val="150000"/>
-                <a:shade val="98000"/>
-                <a:lumMod val="102000"/>
-              </a:schemeClr>
-            </a:gs>
-            <a:gs pos="50000">
-              <a:schemeClr val="phClr">
-                <a:tint val="98000"/>
-                <a:satMod val="130000"/>
-                <a:shade val="90000"/>
-                <a:lumMod val="103000"/>
-              </a:schemeClr>
-            </a:gs>
-            <a:gs pos="100000">
-              <a:schemeClr val="phClr">
-                <a:shade val="63000"/>
-                <a:satMod val="120000"/>
-              </a:schemeClr>
-            </a:gs>
-          </a:gsLst>
-          <a:lin ang="5400000" scaled="0"/>
-        </a:gradFill>
-      </a:bgFillStyleLst>
-    </a:fmtScheme>
-  </a:themeElements>
-  <a:objectDefaults>
-    <a:lnDef>
-      <a:spPr/>
-      <a:bodyPr/>
-      <a:lstStyle/>
-      <a:style>
-        <a:lnRef idx="2">
-          <a:schemeClr val="accent1"/>
-        </a:lnRef>
-        <a:fillRef idx="0">
-          <a:schemeClr val="accent1"/>
-        </a:fillRef>
-        <a:effectRef idx="1">
-          <a:schemeClr val="accent1"/>
-        </a:effectRef>
-        <a:fontRef idx="minor">
-          <a:schemeClr val="tx1"/>
-        </a:fontRef>
-      </a:style>
-    </a:lnDef>
-  </a:objectDefaults>
-  <a:extraClrSchemeLst/>
-  <a:extLst>
-    <a:ext uri="{05A4C25C-085E-4340-85A3-A5531E510DB2}">
-      <thm15:themeFamily xmlns:thm15="http://schemas.microsoft.com/office/thememl/2012/main" name="Office Theme" id="{2E142A2C-CD16-42D6-873A-C26D2A0506FA}" vid="{1BDDFF52-6CD6-40A5-AB3C-68EB2F1E4D0A}"/>
-    </a:ext>
-  </a:extLst>
-</a:theme>
 </file>
</xml_diff>